<commit_message>
Refresh submission deck and demo materials with participant narration
</commit_message>
<xml_diff>
--- a/submission/Clorex_WasteRecast_Pitch_Deck.pptx
+++ b/submission/Clorex_WasteRecast_Pitch_Deck.pptx
@@ -2,46 +2,46 @@
 <file path=ppt/presentation.xml><?xml version="1.0" encoding="utf-8"?>
 <p:presentation xmlns:p="http://schemas.openxmlformats.org/presentationml/2006/main" embedTrueTypeFonts="1" saveSubsetFonts="0">
   <p:sldMasterIdLst>
-    <p:sldMasterId xmlns:r="http://schemas.openxmlformats.org/officeDocument/2006/relationships" id="2147483648" r:id="Rb8ddc481c42e456a"/>
+    <p:sldMasterId xmlns:r="http://schemas.openxmlformats.org/officeDocument/2006/relationships" id="2147483648" r:id="R14c4077138d145a8"/>
   </p:sldMasterIdLst>
   <p:notesMasterIdLst>
-    <p:notesMasterId xmlns:r="http://schemas.openxmlformats.org/officeDocument/2006/relationships" r:id="R9a0458b6d81a4be9"/>
+    <p:notesMasterId xmlns:r="http://schemas.openxmlformats.org/officeDocument/2006/relationships" r:id="Re61c2e09983d4d9e"/>
   </p:notesMasterIdLst>
   <p:sldIdLst>
-    <p:sldId xmlns:r="http://schemas.openxmlformats.org/officeDocument/2006/relationships" id="256" r:id="R022478e5463a4ea4"/>
-    <p:sldId xmlns:r="http://schemas.openxmlformats.org/officeDocument/2006/relationships" id="257" r:id="R3e357c9fb31f482d"/>
-    <p:sldId xmlns:r="http://schemas.openxmlformats.org/officeDocument/2006/relationships" id="258" r:id="R8615fd4155f9442a"/>
-    <p:sldId xmlns:r="http://schemas.openxmlformats.org/officeDocument/2006/relationships" id="259" r:id="R40759cc1596f458a"/>
-    <p:sldId xmlns:r="http://schemas.openxmlformats.org/officeDocument/2006/relationships" id="260" r:id="R97dc9b48bef6471b"/>
-    <p:sldId xmlns:r="http://schemas.openxmlformats.org/officeDocument/2006/relationships" id="261" r:id="Rf67d3e1a1ac94049"/>
-    <p:sldId xmlns:r="http://schemas.openxmlformats.org/officeDocument/2006/relationships" id="262" r:id="R386d64c1bd624d52"/>
-    <p:sldId xmlns:r="http://schemas.openxmlformats.org/officeDocument/2006/relationships" id="263" r:id="Rdeaa978f7ea34938"/>
-    <p:sldId xmlns:r="http://schemas.openxmlformats.org/officeDocument/2006/relationships" id="264" r:id="R474e691b6e17400a"/>
-    <p:sldId xmlns:r="http://schemas.openxmlformats.org/officeDocument/2006/relationships" id="265" r:id="R21ae456edfae4510"/>
-    <p:sldId xmlns:r="http://schemas.openxmlformats.org/officeDocument/2006/relationships" id="266" r:id="R55235c61992a4a58"/>
-    <p:sldId xmlns:r="http://schemas.openxmlformats.org/officeDocument/2006/relationships" id="267" r:id="R63b39ae7a6d7438b"/>
-    <p:sldId xmlns:r="http://schemas.openxmlformats.org/officeDocument/2006/relationships" id="268" r:id="R4bfe9cf06cb3415e"/>
-    <p:sldId xmlns:r="http://schemas.openxmlformats.org/officeDocument/2006/relationships" id="269" r:id="Rc9436b4a46f44389"/>
-    <p:sldId xmlns:r="http://schemas.openxmlformats.org/officeDocument/2006/relationships" id="270" r:id="R63c03a2aaa7d4dae"/>
-    <p:sldId xmlns:r="http://schemas.openxmlformats.org/officeDocument/2006/relationships" id="271" r:id="R063fadd3263a4cd6"/>
+    <p:sldId xmlns:r="http://schemas.openxmlformats.org/officeDocument/2006/relationships" id="256" r:id="R2168346705ea40c7"/>
+    <p:sldId xmlns:r="http://schemas.openxmlformats.org/officeDocument/2006/relationships" id="257" r:id="Rf5d8214877634b16"/>
+    <p:sldId xmlns:r="http://schemas.openxmlformats.org/officeDocument/2006/relationships" id="258" r:id="R11ec0c1fe3da496b"/>
+    <p:sldId xmlns:r="http://schemas.openxmlformats.org/officeDocument/2006/relationships" id="259" r:id="Rc4dc6aef24ac4d8b"/>
+    <p:sldId xmlns:r="http://schemas.openxmlformats.org/officeDocument/2006/relationships" id="260" r:id="Rf5ddd2089c8a4ec1"/>
+    <p:sldId xmlns:r="http://schemas.openxmlformats.org/officeDocument/2006/relationships" id="261" r:id="R353cea2c293b4e23"/>
+    <p:sldId xmlns:r="http://schemas.openxmlformats.org/officeDocument/2006/relationships" id="262" r:id="Rab9647c136d449bb"/>
+    <p:sldId xmlns:r="http://schemas.openxmlformats.org/officeDocument/2006/relationships" id="263" r:id="R1650d3d1ae804455"/>
+    <p:sldId xmlns:r="http://schemas.openxmlformats.org/officeDocument/2006/relationships" id="264" r:id="R8db2169b8eda4344"/>
+    <p:sldId xmlns:r="http://schemas.openxmlformats.org/officeDocument/2006/relationships" id="265" r:id="Rf3212690214142ca"/>
+    <p:sldId xmlns:r="http://schemas.openxmlformats.org/officeDocument/2006/relationships" id="266" r:id="Rc5fe2b1670894da7"/>
+    <p:sldId xmlns:r="http://schemas.openxmlformats.org/officeDocument/2006/relationships" id="267" r:id="R9b0a902bbaac438e"/>
+    <p:sldId xmlns:r="http://schemas.openxmlformats.org/officeDocument/2006/relationships" id="268" r:id="Rc63e83fa652d4fb0"/>
+    <p:sldId xmlns:r="http://schemas.openxmlformats.org/officeDocument/2006/relationships" id="269" r:id="Ra5868ba8d29747c1"/>
+    <p:sldId xmlns:r="http://schemas.openxmlformats.org/officeDocument/2006/relationships" id="270" r:id="R0191829b9823424b"/>
+    <p:sldId xmlns:r="http://schemas.openxmlformats.org/officeDocument/2006/relationships" id="271" r:id="R3e4f57321c124f55"/>
   </p:sldIdLst>
   <p:sldSz cx="9144000" cy="5143500"/>
   <p:notesSz cx="6858000" cy="9144000"/>
   <p:embeddedFontLst>
     <p:embeddedFont>
       <p:font typeface="Google Sans Flex Medium"/>
-      <p:regular xmlns:r="http://schemas.openxmlformats.org/officeDocument/2006/relationships" r:id="R6cedbd006fee4a39"/>
-      <p:bold xmlns:r="http://schemas.openxmlformats.org/officeDocument/2006/relationships" r:id="Re129ea9a5ea14ce0"/>
+      <p:regular xmlns:r="http://schemas.openxmlformats.org/officeDocument/2006/relationships" r:id="R9d88be5f73b849c5"/>
+      <p:bold xmlns:r="http://schemas.openxmlformats.org/officeDocument/2006/relationships" r:id="Rf6dddf64c00b4304"/>
     </p:embeddedFont>
     <p:embeddedFont>
       <p:font typeface="Google Sans Flex"/>
-      <p:regular xmlns:r="http://schemas.openxmlformats.org/officeDocument/2006/relationships" r:id="R332ba64cb07e40e9"/>
-      <p:bold xmlns:r="http://schemas.openxmlformats.org/officeDocument/2006/relationships" r:id="Re9143949ff9f4099"/>
+      <p:regular xmlns:r="http://schemas.openxmlformats.org/officeDocument/2006/relationships" r:id="Rc93539f66143443c"/>
+      <p:bold xmlns:r="http://schemas.openxmlformats.org/officeDocument/2006/relationships" r:id="R52a9dfd8ea94449d"/>
     </p:embeddedFont>
     <p:embeddedFont>
       <p:font typeface="Google Sans Flex SemiBold"/>
-      <p:regular xmlns:r="http://schemas.openxmlformats.org/officeDocument/2006/relationships" r:id="Rc43557c7c4b94bb9"/>
-      <p:bold xmlns:r="http://schemas.openxmlformats.org/officeDocument/2006/relationships" r:id="R1a1ec06882d04c63"/>
+      <p:regular xmlns:r="http://schemas.openxmlformats.org/officeDocument/2006/relationships" r:id="R64ded50a298e45e4"/>
+      <p:bold xmlns:r="http://schemas.openxmlformats.org/officeDocument/2006/relationships" r:id="Ref29ca0591024a38"/>
     </p:embeddedFont>
   </p:embeddedFontLst>
   <p:defaultTextStyle>
@@ -736,7 +736,7 @@
               <a:buNone/>
             </a:pPr>
             <a:r>
-              <a:t>Evidence: https://aibuildercup.com/ ; https://aibuildercup.com/themes.html ; https://github.com/anshuman542018/wasterecast (commit 253e0b0). Live prototype: https://wasterecast.web.app/ . Test date: 17 October 2026. Team and eligibility supplied by participants. Claims describe a prototype, not independently certified performance.</a:t>
+              <a:t>Evidence: https://aibuildercup.com/ ; https://aibuildercup.com/themes.html ; https://github.com/anshuman542018/wasterecast (commit 00ad41d). Live prototype: https://wasterecast.web.app/ . Test date: 18 October 2026. Team and eligibility supplied by participants. Claims describe a prototype, not independently certified performance.</a:t>
             </a:r>
             <a:endParaRPr/>
           </a:p>
@@ -816,7 +816,7 @@
               <a:buNone/>
             </a:pPr>
             <a:r>
-              <a:t>Evidence: https://aibuildercup.com/ ; https://aibuildercup.com/themes.html ; https://github.com/anshuman542018/wasterecast (commit 253e0b0). Live prototype: https://wasterecast.web.app/ . Test date: 17 October 2026. Team and eligibility supplied by participants. Claims describe a prototype, not independently certified performance.</a:t>
+              <a:t>Evidence: https://aibuildercup.com/ ; https://aibuildercup.com/themes.html ; https://github.com/anshuman542018/wasterecast (commit 00ad41d). Live prototype: https://wasterecast.web.app/ . Test date: 18 October 2026. Team and eligibility supplied by participants. Claims describe a prototype, not independently certified performance.</a:t>
             </a:r>
             <a:endParaRPr/>
           </a:p>
@@ -896,7 +896,7 @@
               <a:buNone/>
             </a:pPr>
             <a:r>
-              <a:t>Evidence: https://aibuildercup.com/ ; https://aibuildercup.com/themes.html ; https://github.com/anshuman542018/wasterecast (commit 253e0b0). Live prototype: https://wasterecast.web.app/ . Test date: 17 October 2026. Team and eligibility supplied by participants. Claims describe a prototype, not independently certified performance.</a:t>
+              <a:t>Evidence: https://aibuildercup.com/ ; https://aibuildercup.com/themes.html ; https://github.com/anshuman542018/wasterecast (commit 00ad41d). Live prototype: https://wasterecast.web.app/ . Test date: 18 October 2026. Team and eligibility supplied by participants. Claims describe a prototype, not independently certified performance.</a:t>
             </a:r>
             <a:endParaRPr/>
           </a:p>
@@ -991,7 +991,7 @@
               <a:buNone/>
             </a:pPr>
             <a:r>
-              <a:t>Evidence: https://aibuildercup.com/ ; https://aibuildercup.com/themes.html ; https://github.com/anshuman542018/wasterecast (commit 253e0b0). Live prototype: https://wasterecast.web.app/ . Test date: 17 October 2026. Team and eligibility supplied by participants. Claims describe a prototype, not independently certified performance.</a:t>
+              <a:t>Evidence: https://aibuildercup.com/ ; https://aibuildercup.com/themes.html ; https://github.com/anshuman542018/wasterecast (commit 00ad41d). Live prototype: https://wasterecast.web.app/ . Test date: 18 October 2026. Team and eligibility supplied by participants. Claims describe a prototype, not independently certified performance.</a:t>
             </a:r>
             <a:endParaRPr/>
           </a:p>
@@ -1071,7 +1071,7 @@
               <a:buNone/>
             </a:pPr>
             <a:r>
-              <a:t>Evidence: https://aibuildercup.com/ ; https://aibuildercup.com/themes.html ; https://github.com/anshuman542018/wasterecast (commit 253e0b0). Live prototype: https://wasterecast.web.app/ . Test date: 17 October 2026. Team and eligibility supplied by participants. Claims describe a prototype, not independently certified performance.</a:t>
+              <a:t>Evidence: https://aibuildercup.com/ ; https://aibuildercup.com/themes.html ; https://github.com/anshuman542018/wasterecast (commit 00ad41d). Live prototype: https://wasterecast.web.app/ . Test date: 18 October 2026. Team and eligibility supplied by participants. Claims describe a prototype, not independently certified performance.</a:t>
             </a:r>
             <a:endParaRPr/>
           </a:p>
@@ -1151,7 +1151,7 @@
               <a:buNone/>
             </a:pPr>
             <a:r>
-              <a:t>Evidence: https://aibuildercup.com/ ; https://aibuildercup.com/themes.html ; https://github.com/anshuman542018/wasterecast (commit 253e0b0). Live prototype: https://wasterecast.web.app/ . Test date: 17 October 2026. Team and eligibility supplied by participants. Claims describe a prototype, not independently certified performance.</a:t>
+              <a:t>Evidence: https://aibuildercup.com/ ; https://aibuildercup.com/themes.html ; https://github.com/anshuman542018/wasterecast (commit 00ad41d). Live prototype: https://wasterecast.web.app/ . Test date: 18 October 2026. Team and eligibility supplied by participants. Claims describe a prototype, not independently certified performance.</a:t>
             </a:r>
             <a:endParaRPr/>
           </a:p>
@@ -1231,7 +1231,7 @@
               <a:buNone/>
             </a:pPr>
             <a:r>
-              <a:t>Evidence: https://aibuildercup.com/ ; https://aibuildercup.com/themes.html ; https://github.com/anshuman542018/wasterecast (commit 253e0b0). Live prototype: https://wasterecast.web.app/ . Test date: 17 October 2026. Team and eligibility supplied by participants. Claims describe a prototype, not independently certified performance.</a:t>
+              <a:t>Evidence: https://aibuildercup.com/ ; https://aibuildercup.com/themes.html ; https://github.com/anshuman542018/wasterecast (commit 00ad41d). Live prototype: https://wasterecast.web.app/ . Test date: 18 October 2026. Team and eligibility supplied by participants. Claims describe a prototype, not independently certified performance.</a:t>
             </a:r>
             <a:endParaRPr/>
           </a:p>
@@ -1326,7 +1326,7 @@
               <a:buNone/>
             </a:pPr>
             <a:r>
-              <a:t>Evidence: https://aibuildercup.com/ ; https://aibuildercup.com/themes.html ; https://github.com/anshuman542018/wasterecast (commit 253e0b0). Live prototype: https://wasterecast.web.app/ . Test date: 17 October 2026. Team and eligibility supplied by participants. Claims describe a prototype, not independently certified performance.</a:t>
+              <a:t>Evidence: https://aibuildercup.com/ ; https://aibuildercup.com/themes.html ; https://github.com/anshuman542018/wasterecast (commit 00ad41d). Live prototype: https://wasterecast.web.app/ . Test date: 18 October 2026. Team and eligibility supplied by participants. Claims describe a prototype, not independently certified performance.</a:t>
             </a:r>
             <a:endParaRPr/>
           </a:p>
@@ -1406,7 +1406,7 @@
               <a:buNone/>
             </a:pPr>
             <a:r>
-              <a:t>Evidence: https://aibuildercup.com/ ; https://aibuildercup.com/themes.html ; https://github.com/anshuman542018/wasterecast (commit 253e0b0). Live prototype: https://wasterecast.web.app/ . Test date: 17 October 2026. Team and eligibility supplied by participants. Claims describe a prototype, not independently certified performance.</a:t>
+              <a:t>Evidence: https://aibuildercup.com/ ; https://aibuildercup.com/themes.html ; https://github.com/anshuman542018/wasterecast (commit 00ad41d). Live prototype: https://wasterecast.web.app/ . Test date: 18 October 2026. Team and eligibility supplied by participants. Claims describe a prototype, not independently certified performance.</a:t>
             </a:r>
             <a:endParaRPr/>
           </a:p>
@@ -1486,7 +1486,7 @@
               <a:buNone/>
             </a:pPr>
             <a:r>
-              <a:t>Evidence: https://aibuildercup.com/ ; https://aibuildercup.com/themes.html ; https://github.com/anshuman542018/wasterecast (commit 253e0b0). Live prototype: https://wasterecast.web.app/ . Test date: 17 October 2026. Team and eligibility supplied by participants. Claims describe a prototype, not independently certified performance.</a:t>
+              <a:t>Evidence: https://aibuildercup.com/ ; https://aibuildercup.com/themes.html ; https://github.com/anshuman542018/wasterecast (commit 00ad41d). Live prototype: https://wasterecast.web.app/ . Test date: 18 October 2026. Team and eligibility supplied by participants. Claims describe a prototype, not independently certified performance.</a:t>
             </a:r>
             <a:endParaRPr/>
           </a:p>
@@ -1566,7 +1566,7 @@
               <a:buNone/>
             </a:pPr>
             <a:r>
-              <a:t>Evidence: https://aibuildercup.com/ ; https://aibuildercup.com/themes.html ; https://github.com/anshuman542018/wasterecast (commit 253e0b0). Live prototype: https://wasterecast.web.app/ . Test date: 17 October 2026. Team and eligibility supplied by participants. Claims describe a prototype, not independently certified performance.</a:t>
+              <a:t>Evidence: https://aibuildercup.com/ ; https://aibuildercup.com/themes.html ; https://github.com/anshuman542018/wasterecast (commit 00ad41d). Live prototype: https://wasterecast.web.app/ . Test date: 18 October 2026. Team and eligibility supplied by participants. Claims describe a prototype, not independently certified performance.</a:t>
             </a:r>
             <a:endParaRPr/>
           </a:p>
@@ -1661,7 +1661,7 @@
               <a:buNone/>
             </a:pPr>
             <a:r>
-              <a:t>Evidence: https://aibuildercup.com/ ; https://aibuildercup.com/themes.html ; https://github.com/anshuman542018/wasterecast (commit 253e0b0). Live prototype: https://wasterecast.web.app/ . Test date: 17 October 2026. Team and eligibility supplied by participants. Claims describe a prototype, not independently certified performance.</a:t>
+              <a:t>Evidence: https://aibuildercup.com/ ; https://aibuildercup.com/themes.html ; https://github.com/anshuman542018/wasterecast (commit 00ad41d). Live prototype: https://wasterecast.web.app/ . Test date: 18 October 2026. Team and eligibility supplied by participants. Claims describe a prototype, not independently certified performance.</a:t>
             </a:r>
             <a:endParaRPr/>
           </a:p>
@@ -1756,7 +1756,7 @@
               <a:buNone/>
             </a:pPr>
             <a:r>
-              <a:t>Evidence: https://aibuildercup.com/ ; https://aibuildercup.com/themes.html ; https://github.com/anshuman542018/wasterecast (commit 253e0b0). Live prototype: https://wasterecast.web.app/ . Test date: 17 October 2026. Team and eligibility supplied by participants. Claims describe a prototype, not independently certified performance.</a:t>
+              <a:t>Evidence: https://aibuildercup.com/ ; https://aibuildercup.com/themes.html ; https://github.com/anshuman542018/wasterecast (commit 00ad41d). Live prototype: https://wasterecast.web.app/ . Test date: 18 October 2026. Team and eligibility supplied by participants. Claims describe a prototype, not independently certified performance.</a:t>
             </a:r>
             <a:endParaRPr/>
           </a:p>
@@ -1836,7 +1836,7 @@
               <a:buNone/>
             </a:pPr>
             <a:r>
-              <a:t>Evidence: https://aibuildercup.com/ ; https://aibuildercup.com/themes.html ; https://github.com/anshuman542018/wasterecast (commit 253e0b0). Live prototype: https://wasterecast.web.app/ . Test date: 17 October 2026. Team and eligibility supplied by participants. Claims describe a prototype, not independently certified performance.</a:t>
+              <a:t>Evidence: https://aibuildercup.com/ ; https://aibuildercup.com/themes.html ; https://github.com/anshuman542018/wasterecast (commit 00ad41d). Live prototype: https://wasterecast.web.app/ . Test date: 18 October 2026. Team and eligibility supplied by participants. Claims describe a prototype, not independently certified performance.</a:t>
             </a:r>
             <a:endParaRPr/>
           </a:p>
@@ -1916,7 +1916,7 @@
               <a:buNone/>
             </a:pPr>
             <a:r>
-              <a:t>Evidence: https://aibuildercup.com/ ; https://aibuildercup.com/themes.html ; https://github.com/anshuman542018/wasterecast (commit 253e0b0). Live prototype: https://wasterecast.web.app/ . Test date: 17 October 2026. Team and eligibility supplied by participants. Claims describe a prototype, not independently certified performance.</a:t>
+              <a:t>Evidence: https://aibuildercup.com/ ; https://aibuildercup.com/themes.html ; https://github.com/anshuman542018/wasterecast (commit 00ad41d). Live prototype: https://wasterecast.web.app/ . Test date: 18 October 2026. Team and eligibility supplied by participants. Claims describe a prototype, not independently certified performance.</a:t>
             </a:r>
             <a:endParaRPr/>
           </a:p>
@@ -2011,7 +2011,7 @@
               <a:buNone/>
             </a:pPr>
             <a:r>
-              <a:t>Evidence: https://aibuildercup.com/ ; https://aibuildercup.com/themes.html ; https://github.com/anshuman542018/wasterecast (commit 253e0b0). Live prototype: https://wasterecast.web.app/ . Test date: 17 October 2026. Team and eligibility supplied by participants. Claims describe a prototype, not independently certified performance.</a:t>
+              <a:t>Evidence: https://aibuildercup.com/ ; https://aibuildercup.com/themes.html ; https://github.com/anshuman542018/wasterecast (commit 00ad41d). Live prototype: https://wasterecast.web.app/ . Test date: 18 October 2026. Team and eligibility supplied by participants. Claims describe a prototype, not independently certified performance.</a:t>
             </a:r>
             <a:endParaRPr/>
           </a:p>
@@ -2074,7 +2074,7 @@
           <p:cNvPr id="10" name="Google Shape;10;p2">
             <a:extLst xmlns:a="http://schemas.openxmlformats.org/drawingml/2006/main">
               <a:ext uri="{FF2B5EF4-FFF2-40B4-BE49-F238E27FC236}">
-                <a16:creationId xmlns:a16="http://schemas.microsoft.com/office/drawing/2014/main" id="{8675B08E-0303-4E65-9C07-EF7EF2C2D0D7}"/>
+                <a16:creationId xmlns:a16="http://schemas.microsoft.com/office/drawing/2014/main" id="{D89157EB-C9F2-4D9F-9590-33373D7AB0C9}"/>
               </a:ext>
             </a:extLst>
           </p:cNvPr>
@@ -2207,7 +2207,7 @@
           <p:cNvPr id="11" name="Google Shape;11;p2">
             <a:extLst xmlns:a="http://schemas.openxmlformats.org/drawingml/2006/main">
               <a:ext uri="{FF2B5EF4-FFF2-40B4-BE49-F238E27FC236}">
-                <a16:creationId xmlns:a16="http://schemas.microsoft.com/office/drawing/2014/main" id="{B645626F-B235-4289-8970-0A750357DB45}"/>
+                <a16:creationId xmlns:a16="http://schemas.microsoft.com/office/drawing/2014/main" id="{48534C00-3CA3-47C8-8BC9-B27F2FFFB52A}"/>
               </a:ext>
             </a:extLst>
           </p:cNvPr>
@@ -2367,7 +2367,7 @@
           <p:cNvPr id="12" name="Google Shape;12;p2">
             <a:extLst xmlns:a="http://schemas.openxmlformats.org/drawingml/2006/main">
               <a:ext uri="{FF2B5EF4-FFF2-40B4-BE49-F238E27FC236}">
-                <a16:creationId xmlns:a16="http://schemas.microsoft.com/office/drawing/2014/main" id="{D75AB743-A938-460C-BA1C-1ADA6F20153F}"/>
+                <a16:creationId xmlns:a16="http://schemas.microsoft.com/office/drawing/2014/main" id="{A3461E5B-E00A-4A0F-902C-310FBF7CF127}"/>
               </a:ext>
             </a:extLst>
           </p:cNvPr>
@@ -2468,7 +2468,7 @@
           <p:cNvPr id="45" name="Google Shape;45;p11">
             <a:extLst xmlns:a="http://schemas.openxmlformats.org/drawingml/2006/main">
               <a:ext uri="{FF2B5EF4-FFF2-40B4-BE49-F238E27FC236}">
-                <a16:creationId xmlns:a16="http://schemas.microsoft.com/office/drawing/2014/main" id="{333EC66F-1CCE-4304-864A-D7E57F849097}"/>
+                <a16:creationId xmlns:a16="http://schemas.microsoft.com/office/drawing/2014/main" id="{06B2CF5B-CD6A-4907-BF88-C0BC98535407}"/>
               </a:ext>
             </a:extLst>
           </p:cNvPr>
@@ -2605,7 +2605,7 @@
           <p:cNvPr id="46" name="Google Shape;46;p11">
             <a:extLst xmlns:a="http://schemas.openxmlformats.org/drawingml/2006/main">
               <a:ext uri="{FF2B5EF4-FFF2-40B4-BE49-F238E27FC236}">
-                <a16:creationId xmlns:a16="http://schemas.microsoft.com/office/drawing/2014/main" id="{263684FF-8AF9-4B3E-A500-3EE3633332FB}"/>
+                <a16:creationId xmlns:a16="http://schemas.microsoft.com/office/drawing/2014/main" id="{6D6AA754-7875-4FE8-8D7C-955D4026C709}"/>
               </a:ext>
             </a:extLst>
           </p:cNvPr>
@@ -2738,7 +2738,7 @@
           <p:cNvPr id="47" name="Google Shape;47;p11">
             <a:extLst xmlns:a="http://schemas.openxmlformats.org/drawingml/2006/main">
               <a:ext uri="{FF2B5EF4-FFF2-40B4-BE49-F238E27FC236}">
-                <a16:creationId xmlns:a16="http://schemas.microsoft.com/office/drawing/2014/main" id="{169752EF-BDF9-40C2-9049-26C1DB9C24DF}"/>
+                <a16:creationId xmlns:a16="http://schemas.microsoft.com/office/drawing/2014/main" id="{C55FCD4F-75EA-4A52-AC11-AE901E60FE15}"/>
               </a:ext>
             </a:extLst>
           </p:cNvPr>
@@ -2839,7 +2839,7 @@
           <p:cNvPr id="49" name="Google Shape;49;p12">
             <a:extLst xmlns:a="http://schemas.openxmlformats.org/drawingml/2006/main">
               <a:ext uri="{FF2B5EF4-FFF2-40B4-BE49-F238E27FC236}">
-                <a16:creationId xmlns:a16="http://schemas.microsoft.com/office/drawing/2014/main" id="{C869F42B-9A5B-47E5-A832-58ECA24689CA}"/>
+                <a16:creationId xmlns:a16="http://schemas.microsoft.com/office/drawing/2014/main" id="{19882645-0700-4F3E-BF0D-A5FEC8B69973}"/>
               </a:ext>
             </a:extLst>
           </p:cNvPr>
@@ -2940,7 +2940,7 @@
           <p:cNvPr id="14" name="Google Shape;14;p3">
             <a:extLst xmlns:a="http://schemas.openxmlformats.org/drawingml/2006/main">
               <a:ext uri="{FF2B5EF4-FFF2-40B4-BE49-F238E27FC236}">
-                <a16:creationId xmlns:a16="http://schemas.microsoft.com/office/drawing/2014/main" id="{95C1C462-9B71-401F-8389-744BF2A9EAB9}"/>
+                <a16:creationId xmlns:a16="http://schemas.microsoft.com/office/drawing/2014/main" id="{DA8D5921-B8AE-47A6-804C-CDCF0451AED7}"/>
               </a:ext>
             </a:extLst>
           </p:cNvPr>
@@ -3073,7 +3073,7 @@
           <p:cNvPr id="15" name="Google Shape;15;p3">
             <a:extLst xmlns:a="http://schemas.openxmlformats.org/drawingml/2006/main">
               <a:ext uri="{FF2B5EF4-FFF2-40B4-BE49-F238E27FC236}">
-                <a16:creationId xmlns:a16="http://schemas.microsoft.com/office/drawing/2014/main" id="{5BDF4CEA-AAAF-42B0-9F75-862FA7476399}"/>
+                <a16:creationId xmlns:a16="http://schemas.microsoft.com/office/drawing/2014/main" id="{557AB7A5-720F-4CF9-AAAA-E2B47833FA65}"/>
               </a:ext>
             </a:extLst>
           </p:cNvPr>
@@ -3174,7 +3174,7 @@
           <p:cNvPr id="17" name="Google Shape;17;p4">
             <a:extLst xmlns:a="http://schemas.openxmlformats.org/drawingml/2006/main">
               <a:ext uri="{FF2B5EF4-FFF2-40B4-BE49-F238E27FC236}">
-                <a16:creationId xmlns:a16="http://schemas.microsoft.com/office/drawing/2014/main" id="{B838621D-9DE2-4316-9A7D-0D1099B39BBD}"/>
+                <a16:creationId xmlns:a16="http://schemas.microsoft.com/office/drawing/2014/main" id="{6C4B02F7-11E3-45CB-822A-6ECF02B310D6}"/>
               </a:ext>
             </a:extLst>
           </p:cNvPr>
@@ -3307,7 +3307,7 @@
           <p:cNvPr id="18" name="Google Shape;18;p4">
             <a:extLst xmlns:a="http://schemas.openxmlformats.org/drawingml/2006/main">
               <a:ext uri="{FF2B5EF4-FFF2-40B4-BE49-F238E27FC236}">
-                <a16:creationId xmlns:a16="http://schemas.microsoft.com/office/drawing/2014/main" id="{C9B52D2B-6508-4FB3-BA86-50096BC06E2B}"/>
+                <a16:creationId xmlns:a16="http://schemas.microsoft.com/office/drawing/2014/main" id="{E2761933-3541-423B-80B2-1870A9DD248E}"/>
               </a:ext>
             </a:extLst>
           </p:cNvPr>
@@ -3440,7 +3440,7 @@
           <p:cNvPr id="19" name="Google Shape;19;p4">
             <a:extLst xmlns:a="http://schemas.openxmlformats.org/drawingml/2006/main">
               <a:ext uri="{FF2B5EF4-FFF2-40B4-BE49-F238E27FC236}">
-                <a16:creationId xmlns:a16="http://schemas.microsoft.com/office/drawing/2014/main" id="{0C722CE0-F365-4752-ACB6-C6A9A8F1C28B}"/>
+                <a16:creationId xmlns:a16="http://schemas.microsoft.com/office/drawing/2014/main" id="{6D032544-F3ED-4958-94C4-B910F2E146EA}"/>
               </a:ext>
             </a:extLst>
           </p:cNvPr>
@@ -3541,7 +3541,7 @@
           <p:cNvPr id="21" name="Google Shape;21;p5">
             <a:extLst xmlns:a="http://schemas.openxmlformats.org/drawingml/2006/main">
               <a:ext uri="{FF2B5EF4-FFF2-40B4-BE49-F238E27FC236}">
-                <a16:creationId xmlns:a16="http://schemas.microsoft.com/office/drawing/2014/main" id="{8FF451B1-3D3A-41A5-A062-1807B55A9E8B}"/>
+                <a16:creationId xmlns:a16="http://schemas.microsoft.com/office/drawing/2014/main" id="{177287FD-F41E-4A91-AF38-95309C4CE19D}"/>
               </a:ext>
             </a:extLst>
           </p:cNvPr>
@@ -3674,7 +3674,7 @@
           <p:cNvPr id="22" name="Google Shape;22;p5">
             <a:extLst xmlns:a="http://schemas.openxmlformats.org/drawingml/2006/main">
               <a:ext uri="{FF2B5EF4-FFF2-40B4-BE49-F238E27FC236}">
-                <a16:creationId xmlns:a16="http://schemas.microsoft.com/office/drawing/2014/main" id="{6BD51A54-31BB-41A7-B052-0AEC59EF515C}"/>
+                <a16:creationId xmlns:a16="http://schemas.microsoft.com/office/drawing/2014/main" id="{64F36FF5-0A83-456F-B76A-BCD9A6F71C41}"/>
               </a:ext>
             </a:extLst>
           </p:cNvPr>
@@ -3807,7 +3807,7 @@
           <p:cNvPr id="23" name="Google Shape;23;p5">
             <a:extLst xmlns:a="http://schemas.openxmlformats.org/drawingml/2006/main">
               <a:ext uri="{FF2B5EF4-FFF2-40B4-BE49-F238E27FC236}">
-                <a16:creationId xmlns:a16="http://schemas.microsoft.com/office/drawing/2014/main" id="{D7C91530-DC0D-48E9-AA2F-3671FB5B56AD}"/>
+                <a16:creationId xmlns:a16="http://schemas.microsoft.com/office/drawing/2014/main" id="{7514AF84-606D-44B8-9F11-B95C0C8BBF63}"/>
               </a:ext>
             </a:extLst>
           </p:cNvPr>
@@ -3940,7 +3940,7 @@
           <p:cNvPr id="24" name="Google Shape;24;p5">
             <a:extLst xmlns:a="http://schemas.openxmlformats.org/drawingml/2006/main">
               <a:ext uri="{FF2B5EF4-FFF2-40B4-BE49-F238E27FC236}">
-                <a16:creationId xmlns:a16="http://schemas.microsoft.com/office/drawing/2014/main" id="{3EBAD8D4-BAA1-4BB4-858B-5D6044D55A18}"/>
+                <a16:creationId xmlns:a16="http://schemas.microsoft.com/office/drawing/2014/main" id="{1384970C-6A71-4232-A7FE-B62FFBCD1369}"/>
               </a:ext>
             </a:extLst>
           </p:cNvPr>
@@ -4041,7 +4041,7 @@
           <p:cNvPr id="26" name="Google Shape;26;p6">
             <a:extLst xmlns:a="http://schemas.openxmlformats.org/drawingml/2006/main">
               <a:ext uri="{FF2B5EF4-FFF2-40B4-BE49-F238E27FC236}">
-                <a16:creationId xmlns:a16="http://schemas.microsoft.com/office/drawing/2014/main" id="{47D790C4-1A92-42F3-A8F9-32AF9644074A}"/>
+                <a16:creationId xmlns:a16="http://schemas.microsoft.com/office/drawing/2014/main" id="{B7FB5794-0D4E-47C8-922E-B3E1635C4723}"/>
               </a:ext>
             </a:extLst>
           </p:cNvPr>
@@ -4174,7 +4174,7 @@
           <p:cNvPr id="27" name="Google Shape;27;p6">
             <a:extLst xmlns:a="http://schemas.openxmlformats.org/drawingml/2006/main">
               <a:ext uri="{FF2B5EF4-FFF2-40B4-BE49-F238E27FC236}">
-                <a16:creationId xmlns:a16="http://schemas.microsoft.com/office/drawing/2014/main" id="{FBCA5817-A466-4A62-81E9-81EE54800340}"/>
+                <a16:creationId xmlns:a16="http://schemas.microsoft.com/office/drawing/2014/main" id="{DD605B8B-D9BF-40BB-9557-C9753B7FD5FA}"/>
               </a:ext>
             </a:extLst>
           </p:cNvPr>
@@ -4275,7 +4275,7 @@
           <p:cNvPr id="29" name="Google Shape;29;p7">
             <a:extLst xmlns:a="http://schemas.openxmlformats.org/drawingml/2006/main">
               <a:ext uri="{FF2B5EF4-FFF2-40B4-BE49-F238E27FC236}">
-                <a16:creationId xmlns:a16="http://schemas.microsoft.com/office/drawing/2014/main" id="{38A8AFA4-4287-4A6B-8A7E-68F3FD7DB08E}"/>
+                <a16:creationId xmlns:a16="http://schemas.microsoft.com/office/drawing/2014/main" id="{B005853F-FC27-40C8-B2BD-B69705AA055A}"/>
               </a:ext>
             </a:extLst>
           </p:cNvPr>
@@ -4408,7 +4408,7 @@
           <p:cNvPr id="30" name="Google Shape;30;p7">
             <a:extLst xmlns:a="http://schemas.openxmlformats.org/drawingml/2006/main">
               <a:ext uri="{FF2B5EF4-FFF2-40B4-BE49-F238E27FC236}">
-                <a16:creationId xmlns:a16="http://schemas.microsoft.com/office/drawing/2014/main" id="{7A63F29F-A17F-4181-9567-B79940393A04}"/>
+                <a16:creationId xmlns:a16="http://schemas.microsoft.com/office/drawing/2014/main" id="{79B6DACD-E410-4113-92D6-B03BFAD29742}"/>
               </a:ext>
             </a:extLst>
           </p:cNvPr>
@@ -4541,7 +4541,7 @@
           <p:cNvPr id="31" name="Google Shape;31;p7">
             <a:extLst xmlns:a="http://schemas.openxmlformats.org/drawingml/2006/main">
               <a:ext uri="{FF2B5EF4-FFF2-40B4-BE49-F238E27FC236}">
-                <a16:creationId xmlns:a16="http://schemas.microsoft.com/office/drawing/2014/main" id="{C4533E5C-2DE8-4EF7-983E-92C5E36C5C1C}"/>
+                <a16:creationId xmlns:a16="http://schemas.microsoft.com/office/drawing/2014/main" id="{53499764-8C7E-441E-88C9-98041E248813}"/>
               </a:ext>
             </a:extLst>
           </p:cNvPr>
@@ -4642,7 +4642,7 @@
           <p:cNvPr id="33" name="Google Shape;33;p8">
             <a:extLst xmlns:a="http://schemas.openxmlformats.org/drawingml/2006/main">
               <a:ext uri="{FF2B5EF4-FFF2-40B4-BE49-F238E27FC236}">
-                <a16:creationId xmlns:a16="http://schemas.microsoft.com/office/drawing/2014/main" id="{4B453FCC-EE40-4FDD-B448-5D4D2EB560E2}"/>
+                <a16:creationId xmlns:a16="http://schemas.microsoft.com/office/drawing/2014/main" id="{88C2FE8F-BD02-42E2-9338-46AFCA8EAA68}"/>
               </a:ext>
             </a:extLst>
           </p:cNvPr>
@@ -4775,7 +4775,7 @@
           <p:cNvPr id="34" name="Google Shape;34;p8">
             <a:extLst xmlns:a="http://schemas.openxmlformats.org/drawingml/2006/main">
               <a:ext uri="{FF2B5EF4-FFF2-40B4-BE49-F238E27FC236}">
-                <a16:creationId xmlns:a16="http://schemas.microsoft.com/office/drawing/2014/main" id="{662618F4-29A7-4FE3-B062-88578F2ABFE2}"/>
+                <a16:creationId xmlns:a16="http://schemas.microsoft.com/office/drawing/2014/main" id="{04FBF2FC-A35E-477E-8A4B-C1D60074DA03}"/>
               </a:ext>
             </a:extLst>
           </p:cNvPr>
@@ -4876,7 +4876,7 @@
           <p:cNvPr id="36" name="Google Shape;36;p9">
             <a:extLst xmlns:a="http://schemas.openxmlformats.org/drawingml/2006/main">
               <a:ext uri="{FF2B5EF4-FFF2-40B4-BE49-F238E27FC236}">
-                <a16:creationId xmlns:a16="http://schemas.microsoft.com/office/drawing/2014/main" id="{CEA5154B-F017-4452-8665-2D6A936203ED}"/>
+                <a16:creationId xmlns:a16="http://schemas.microsoft.com/office/drawing/2014/main" id="{7BE2E93C-370C-4AF9-A29D-1025C43672C7}"/>
               </a:ext>
             </a:extLst>
           </p:cNvPr>
@@ -4927,7 +4927,7 @@
           <p:cNvPr id="37" name="Google Shape;37;p9">
             <a:extLst xmlns:a="http://schemas.openxmlformats.org/drawingml/2006/main">
               <a:ext uri="{FF2B5EF4-FFF2-40B4-BE49-F238E27FC236}">
-                <a16:creationId xmlns:a16="http://schemas.microsoft.com/office/drawing/2014/main" id="{95670F5E-B80F-47C8-8B59-8F53AE5CBDA0}"/>
+                <a16:creationId xmlns:a16="http://schemas.microsoft.com/office/drawing/2014/main" id="{72DD6735-E041-484F-A96E-973FABC0B29C}"/>
               </a:ext>
             </a:extLst>
           </p:cNvPr>
@@ -5060,7 +5060,7 @@
           <p:cNvPr id="38" name="Google Shape;38;p9">
             <a:extLst xmlns:a="http://schemas.openxmlformats.org/drawingml/2006/main">
               <a:ext uri="{FF2B5EF4-FFF2-40B4-BE49-F238E27FC236}">
-                <a16:creationId xmlns:a16="http://schemas.microsoft.com/office/drawing/2014/main" id="{72A49AD1-A156-43D3-AA72-A1B7CF0112BC}"/>
+                <a16:creationId xmlns:a16="http://schemas.microsoft.com/office/drawing/2014/main" id="{47C12201-6B50-45A0-B12A-F17CFDCFCB12}"/>
               </a:ext>
             </a:extLst>
           </p:cNvPr>
@@ -5220,7 +5220,7 @@
           <p:cNvPr id="39" name="Google Shape;39;p9">
             <a:extLst xmlns:a="http://schemas.openxmlformats.org/drawingml/2006/main">
               <a:ext uri="{FF2B5EF4-FFF2-40B4-BE49-F238E27FC236}">
-                <a16:creationId xmlns:a16="http://schemas.microsoft.com/office/drawing/2014/main" id="{FB744F85-A784-4F75-951D-70A04A829A53}"/>
+                <a16:creationId xmlns:a16="http://schemas.microsoft.com/office/drawing/2014/main" id="{8234009F-143B-4FBC-B092-53E72D5523DB}"/>
               </a:ext>
             </a:extLst>
           </p:cNvPr>
@@ -5353,7 +5353,7 @@
           <p:cNvPr id="40" name="Google Shape;40;p9">
             <a:extLst xmlns:a="http://schemas.openxmlformats.org/drawingml/2006/main">
               <a:ext uri="{FF2B5EF4-FFF2-40B4-BE49-F238E27FC236}">
-                <a16:creationId xmlns:a16="http://schemas.microsoft.com/office/drawing/2014/main" id="{7BB68212-3FA9-4A77-B8AA-1E397829FD85}"/>
+                <a16:creationId xmlns:a16="http://schemas.microsoft.com/office/drawing/2014/main" id="{470FEAAC-4302-4DB9-902C-E7A5F20EA70D}"/>
               </a:ext>
             </a:extLst>
           </p:cNvPr>
@@ -5454,7 +5454,7 @@
           <p:cNvPr id="42" name="Google Shape;42;p10">
             <a:extLst xmlns:a="http://schemas.openxmlformats.org/drawingml/2006/main">
               <a:ext uri="{FF2B5EF4-FFF2-40B4-BE49-F238E27FC236}">
-                <a16:creationId xmlns:a16="http://schemas.microsoft.com/office/drawing/2014/main" id="{2C2255EC-1AF8-40C9-B85D-FB6C02577AB7}"/>
+                <a16:creationId xmlns:a16="http://schemas.microsoft.com/office/drawing/2014/main" id="{502DF433-EE77-49BD-9743-7E3015E90779}"/>
               </a:ext>
             </a:extLst>
           </p:cNvPr>
@@ -5502,7 +5502,7 @@
           <p:cNvPr id="43" name="Google Shape;43;p10">
             <a:extLst xmlns:a="http://schemas.openxmlformats.org/drawingml/2006/main">
               <a:ext uri="{FF2B5EF4-FFF2-40B4-BE49-F238E27FC236}">
-                <a16:creationId xmlns:a16="http://schemas.microsoft.com/office/drawing/2014/main" id="{719ED0FA-C3CC-47B4-BEF8-9DF5900C3386}"/>
+                <a16:creationId xmlns:a16="http://schemas.microsoft.com/office/drawing/2014/main" id="{E3BA45EC-4639-40EE-BCBD-7AB59EBB754A}"/>
               </a:ext>
             </a:extLst>
           </p:cNvPr>
@@ -5610,7 +5610,7 @@
           <p:cNvPr id="6" name="Google Shape;6;p1">
             <a:extLst xmlns:a="http://schemas.openxmlformats.org/drawingml/2006/main">
               <a:ext uri="{FF2B5EF4-FFF2-40B4-BE49-F238E27FC236}">
-                <a16:creationId xmlns:a16="http://schemas.microsoft.com/office/drawing/2014/main" id="{775D2287-ED60-413C-819B-A878E9676440}"/>
+                <a16:creationId xmlns:a16="http://schemas.microsoft.com/office/drawing/2014/main" id="{2F7D403B-E863-4FE6-908E-834BDBF8EA86}"/>
               </a:ext>
             </a:extLst>
           </p:cNvPr>
@@ -5810,7 +5810,7 @@
           <p:cNvPr id="7" name="Google Shape;7;p1">
             <a:extLst xmlns:a="http://schemas.openxmlformats.org/drawingml/2006/main">
               <a:ext uri="{FF2B5EF4-FFF2-40B4-BE49-F238E27FC236}">
-                <a16:creationId xmlns:a16="http://schemas.microsoft.com/office/drawing/2014/main" id="{E6295C30-46F8-4C2F-9FEE-CE9232AAD605}"/>
+                <a16:creationId xmlns:a16="http://schemas.microsoft.com/office/drawing/2014/main" id="{ACE7C0C8-4039-4A16-9069-EBF8DA2DEF75}"/>
               </a:ext>
             </a:extLst>
           </p:cNvPr>
@@ -6037,7 +6037,7 @@
           <p:cNvPr id="8" name="Google Shape;8;p1">
             <a:extLst xmlns:a="http://schemas.openxmlformats.org/drawingml/2006/main">
               <a:ext uri="{FF2B5EF4-FFF2-40B4-BE49-F238E27FC236}">
-                <a16:creationId xmlns:a16="http://schemas.microsoft.com/office/drawing/2014/main" id="{3105EC0F-91CB-4A8A-ABD7-AC9ECC68DEE2}"/>
+                <a16:creationId xmlns:a16="http://schemas.microsoft.com/office/drawing/2014/main" id="{5E1C7269-C818-433B-B414-09A5230002E3}"/>
               </a:ext>
             </a:extLst>
           </p:cNvPr>
@@ -6160,17 +6160,17 @@
   </p:cSld>
   <p:clrMap bg1="lt1" tx1="dk1" bg2="dk2" tx2="lt2" accent1="accent1" accent2="accent2" accent3="accent3" accent4="accent4" accent5="accent5" accent6="accent6" hlink="hlink" folHlink="folHlink"/>
   <p:sldLayoutIdLst>
-    <p:sldLayoutId xmlns:r="http://schemas.openxmlformats.org/officeDocument/2006/relationships" id="2147483649" r:id="R61bf6eee80414ce4"/>
-    <p:sldLayoutId xmlns:r="http://schemas.openxmlformats.org/officeDocument/2006/relationships" id="2147483650" r:id="Re88109c41b484b7e"/>
-    <p:sldLayoutId xmlns:r="http://schemas.openxmlformats.org/officeDocument/2006/relationships" id="2147483651" r:id="R45d54efa66a24cff"/>
-    <p:sldLayoutId xmlns:r="http://schemas.openxmlformats.org/officeDocument/2006/relationships" id="2147483652" r:id="Re01b9e0c04434553"/>
-    <p:sldLayoutId xmlns:r="http://schemas.openxmlformats.org/officeDocument/2006/relationships" id="2147483653" r:id="R2ebef6faf8324b38"/>
-    <p:sldLayoutId xmlns:r="http://schemas.openxmlformats.org/officeDocument/2006/relationships" id="2147483654" r:id="R3766871df9354c95"/>
-    <p:sldLayoutId xmlns:r="http://schemas.openxmlformats.org/officeDocument/2006/relationships" id="2147483655" r:id="R72c0bae1589f494a"/>
-    <p:sldLayoutId xmlns:r="http://schemas.openxmlformats.org/officeDocument/2006/relationships" id="2147483656" r:id="R13a864e668c14501"/>
-    <p:sldLayoutId xmlns:r="http://schemas.openxmlformats.org/officeDocument/2006/relationships" id="2147483657" r:id="R0f2f0507f88941fd"/>
-    <p:sldLayoutId xmlns:r="http://schemas.openxmlformats.org/officeDocument/2006/relationships" id="2147483658" r:id="Ra11e40cf74244135"/>
-    <p:sldLayoutId xmlns:r="http://schemas.openxmlformats.org/officeDocument/2006/relationships" id="2147483659" r:id="Rf48d894793954f8d"/>
+    <p:sldLayoutId xmlns:r="http://schemas.openxmlformats.org/officeDocument/2006/relationships" id="2147483649" r:id="Rf056c70a021348ce"/>
+    <p:sldLayoutId xmlns:r="http://schemas.openxmlformats.org/officeDocument/2006/relationships" id="2147483650" r:id="Rae9f7feae5a842e0"/>
+    <p:sldLayoutId xmlns:r="http://schemas.openxmlformats.org/officeDocument/2006/relationships" id="2147483651" r:id="R1ff97a981b414520"/>
+    <p:sldLayoutId xmlns:r="http://schemas.openxmlformats.org/officeDocument/2006/relationships" id="2147483652" r:id="R4006e34872a74717"/>
+    <p:sldLayoutId xmlns:r="http://schemas.openxmlformats.org/officeDocument/2006/relationships" id="2147483653" r:id="R84622890aa244f5c"/>
+    <p:sldLayoutId xmlns:r="http://schemas.openxmlformats.org/officeDocument/2006/relationships" id="2147483654" r:id="R65c06a3f7e8f4e95"/>
+    <p:sldLayoutId xmlns:r="http://schemas.openxmlformats.org/officeDocument/2006/relationships" id="2147483655" r:id="Racbcbae1ab174c8d"/>
+    <p:sldLayoutId xmlns:r="http://schemas.openxmlformats.org/officeDocument/2006/relationships" id="2147483656" r:id="R350bb9ac0a3f4fa8"/>
+    <p:sldLayoutId xmlns:r="http://schemas.openxmlformats.org/officeDocument/2006/relationships" id="2147483657" r:id="R6a49f2e44db14f58"/>
+    <p:sldLayoutId xmlns:r="http://schemas.openxmlformats.org/officeDocument/2006/relationships" id="2147483658" r:id="Rb38d3e20c1594f31"/>
+    <p:sldLayoutId xmlns:r="http://schemas.openxmlformats.org/officeDocument/2006/relationships" id="2147483659" r:id="R75573ba62cbb4b79"/>
   </p:sldLayoutIdLst>
   <p:hf sldNum="0" hdr="0" ftr="0" dt="0"/>
   <p:txStyles>
@@ -7117,7 +7117,7 @@
           <p:cNvPr id="54" name="Google Shape;54;p13">
             <a:extLst xmlns:a="http://schemas.openxmlformats.org/drawingml/2006/main">
               <a:ext uri="{FF2B5EF4-FFF2-40B4-BE49-F238E27FC236}">
-                <a16:creationId xmlns:a16="http://schemas.microsoft.com/office/drawing/2014/main" id="{62DDA1E6-4529-4FE3-A7AD-E230EAAB0BFA}"/>
+                <a16:creationId xmlns:a16="http://schemas.microsoft.com/office/drawing/2014/main" id="{3E026836-1491-4243-A641-8C4FA236F4AC}"/>
               </a:ext>
             </a:extLst>
           </p:cNvPr>
@@ -7357,7 +7357,7 @@
                 <a:ea typeface="Google Sans Flex"/>
                 <a:cs typeface="Google Sans Flex"/>
               </a:rPr>
-              <a:t>AI-assisted waste recovery and reuse discovery</a:t>
+              <a:t>Evidence-based material reuse and global matching</a:t>
             </a:r>
             <a:endParaRPr sz="1800">
               <a:latin typeface="Google Sans Flex Medium"/>
@@ -7372,7 +7372,7 @@
           <p:cNvPr id="55" name="Google Shape;55;p13">
             <a:extLst xmlns:a="http://schemas.openxmlformats.org/drawingml/2006/main">
               <a:ext uri="{FF2B5EF4-FFF2-40B4-BE49-F238E27FC236}">
-                <a16:creationId xmlns:a16="http://schemas.microsoft.com/office/drawing/2014/main" id="{25D81DB6-4980-4B5F-A492-D6244DC8AADD}"/>
+                <a16:creationId xmlns:a16="http://schemas.microsoft.com/office/drawing/2014/main" id="{D86A2939-E761-4D3A-9DCC-19E143B225A0}"/>
               </a:ext>
             </a:extLst>
           </p:cNvPr>
@@ -7382,7 +7382,7 @@
           <p:nvPr/>
         </p:nvPicPr>
         <p:blipFill>
-          <a:blip xmlns:r="http://schemas.openxmlformats.org/officeDocument/2006/relationships" xmlns:a="http://schemas.openxmlformats.org/drawingml/2006/main" r:embed="Recfbb7e16fbd4e1d">
+          <a:blip xmlns:r="http://schemas.openxmlformats.org/officeDocument/2006/relationships" xmlns:a="http://schemas.openxmlformats.org/drawingml/2006/main" r:embed="Rbad165dd64d54a2b">
             <a:alphaModFix/>
           </a:blip>
           <a:stretch xmlns:a="http://schemas.openxmlformats.org/drawingml/2006/main">
@@ -7407,7 +7407,7 @@
           <p:cNvPr id="56" name="Google Shape;56;p13">
             <a:extLst xmlns:a="http://schemas.openxmlformats.org/drawingml/2006/main">
               <a:ext uri="{FF2B5EF4-FFF2-40B4-BE49-F238E27FC236}">
-                <a16:creationId xmlns:a16="http://schemas.microsoft.com/office/drawing/2014/main" id="{8DAA1624-EAF1-4E76-890F-DFD36B737FBF}"/>
+                <a16:creationId xmlns:a16="http://schemas.microsoft.com/office/drawing/2014/main" id="{095AD501-AF38-485F-B490-E1DA7028D430}"/>
               </a:ext>
             </a:extLst>
           </p:cNvPr>
@@ -7417,7 +7417,7 @@
           <p:nvPr/>
         </p:nvPicPr>
         <p:blipFill rotWithShape="1">
-          <a:blip xmlns:r="http://schemas.openxmlformats.org/officeDocument/2006/relationships" xmlns:a="http://schemas.openxmlformats.org/drawingml/2006/main" r:embed="R74a0bf8d74e7469a">
+          <a:blip xmlns:r="http://schemas.openxmlformats.org/officeDocument/2006/relationships" xmlns:a="http://schemas.openxmlformats.org/drawingml/2006/main" r:embed="Rb9f76075d3294721">
             <a:alphaModFix/>
           </a:blip>
           <a:srcRect xmlns:a="http://schemas.openxmlformats.org/drawingml/2006/main" l="0" t="0" r="0" b="98001"/>
@@ -7439,7 +7439,7 @@
     </p:spTree>
     <p:extLst>
       <p:ext uri="{BB962C8B-B14F-4D97-AF65-F5344CB8AC3E}">
-        <p14:creationId xmlns:p14="http://schemas.microsoft.com/office/powerpoint/2010/main" val="1340829841"/>
+        <p14:creationId xmlns:p14="http://schemas.microsoft.com/office/powerpoint/2010/main" val="1515471821"/>
       </p:ext>
     </p:extLst>
   </p:cSld>
@@ -7463,7 +7463,7 @@
           <p:cNvPr id="124" name="Google Shape;124;p22">
             <a:extLst xmlns:a="http://schemas.openxmlformats.org/drawingml/2006/main">
               <a:ext uri="{FF2B5EF4-FFF2-40B4-BE49-F238E27FC236}">
-                <a16:creationId xmlns:a16="http://schemas.microsoft.com/office/drawing/2014/main" id="{361FBAAE-01AC-477A-BEFE-86FCA187E132}"/>
+                <a16:creationId xmlns:a16="http://schemas.microsoft.com/office/drawing/2014/main" id="{A4CC13B1-DDE8-42BB-A95B-06C44F983D92}"/>
               </a:ext>
             </a:extLst>
           </p:cNvPr>
@@ -7473,7 +7473,7 @@
           <p:nvPr/>
         </p:nvPicPr>
         <p:blipFill rotWithShape="1">
-          <a:blip xmlns:r="http://schemas.openxmlformats.org/officeDocument/2006/relationships" xmlns:a="http://schemas.openxmlformats.org/drawingml/2006/main" r:embed="Rbc0bd2cec6b04886">
+          <a:blip xmlns:r="http://schemas.openxmlformats.org/officeDocument/2006/relationships" xmlns:a="http://schemas.openxmlformats.org/drawingml/2006/main" r:embed="R2bd52fd7e55140a8">
             <a:alphaModFix/>
           </a:blip>
           <a:srcRect xmlns:a="http://schemas.openxmlformats.org/drawingml/2006/main" l="0" t="0" r="0" b="98001"/>
@@ -7497,7 +7497,7 @@
           <p:cNvPr id="125" name="Google Shape;125;p22">
             <a:extLst xmlns:a="http://schemas.openxmlformats.org/drawingml/2006/main">
               <a:ext uri="{FF2B5EF4-FFF2-40B4-BE49-F238E27FC236}">
-                <a16:creationId xmlns:a16="http://schemas.microsoft.com/office/drawing/2014/main" id="{623672F2-8CDA-4EA5-BCB1-D8AF2F4DCB2C}"/>
+                <a16:creationId xmlns:a16="http://schemas.microsoft.com/office/drawing/2014/main" id="{D75394E8-792F-4A82-B0DC-AC55CACCC92C}"/>
               </a:ext>
             </a:extLst>
           </p:cNvPr>
@@ -7507,7 +7507,7 @@
           <p:nvPr/>
         </p:nvPicPr>
         <p:blipFill>
-          <a:blip xmlns:r="http://schemas.openxmlformats.org/officeDocument/2006/relationships" xmlns:a="http://schemas.openxmlformats.org/drawingml/2006/main" r:embed="R92abd6daa9f04b58">
+          <a:blip xmlns:r="http://schemas.openxmlformats.org/officeDocument/2006/relationships" xmlns:a="http://schemas.openxmlformats.org/drawingml/2006/main" r:embed="R072e8d97eb984aac">
             <a:alphaModFix/>
           </a:blip>
           <a:stretch xmlns:a="http://schemas.openxmlformats.org/drawingml/2006/main">
@@ -7532,7 +7532,7 @@
           <p:cNvPr id="126" name="Google Shape;126;p22">
             <a:extLst xmlns:a="http://schemas.openxmlformats.org/drawingml/2006/main">
               <a:ext uri="{FF2B5EF4-FFF2-40B4-BE49-F238E27FC236}">
-                <a16:creationId xmlns:a16="http://schemas.microsoft.com/office/drawing/2014/main" id="{B36AA875-E6BA-48A3-B4E7-DAC19FDE5953}"/>
+                <a16:creationId xmlns:a16="http://schemas.microsoft.com/office/drawing/2014/main" id="{18D892E8-32C5-4541-A1FB-8F2C0F5C7116}"/>
               </a:ext>
             </a:extLst>
           </p:cNvPr>
@@ -7583,7 +7583,7 @@
           <p:cNvPr id="127" name="Google Shape;127;p22">
             <a:extLst xmlns:a="http://schemas.openxmlformats.org/drawingml/2006/main">
               <a:ext uri="{FF2B5EF4-FFF2-40B4-BE49-F238E27FC236}">
-                <a16:creationId xmlns:a16="http://schemas.microsoft.com/office/drawing/2014/main" id="{85004BCF-2708-4963-8243-945634100686}"/>
+                <a16:creationId xmlns:a16="http://schemas.microsoft.com/office/drawing/2014/main" id="{AEE6D57D-F4D1-4AC2-A02F-451C28FAE2A4}"/>
               </a:ext>
             </a:extLst>
           </p:cNvPr>
@@ -7663,7 +7663,7 @@
           <p:cNvPr id="128" name="">
             <a:extLst xmlns:a="http://schemas.openxmlformats.org/drawingml/2006/main">
               <a:ext uri="{FF2B5EF4-FFF2-40B4-BE49-F238E27FC236}">
-                <a16:creationId xmlns:a16="http://schemas.microsoft.com/office/drawing/2014/main" id="{505AECFB-9ED8-4ADD-B485-0F78D9050E5C}"/>
+                <a16:creationId xmlns:a16="http://schemas.microsoft.com/office/drawing/2014/main" id="{4DF44DCE-69D9-497F-9610-51EFE37ABF15}"/>
               </a:ext>
             </a:extLst>
           </p:cNvPr>
@@ -7729,7 +7729,7 @@
           <p:cNvPr id="129" name="">
             <a:extLst xmlns:a="http://schemas.openxmlformats.org/drawingml/2006/main">
               <a:ext uri="{FF2B5EF4-FFF2-40B4-BE49-F238E27FC236}">
-                <a16:creationId xmlns:a16="http://schemas.microsoft.com/office/drawing/2014/main" id="{47735117-81B1-4516-A6C1-749A3C0308F7}"/>
+                <a16:creationId xmlns:a16="http://schemas.microsoft.com/office/drawing/2014/main" id="{DBCA0DDA-E1FA-4325-8405-5230ED2E3653}"/>
               </a:ext>
             </a:extLst>
           </p:cNvPr>
@@ -7795,7 +7795,7 @@
           <p:cNvPr id="130" name="">
             <a:extLst xmlns:a="http://schemas.openxmlformats.org/drawingml/2006/main">
               <a:ext uri="{FF2B5EF4-FFF2-40B4-BE49-F238E27FC236}">
-                <a16:creationId xmlns:a16="http://schemas.microsoft.com/office/drawing/2014/main" id="{32892104-EEF5-4437-A2EE-343E88FA6BEB}"/>
+                <a16:creationId xmlns:a16="http://schemas.microsoft.com/office/drawing/2014/main" id="{1BBEE9B1-4B79-4315-8184-823CBFCE4175}"/>
               </a:ext>
             </a:extLst>
           </p:cNvPr>
@@ -7861,7 +7861,7 @@
           <p:cNvPr id="131" name="">
             <a:extLst xmlns:a="http://schemas.openxmlformats.org/drawingml/2006/main">
               <a:ext uri="{FF2B5EF4-FFF2-40B4-BE49-F238E27FC236}">
-                <a16:creationId xmlns:a16="http://schemas.microsoft.com/office/drawing/2014/main" id="{57633134-7ED3-4B7C-8D82-939774A1C07C}"/>
+                <a16:creationId xmlns:a16="http://schemas.microsoft.com/office/drawing/2014/main" id="{55BECE39-C495-4A46-A358-3007634EFBDC}"/>
               </a:ext>
             </a:extLst>
           </p:cNvPr>
@@ -7927,7 +7927,7 @@
           <p:cNvPr id="132" name="">
             <a:extLst xmlns:a="http://schemas.openxmlformats.org/drawingml/2006/main">
               <a:ext uri="{FF2B5EF4-FFF2-40B4-BE49-F238E27FC236}">
-                <a16:creationId xmlns:a16="http://schemas.microsoft.com/office/drawing/2014/main" id="{42C4BF96-6C2A-4276-901E-B49AD53EEAD6}"/>
+                <a16:creationId xmlns:a16="http://schemas.microsoft.com/office/drawing/2014/main" id="{3979B1C3-0DB7-4EC5-BA42-CB821E13CD55}"/>
               </a:ext>
             </a:extLst>
           </p:cNvPr>
@@ -7983,7 +7983,7 @@
                 <a:ea typeface="Google Sans Flex"/>
                 <a:cs typeface="Google Sans Flex"/>
               </a:rPr>
-              <a:t>Static delivery; chunked reads; bounded AI calls, response cache and clear manual fallback when providers are unavailable.</a:t>
+              <a:t>Static delivery; bounded 200-candidate initial pool; vector cache; durable 240-text/account/24-hour embedding budget; transparent fallback.</a:t>
             </a:r>
           </a:p>
         </p:txBody>
@@ -7993,7 +7993,7 @@
           <p:cNvPr id="133" name="">
             <a:extLst xmlns:a="http://schemas.openxmlformats.org/drawingml/2006/main">
               <a:ext uri="{FF2B5EF4-FFF2-40B4-BE49-F238E27FC236}">
-                <a16:creationId xmlns:a16="http://schemas.microsoft.com/office/drawing/2014/main" id="{55D113E5-6CA3-4B23-BB7D-C4B4BDFE3B31}"/>
+                <a16:creationId xmlns:a16="http://schemas.microsoft.com/office/drawing/2014/main" id="{4192A2D1-EEE5-437C-B2E2-232A375F95CC}"/>
               </a:ext>
             </a:extLst>
           </p:cNvPr>
@@ -8059,7 +8059,7 @@
           <p:cNvPr id="134" name="">
             <a:extLst xmlns:a="http://schemas.openxmlformats.org/drawingml/2006/main">
               <a:ext uri="{FF2B5EF4-FFF2-40B4-BE49-F238E27FC236}">
-                <a16:creationId xmlns:a16="http://schemas.microsoft.com/office/drawing/2014/main" id="{6210F8EC-0748-4D63-A942-5B48F3241F23}"/>
+                <a16:creationId xmlns:a16="http://schemas.microsoft.com/office/drawing/2014/main" id="{FE2B879A-9A5F-4821-855A-6E7043ACD99B}"/>
               </a:ext>
             </a:extLst>
           </p:cNvPr>
@@ -8115,7 +8115,7 @@
                 <a:ea typeface="Google Sans Flex"/>
                 <a:cs typeface="Google Sans Flex"/>
               </a:rPr>
-              <a:t>Measure requests, tokens, database reads and audio minutes. Add user authentication, shared quotas and monitoring before changing billing.</a:t>
+              <a:t>Measure traffic and model usage. Add server retrieval indexes, durable vector caching, moderation and monitoring before broad rollout.</a:t>
             </a:r>
           </a:p>
         </p:txBody>
@@ -8125,7 +8125,7 @@
           <p:cNvPr id="135" name="">
             <a:extLst xmlns:a="http://schemas.openxmlformats.org/drawingml/2006/main">
               <a:ext uri="{FF2B5EF4-FFF2-40B4-BE49-F238E27FC236}">
-                <a16:creationId xmlns:a16="http://schemas.microsoft.com/office/drawing/2014/main" id="{23743427-2969-4398-83EE-3CC4A8D1062D}"/>
+                <a16:creationId xmlns:a16="http://schemas.microsoft.com/office/drawing/2014/main" id="{50858E6F-24B6-470C-B8AB-9B26829F6136}"/>
               </a:ext>
             </a:extLst>
           </p:cNvPr>
@@ -8189,7 +8189,7 @@
     </p:spTree>
     <p:extLst>
       <p:ext uri="{BB962C8B-B14F-4D97-AF65-F5344CB8AC3E}">
-        <p14:creationId xmlns:p14="http://schemas.microsoft.com/office/powerpoint/2010/main" val="158033141"/>
+        <p14:creationId xmlns:p14="http://schemas.microsoft.com/office/powerpoint/2010/main" val="107164330"/>
       </p:ext>
     </p:extLst>
   </p:cSld>
@@ -8213,7 +8213,7 @@
           <p:cNvPr id="132" name="Google Shape;132;p23">
             <a:extLst xmlns:a="http://schemas.openxmlformats.org/drawingml/2006/main">
               <a:ext uri="{FF2B5EF4-FFF2-40B4-BE49-F238E27FC236}">
-                <a16:creationId xmlns:a16="http://schemas.microsoft.com/office/drawing/2014/main" id="{80470AA9-A77E-425F-B7A0-34DD4563EEC0}"/>
+                <a16:creationId xmlns:a16="http://schemas.microsoft.com/office/drawing/2014/main" id="{CEBF6A48-2B6F-40DA-A74C-B6CFD8A85AB0}"/>
               </a:ext>
             </a:extLst>
           </p:cNvPr>
@@ -8223,7 +8223,7 @@
           <p:nvPr/>
         </p:nvPicPr>
         <p:blipFill rotWithShape="1">
-          <a:blip xmlns:r="http://schemas.openxmlformats.org/officeDocument/2006/relationships" xmlns:a="http://schemas.openxmlformats.org/drawingml/2006/main" r:embed="R301dfc8c5f07457b">
+          <a:blip xmlns:r="http://schemas.openxmlformats.org/officeDocument/2006/relationships" xmlns:a="http://schemas.openxmlformats.org/drawingml/2006/main" r:embed="Re85589967e194c0d">
             <a:alphaModFix/>
           </a:blip>
           <a:srcRect xmlns:a="http://schemas.openxmlformats.org/drawingml/2006/main" l="0" t="0" r="0" b="98001"/>
@@ -8247,7 +8247,7 @@
           <p:cNvPr id="133" name="Google Shape;133;p23">
             <a:extLst xmlns:a="http://schemas.openxmlformats.org/drawingml/2006/main">
               <a:ext uri="{FF2B5EF4-FFF2-40B4-BE49-F238E27FC236}">
-                <a16:creationId xmlns:a16="http://schemas.microsoft.com/office/drawing/2014/main" id="{F82A29AA-FE3A-4013-9765-67BC7268AE18}"/>
+                <a16:creationId xmlns:a16="http://schemas.microsoft.com/office/drawing/2014/main" id="{6EF0C476-8DC5-42A4-9C5A-A5EA895DADD6}"/>
               </a:ext>
             </a:extLst>
           </p:cNvPr>
@@ -8257,7 +8257,7 @@
           <p:nvPr/>
         </p:nvPicPr>
         <p:blipFill>
-          <a:blip xmlns:r="http://schemas.openxmlformats.org/officeDocument/2006/relationships" xmlns:a="http://schemas.openxmlformats.org/drawingml/2006/main" r:embed="Re8dea8a9a4cb4cc7">
+          <a:blip xmlns:r="http://schemas.openxmlformats.org/officeDocument/2006/relationships" xmlns:a="http://schemas.openxmlformats.org/drawingml/2006/main" r:embed="Ra82d1213f8ad4b77">
             <a:alphaModFix/>
           </a:blip>
           <a:stretch xmlns:a="http://schemas.openxmlformats.org/drawingml/2006/main">
@@ -8282,7 +8282,7 @@
           <p:cNvPr id="134" name="Google Shape;134;p23">
             <a:extLst xmlns:a="http://schemas.openxmlformats.org/drawingml/2006/main">
               <a:ext uri="{FF2B5EF4-FFF2-40B4-BE49-F238E27FC236}">
-                <a16:creationId xmlns:a16="http://schemas.microsoft.com/office/drawing/2014/main" id="{73C01377-25D9-4021-8150-429CCBD2F85A}"/>
+                <a16:creationId xmlns:a16="http://schemas.microsoft.com/office/drawing/2014/main" id="{D65330E6-B713-4F47-96D3-CE8EA09861D8}"/>
               </a:ext>
             </a:extLst>
           </p:cNvPr>
@@ -8333,7 +8333,7 @@
           <p:cNvPr id="135" name="Google Shape;135;p23">
             <a:extLst xmlns:a="http://schemas.openxmlformats.org/drawingml/2006/main">
               <a:ext uri="{FF2B5EF4-FFF2-40B4-BE49-F238E27FC236}">
-                <a16:creationId xmlns:a16="http://schemas.microsoft.com/office/drawing/2014/main" id="{7AF9F728-8204-45EA-BC35-D79D2BE7ABF0}"/>
+                <a16:creationId xmlns:a16="http://schemas.microsoft.com/office/drawing/2014/main" id="{01440FE7-A316-4F03-A149-40399191CED0}"/>
               </a:ext>
             </a:extLst>
           </p:cNvPr>
@@ -8413,7 +8413,7 @@
           <p:cNvPr id="136" name="">
             <a:extLst xmlns:a="http://schemas.openxmlformats.org/drawingml/2006/main">
               <a:ext uri="{FF2B5EF4-FFF2-40B4-BE49-F238E27FC236}">
-                <a16:creationId xmlns:a16="http://schemas.microsoft.com/office/drawing/2014/main" id="{691DF801-EA79-49AD-955B-4374B7946922}"/>
+                <a16:creationId xmlns:a16="http://schemas.microsoft.com/office/drawing/2014/main" id="{BB700218-D639-4C22-BAD0-CA16ED0B7E0D}"/>
               </a:ext>
             </a:extLst>
           </p:cNvPr>
@@ -8423,7 +8423,7 @@
           <p:nvPr/>
         </p:nvPicPr>
         <p:blipFill>
-          <a:blip xmlns:r="http://schemas.openxmlformats.org/officeDocument/2006/relationships" xmlns:a="http://schemas.openxmlformats.org/drawingml/2006/main" r:embed="R646254b949054e04"/>
+          <a:blip xmlns:r="http://schemas.openxmlformats.org/officeDocument/2006/relationships" xmlns:a="http://schemas.openxmlformats.org/drawingml/2006/main" r:embed="R9d1b5494fe3e44e4"/>
           <a:stretch xmlns:a="http://schemas.openxmlformats.org/drawingml/2006/main"/>
         </p:blipFill>
         <p:spPr>
@@ -8441,7 +8441,7 @@
           <p:cNvPr id="137" name="">
             <a:extLst xmlns:a="http://schemas.openxmlformats.org/drawingml/2006/main">
               <a:ext uri="{FF2B5EF4-FFF2-40B4-BE49-F238E27FC236}">
-                <a16:creationId xmlns:a16="http://schemas.microsoft.com/office/drawing/2014/main" id="{E1559A64-5685-480A-AD7E-1D3CD548EF54}"/>
+                <a16:creationId xmlns:a16="http://schemas.microsoft.com/office/drawing/2014/main" id="{B20AE7F8-E7AD-4282-86D2-7C8E4B85D3EE}"/>
               </a:ext>
             </a:extLst>
           </p:cNvPr>
@@ -8497,7 +8497,7 @@
                 <a:ea typeface="Google Sans Flex"/>
                 <a:cs typeface="Google Sans Flex"/>
               </a:rPr>
-              <a:t>LEADS → ACTION</a:t>
+              <a:t>PARTIAL FIT → NEXT STEP</a:t>
             </a:r>
           </a:p>
         </p:txBody>
@@ -8507,7 +8507,7 @@
           <p:cNvPr id="138" name="">
             <a:extLst xmlns:a="http://schemas.openxmlformats.org/drawingml/2006/main">
               <a:ext uri="{FF2B5EF4-FFF2-40B4-BE49-F238E27FC236}">
-                <a16:creationId xmlns:a16="http://schemas.microsoft.com/office/drawing/2014/main" id="{99A8FFF9-3E3E-49FB-B8EA-39894C9A3B93}"/>
+                <a16:creationId xmlns:a16="http://schemas.microsoft.com/office/drawing/2014/main" id="{B35F3587-EE73-4BF1-8716-7BD45062FA83}"/>
               </a:ext>
             </a:extLst>
           </p:cNvPr>
@@ -8563,7 +8563,7 @@
                 <a:ea typeface="Google Sans Flex"/>
                 <a:cs typeface="Google Sans Flex"/>
               </a:rPr>
-              <a:t>Real source records</a:t>
+              <a:t>PP identity: pass</a:t>
             </a:r>
           </a:p>
           <a:p xmlns:a="http://schemas.openxmlformats.org/drawingml/2006/main">
@@ -8591,7 +8591,7 @@
                 <a:ea typeface="Google Sans Flex"/>
                 <a:cs typeface="Google Sans Flex"/>
               </a:rPr>
-              <a:t>A focused acceptance enquiry</a:t>
+              <a:t>Moisture: fail</a:t>
             </a:r>
           </a:p>
           <a:p xmlns:a="http://schemas.openxmlformats.org/drawingml/2006/main">
@@ -8619,7 +8619,7 @@
                 <a:ea typeface="Google Sans Flex"/>
                 <a:cs typeface="Google Sans Flex"/>
               </a:rPr>
-              <a:t>No invented buyer prices</a:t>
+              <a:t>Drying: investigate, then retest</a:t>
             </a:r>
           </a:p>
         </p:txBody>
@@ -8629,7 +8629,7 @@
           <p:cNvPr id="139" name="">
             <a:extLst xmlns:a="http://schemas.openxmlformats.org/drawingml/2006/main">
               <a:ext uri="{FF2B5EF4-FFF2-40B4-BE49-F238E27FC236}">
-                <a16:creationId xmlns:a16="http://schemas.microsoft.com/office/drawing/2014/main" id="{8911FE55-11CC-440C-BC15-CDAB1EB39E0C}"/>
+                <a16:creationId xmlns:a16="http://schemas.microsoft.com/office/drawing/2014/main" id="{A406E482-A14F-451A-BA70-8872123E2EA0}"/>
               </a:ext>
             </a:extLst>
           </p:cNvPr>
@@ -8685,7 +8685,7 @@
                 <a:ea typeface="Google Sans Flex"/>
                 <a:cs typeface="Google Sans Flex"/>
               </a:rPr>
-              <a:t>Illustrative polypropylene scenario + real public listings. Screenshots show the working local AI connection; hosted UI is the same application.</a:t>
+              <a:t>Actual public-app capture. Illustrative PP facts and buyer requirements. A conditioning suggestion does not establish successful acceptance.</a:t>
             </a:r>
           </a:p>
         </p:txBody>
@@ -8693,7 +8693,7 @@
     </p:spTree>
     <p:extLst>
       <p:ext uri="{BB962C8B-B14F-4D97-AF65-F5344CB8AC3E}">
-        <p14:creationId xmlns:p14="http://schemas.microsoft.com/office/powerpoint/2010/main" val="104855873"/>
+        <p14:creationId xmlns:p14="http://schemas.microsoft.com/office/powerpoint/2010/main" val="741646553"/>
       </p:ext>
     </p:extLst>
   </p:cSld>
@@ -8717,7 +8717,7 @@
           <p:cNvPr id="140" name="Google Shape;140;p24">
             <a:extLst xmlns:a="http://schemas.openxmlformats.org/drawingml/2006/main">
               <a:ext uri="{FF2B5EF4-FFF2-40B4-BE49-F238E27FC236}">
-                <a16:creationId xmlns:a16="http://schemas.microsoft.com/office/drawing/2014/main" id="{F343725F-1CA9-4CE5-99A3-53DD9FFE24D1}"/>
+                <a16:creationId xmlns:a16="http://schemas.microsoft.com/office/drawing/2014/main" id="{7E5AA517-B488-4BC5-859F-A6B5ED8E67E0}"/>
               </a:ext>
             </a:extLst>
           </p:cNvPr>
@@ -8727,7 +8727,7 @@
           <p:nvPr/>
         </p:nvPicPr>
         <p:blipFill rotWithShape="1">
-          <a:blip xmlns:r="http://schemas.openxmlformats.org/officeDocument/2006/relationships" xmlns:a="http://schemas.openxmlformats.org/drawingml/2006/main" r:embed="R11f2b4d0a13a42f2">
+          <a:blip xmlns:r="http://schemas.openxmlformats.org/officeDocument/2006/relationships" xmlns:a="http://schemas.openxmlformats.org/drawingml/2006/main" r:embed="R9d04adf7d5f348d7">
             <a:alphaModFix/>
           </a:blip>
           <a:srcRect xmlns:a="http://schemas.openxmlformats.org/drawingml/2006/main" l="0" t="0" r="0" b="98001"/>
@@ -8751,7 +8751,7 @@
           <p:cNvPr id="141" name="Google Shape;141;p24">
             <a:extLst xmlns:a="http://schemas.openxmlformats.org/drawingml/2006/main">
               <a:ext uri="{FF2B5EF4-FFF2-40B4-BE49-F238E27FC236}">
-                <a16:creationId xmlns:a16="http://schemas.microsoft.com/office/drawing/2014/main" id="{6B2831BC-5EFE-4513-A75D-D2017E6DA0DB}"/>
+                <a16:creationId xmlns:a16="http://schemas.microsoft.com/office/drawing/2014/main" id="{CA4A335C-D11F-4CC9-AB71-C3FF36FE7F8B}"/>
               </a:ext>
             </a:extLst>
           </p:cNvPr>
@@ -8761,7 +8761,7 @@
           <p:nvPr/>
         </p:nvPicPr>
         <p:blipFill>
-          <a:blip xmlns:r="http://schemas.openxmlformats.org/officeDocument/2006/relationships" xmlns:a="http://schemas.openxmlformats.org/drawingml/2006/main" r:embed="R7be472fc5caa4f03">
+          <a:blip xmlns:r="http://schemas.openxmlformats.org/officeDocument/2006/relationships" xmlns:a="http://schemas.openxmlformats.org/drawingml/2006/main" r:embed="R8004706bebb14905">
             <a:alphaModFix/>
           </a:blip>
           <a:stretch xmlns:a="http://schemas.openxmlformats.org/drawingml/2006/main">
@@ -8786,7 +8786,7 @@
           <p:cNvPr id="142" name="Google Shape;142;p24">
             <a:extLst xmlns:a="http://schemas.openxmlformats.org/drawingml/2006/main">
               <a:ext uri="{FF2B5EF4-FFF2-40B4-BE49-F238E27FC236}">
-                <a16:creationId xmlns:a16="http://schemas.microsoft.com/office/drawing/2014/main" id="{E389E44E-440C-49A1-B689-785E8AA98779}"/>
+                <a16:creationId xmlns:a16="http://schemas.microsoft.com/office/drawing/2014/main" id="{39909D9F-7AA8-4B90-9B30-ACAE88A7F20A}"/>
               </a:ext>
             </a:extLst>
           </p:cNvPr>
@@ -8837,7 +8837,7 @@
           <p:cNvPr id="143" name="Google Shape;143;p24">
             <a:extLst xmlns:a="http://schemas.openxmlformats.org/drawingml/2006/main">
               <a:ext uri="{FF2B5EF4-FFF2-40B4-BE49-F238E27FC236}">
-                <a16:creationId xmlns:a16="http://schemas.microsoft.com/office/drawing/2014/main" id="{03AA97D3-65E5-4485-9B63-C14608D96F4F}"/>
+                <a16:creationId xmlns:a16="http://schemas.microsoft.com/office/drawing/2014/main" id="{7A130901-6DA9-435E-8917-F3CDFF45647D}"/>
               </a:ext>
             </a:extLst>
           </p:cNvPr>
@@ -8917,7 +8917,7 @@
           <p:cNvPr id="144" name="">
             <a:extLst xmlns:a="http://schemas.openxmlformats.org/drawingml/2006/main">
               <a:ext uri="{FF2B5EF4-FFF2-40B4-BE49-F238E27FC236}">
-                <a16:creationId xmlns:a16="http://schemas.microsoft.com/office/drawing/2014/main" id="{0E9CB6F1-CF02-49E8-99FC-90A1DC2D6149}"/>
+                <a16:creationId xmlns:a16="http://schemas.microsoft.com/office/drawing/2014/main" id="{72B23B86-D926-442F-B70A-61E23CC06CD4}"/>
               </a:ext>
             </a:extLst>
           </p:cNvPr>
@@ -8973,7 +8973,7 @@
                 <a:ea typeface="Google Sans Flex"/>
                 <a:cs typeface="Google Sans Flex"/>
               </a:rPr>
-              <a:t>39 / 39 TESTS PASS</a:t>
+              <a:t>57 AUTOMATED TESTS PASS</a:t>
             </a:r>
           </a:p>
         </p:txBody>
@@ -8983,7 +8983,7 @@
           <p:cNvPr id="145" name="">
             <a:extLst xmlns:a="http://schemas.openxmlformats.org/drawingml/2006/main">
               <a:ext uri="{FF2B5EF4-FFF2-40B4-BE49-F238E27FC236}">
-                <a16:creationId xmlns:a16="http://schemas.microsoft.com/office/drawing/2014/main" id="{51B865DA-0F80-4942-A6A8-DFA667954584}"/>
+                <a16:creationId xmlns:a16="http://schemas.microsoft.com/office/drawing/2014/main" id="{62F05DF8-3424-40ED-8F54-2D9F41D766B4}"/>
               </a:ext>
             </a:extLst>
           </p:cNvPr>
@@ -9039,7 +9039,7 @@
                 <a:ea typeface="Google Sans Flex"/>
                 <a:cs typeface="Google Sans Flex"/>
               </a:rPr>
-              <a:t>Automated regression tests cover screening, missing quotes, language keys, tool validation, microphone PCM and token controls.</a:t>
+              <a:t>Regression tests cover retrieval, units, conflicting evidence, unknowns, economics, security and existing voice controls.</a:t>
             </a:r>
           </a:p>
         </p:txBody>
@@ -9049,7 +9049,7 @@
           <p:cNvPr id="146" name="">
             <a:extLst xmlns:a="http://schemas.openxmlformats.org/drawingml/2006/main">
               <a:ext uri="{FF2B5EF4-FFF2-40B4-BE49-F238E27FC236}">
-                <a16:creationId xmlns:a16="http://schemas.microsoft.com/office/drawing/2014/main" id="{5883046B-B357-446E-B712-7689534A06AE}"/>
+                <a16:creationId xmlns:a16="http://schemas.microsoft.com/office/drawing/2014/main" id="{0F975430-6FC4-42CA-B32C-076A374E5A25}"/>
               </a:ext>
             </a:extLst>
           </p:cNvPr>
@@ -9105,7 +9105,7 @@
                 <a:ea typeface="Google Sans Flex"/>
                 <a:cs typeface="Google Sans Flex"/>
               </a:rPr>
-              <a:t>GEMINI BACKEND / PASS</a:t>
+              <a:t>24 AUTHORED ACCEPTANCE CASES</a:t>
             </a:r>
           </a:p>
         </p:txBody>
@@ -9115,7 +9115,7 @@
           <p:cNvPr id="147" name="">
             <a:extLst xmlns:a="http://schemas.openxmlformats.org/drawingml/2006/main">
               <a:ext uri="{FF2B5EF4-FFF2-40B4-BE49-F238E27FC236}">
-                <a16:creationId xmlns:a16="http://schemas.microsoft.com/office/drawing/2014/main" id="{97F2C526-2161-4081-9391-FC70C5188B8C}"/>
+                <a16:creationId xmlns:a16="http://schemas.microsoft.com/office/drawing/2014/main" id="{6672E0A5-5580-4540-BAED-877A3A9EE93A}"/>
               </a:ext>
             </a:extLst>
           </p:cNvPr>
@@ -9171,7 +9171,7 @@
                 <a:ea typeface="Google Sans Flex"/>
                 <a:cs typeface="Google Sans Flex"/>
               </a:rPr>
-              <a:t>Live Firebase AI Logic request returned HTTP 200 and a structured polypropylene profile on 17 October 2026.</a:t>
+              <a:t>24/24 expected decisions. Tests include missing facts, contradictions, hard conflicts and process conditions. Expert labels pending.</a:t>
             </a:r>
           </a:p>
         </p:txBody>
@@ -9181,7 +9181,7 @@
           <p:cNvPr id="148" name="">
             <a:extLst xmlns:a="http://schemas.openxmlformats.org/drawingml/2006/main">
               <a:ext uri="{FF2B5EF4-FFF2-40B4-BE49-F238E27FC236}">
-                <a16:creationId xmlns:a16="http://schemas.microsoft.com/office/drawing/2014/main" id="{4B1DC3A0-FD79-4B10-AA1D-807EDF35DDC9}"/>
+                <a16:creationId xmlns:a16="http://schemas.microsoft.com/office/drawing/2014/main" id="{BC199B87-1F08-400C-9E83-583DE53013C2}"/>
               </a:ext>
             </a:extLst>
           </p:cNvPr>
@@ -9237,7 +9237,7 @@
                 <a:ea typeface="Google Sans Flex"/>
                 <a:cs typeface="Google Sans Flex"/>
               </a:rPr>
-              <a:t>BROWSER WALKTHROUGH</a:t>
+              <a:t>LIVE SERVICE CHECKS</a:t>
             </a:r>
           </a:p>
         </p:txBody>
@@ -9247,7 +9247,7 @@
           <p:cNvPr id="149" name="">
             <a:extLst xmlns:a="http://schemas.openxmlformats.org/drawingml/2006/main">
               <a:ext uri="{FF2B5EF4-FFF2-40B4-BE49-F238E27FC236}">
-                <a16:creationId xmlns:a16="http://schemas.microsoft.com/office/drawing/2014/main" id="{3E173386-6E74-4FD9-90F5-0FABE8B60852}"/>
+                <a16:creationId xmlns:a16="http://schemas.microsoft.com/office/drawing/2014/main" id="{5667AC30-4CC3-4BC1-BE5D-5C89CDA6C5E3}"/>
               </a:ext>
             </a:extLst>
           </p:cNvPr>
@@ -9303,7 +9303,7 @@
                 <a:ea typeface="Google Sans Flex"/>
                 <a:cs typeface="Google Sans Flex"/>
               </a:rPr>
-              <a:t>Local AI profile, fit review and enquiry flow verified. Participant confirmed the public material profile works in Chrome/Edge.</a:t>
+              <a:t>29 cloud/access checks and 13 Firebase SDK checks pass. Actual 768-dimensional vectors and public Gemini explanations tested.</a:t>
             </a:r>
           </a:p>
         </p:txBody>
@@ -9313,7 +9313,7 @@
           <p:cNvPr id="150" name="">
             <a:extLst xmlns:a="http://schemas.openxmlformats.org/drawingml/2006/main">
               <a:ext uri="{FF2B5EF4-FFF2-40B4-BE49-F238E27FC236}">
-                <a16:creationId xmlns:a16="http://schemas.microsoft.com/office/drawing/2014/main" id="{0C9C778D-CA1D-4853-82DE-E5D1E3EB75C1}"/>
+                <a16:creationId xmlns:a16="http://schemas.microsoft.com/office/drawing/2014/main" id="{6A895715-AC78-4B82-8656-404A89343529}"/>
               </a:ext>
             </a:extLst>
           </p:cNvPr>
@@ -9369,7 +9369,7 @@
                 <a:ea typeface="Google Sans Flex"/>
                 <a:cs typeface="Google Sans Flex"/>
               </a:rPr>
-              <a:t>NOT YET BENCHMARKED</a:t>
+              <a:t>LIMITED LIVE EVALUATION</a:t>
             </a:r>
           </a:p>
         </p:txBody>
@@ -9379,7 +9379,7 @@
           <p:cNvPr id="151" name="">
             <a:extLst xmlns:a="http://schemas.openxmlformats.org/drawingml/2006/main">
               <a:ext uri="{FF2B5EF4-FFF2-40B4-BE49-F238E27FC236}">
-                <a16:creationId xmlns:a16="http://schemas.microsoft.com/office/drawing/2014/main" id="{ED25E704-DF28-4821-878B-05F997F41978}"/>
+                <a16:creationId xmlns:a16="http://schemas.microsoft.com/office/drawing/2014/main" id="{4829CB22-7A46-4812-A864-5B9E6B8E67F5}"/>
               </a:ext>
             </a:extLst>
           </p:cNvPr>
@@ -9435,7 +9435,7 @@
                 <a:ea typeface="Google Sans Flex"/>
                 <a:cs typeface="Google Sans Flex"/>
               </a:rPr>
-              <a:t>No independent extraction-accuracy study, load test, verified buyer conversion or measured environmental savings.</a:t>
+              <a:t>One scenario, 3 model runs: conditional in all three; scores 55/70/65. Two 31-record retrieval fixtures: target ranked first.</a:t>
             </a:r>
           </a:p>
         </p:txBody>
@@ -9445,7 +9445,7 @@
           <p:cNvPr id="152" name="">
             <a:extLst xmlns:a="http://schemas.openxmlformats.org/drawingml/2006/main">
               <a:ext uri="{FF2B5EF4-FFF2-40B4-BE49-F238E27FC236}">
-                <a16:creationId xmlns:a16="http://schemas.microsoft.com/office/drawing/2014/main" id="{E81160E0-D0BD-4D79-964C-60256B1D0612}"/>
+                <a16:creationId xmlns:a16="http://schemas.microsoft.com/office/drawing/2014/main" id="{F7AB30B4-5B02-42FA-9A20-981682958ABD}"/>
               </a:ext>
             </a:extLst>
           </p:cNvPr>
@@ -9501,7 +9501,7 @@
                 <a:ea typeface="Google Sans Flex"/>
                 <a:cs typeface="Google Sans Flex"/>
               </a:rPr>
-              <a:t>Test counts describe automated checks, not AI accuracy. Codex’s in-app browser could not fetch public AI; Chrome/Edge check was participant-reported.</a:t>
+              <a:t>18 October 2026. Authored fixtures and service tests are not market accuracy. No independent expert study, load benchmark or verified trade result.</a:t>
             </a:r>
           </a:p>
         </p:txBody>
@@ -9509,7 +9509,7 @@
     </p:spTree>
     <p:extLst>
       <p:ext uri="{BB962C8B-B14F-4D97-AF65-F5344CB8AC3E}">
-        <p14:creationId xmlns:p14="http://schemas.microsoft.com/office/powerpoint/2010/main" val="35244058"/>
+        <p14:creationId xmlns:p14="http://schemas.microsoft.com/office/powerpoint/2010/main" val="2127847336"/>
       </p:ext>
     </p:extLst>
   </p:cSld>
@@ -9533,7 +9533,7 @@
           <p:cNvPr id="148" name="Google Shape;148;p25">
             <a:extLst xmlns:a="http://schemas.openxmlformats.org/drawingml/2006/main">
               <a:ext uri="{FF2B5EF4-FFF2-40B4-BE49-F238E27FC236}">
-                <a16:creationId xmlns:a16="http://schemas.microsoft.com/office/drawing/2014/main" id="{FAE41E79-B2F9-4C40-B4B4-626CFC4B6B21}"/>
+                <a16:creationId xmlns:a16="http://schemas.microsoft.com/office/drawing/2014/main" id="{43BC03A9-7E97-4221-AF11-DA11D8C00DF5}"/>
               </a:ext>
             </a:extLst>
           </p:cNvPr>
@@ -9543,7 +9543,7 @@
           <p:nvPr/>
         </p:nvPicPr>
         <p:blipFill rotWithShape="1">
-          <a:blip xmlns:r="http://schemas.openxmlformats.org/officeDocument/2006/relationships" xmlns:a="http://schemas.openxmlformats.org/drawingml/2006/main" r:embed="R6f0ebb0a953d4661">
+          <a:blip xmlns:r="http://schemas.openxmlformats.org/officeDocument/2006/relationships" xmlns:a="http://schemas.openxmlformats.org/drawingml/2006/main" r:embed="R4ea448a147fc42c4">
             <a:alphaModFix/>
           </a:blip>
           <a:srcRect xmlns:a="http://schemas.openxmlformats.org/drawingml/2006/main" l="0" t="0" r="0" b="98001"/>
@@ -9567,7 +9567,7 @@
           <p:cNvPr id="149" name="Google Shape;149;p25">
             <a:extLst xmlns:a="http://schemas.openxmlformats.org/drawingml/2006/main">
               <a:ext uri="{FF2B5EF4-FFF2-40B4-BE49-F238E27FC236}">
-                <a16:creationId xmlns:a16="http://schemas.microsoft.com/office/drawing/2014/main" id="{BE5CE1D3-D734-4262-9D57-901A2ABC6FA3}"/>
+                <a16:creationId xmlns:a16="http://schemas.microsoft.com/office/drawing/2014/main" id="{2F98086E-2964-46FC-9B82-5B036D627CFA}"/>
               </a:ext>
             </a:extLst>
           </p:cNvPr>
@@ -9577,7 +9577,7 @@
           <p:nvPr/>
         </p:nvPicPr>
         <p:blipFill>
-          <a:blip xmlns:r="http://schemas.openxmlformats.org/officeDocument/2006/relationships" xmlns:a="http://schemas.openxmlformats.org/drawingml/2006/main" r:embed="Rfeaf112bb73545da">
+          <a:blip xmlns:r="http://schemas.openxmlformats.org/officeDocument/2006/relationships" xmlns:a="http://schemas.openxmlformats.org/drawingml/2006/main" r:embed="R2c670353f09d4fc2">
             <a:alphaModFix/>
           </a:blip>
           <a:stretch xmlns:a="http://schemas.openxmlformats.org/drawingml/2006/main">
@@ -9602,7 +9602,7 @@
           <p:cNvPr id="150" name="Google Shape;150;p25">
             <a:extLst xmlns:a="http://schemas.openxmlformats.org/drawingml/2006/main">
               <a:ext uri="{FF2B5EF4-FFF2-40B4-BE49-F238E27FC236}">
-                <a16:creationId xmlns:a16="http://schemas.microsoft.com/office/drawing/2014/main" id="{45341359-444C-42F7-8D4E-4F72C8D3AD92}"/>
+                <a16:creationId xmlns:a16="http://schemas.microsoft.com/office/drawing/2014/main" id="{C55C2C2E-E475-423E-AC6C-3FE1ED361A6D}"/>
               </a:ext>
             </a:extLst>
           </p:cNvPr>
@@ -9653,7 +9653,7 @@
           <p:cNvPr id="151" name="Google Shape;151;p25">
             <a:extLst xmlns:a="http://schemas.openxmlformats.org/drawingml/2006/main">
               <a:ext uri="{FF2B5EF4-FFF2-40B4-BE49-F238E27FC236}">
-                <a16:creationId xmlns:a16="http://schemas.microsoft.com/office/drawing/2014/main" id="{8EB1F5CD-2BF1-49C3-AFE5-D9B0C474A400}"/>
+                <a16:creationId xmlns:a16="http://schemas.microsoft.com/office/drawing/2014/main" id="{40B26A6E-AB36-4883-8A74-6429C1E24B74}"/>
               </a:ext>
             </a:extLst>
           </p:cNvPr>
@@ -9733,7 +9733,7 @@
           <p:cNvPr id="152" name="">
             <a:extLst xmlns:a="http://schemas.openxmlformats.org/drawingml/2006/main">
               <a:ext uri="{FF2B5EF4-FFF2-40B4-BE49-F238E27FC236}">
-                <a16:creationId xmlns:a16="http://schemas.microsoft.com/office/drawing/2014/main" id="{3CF4E2DA-1985-4241-A199-5706EA0E6C11}"/>
+                <a16:creationId xmlns:a16="http://schemas.microsoft.com/office/drawing/2014/main" id="{28B2FD39-81D2-4CE5-812B-8EEA92B076F9}"/>
               </a:ext>
             </a:extLst>
           </p:cNvPr>
@@ -9789,7 +9789,7 @@
                 <a:ea typeface="Google Sans Flex"/>
                 <a:cs typeface="Google Sans Flex"/>
               </a:rPr>
-              <a:t>NEXT / BUYER ACCEPTANCE</a:t>
+              <a:t>NEXT / VERIFIED PILOT</a:t>
             </a:r>
           </a:p>
         </p:txBody>
@@ -9799,7 +9799,7 @@
           <p:cNvPr id="153" name="">
             <a:extLst xmlns:a="http://schemas.openxmlformats.org/drawingml/2006/main">
               <a:ext uri="{FF2B5EF4-FFF2-40B4-BE49-F238E27FC236}">
-                <a16:creationId xmlns:a16="http://schemas.microsoft.com/office/drawing/2014/main" id="{7934119C-ECDB-4A65-83D6-84885D7BD229}"/>
+                <a16:creationId xmlns:a16="http://schemas.microsoft.com/office/drawing/2014/main" id="{A6298034-E36F-417E-82E6-EBCC2A3EF23C}"/>
               </a:ext>
             </a:extLst>
           </p:cNvPr>
@@ -9855,7 +9855,7 @@
                 <a:ea typeface="Google Sans Flex"/>
                 <a:cs typeface="Google Sans Flex"/>
               </a:rPr>
-              <a:t>Onboard consenting recyclers; collect actual accepted specifications, permits, capacity and written quotes.</a:t>
+              <a:t>Onboard consenting buyers and sellers. Validate evidence, accepted specifications, sample outcomes and written commercial terms.</a:t>
             </a:r>
           </a:p>
         </p:txBody>
@@ -9865,7 +9865,7 @@
           <p:cNvPr id="154" name="">
             <a:extLst xmlns:a="http://schemas.openxmlformats.org/drawingml/2006/main">
               <a:ext uri="{FF2B5EF4-FFF2-40B4-BE49-F238E27FC236}">
-                <a16:creationId xmlns:a16="http://schemas.microsoft.com/office/drawing/2014/main" id="{22BF77B0-95F2-421E-9D06-F18AF6E3AD9D}"/>
+                <a16:creationId xmlns:a16="http://schemas.microsoft.com/office/drawing/2014/main" id="{0AC1D007-08F7-417D-B68B-CE79E22C3539}"/>
               </a:ext>
             </a:extLst>
           </p:cNvPr>
@@ -9931,7 +9931,7 @@
           <p:cNvPr id="155" name="">
             <a:extLst xmlns:a="http://schemas.openxmlformats.org/drawingml/2006/main">
               <a:ext uri="{FF2B5EF4-FFF2-40B4-BE49-F238E27FC236}">
-                <a16:creationId xmlns:a16="http://schemas.microsoft.com/office/drawing/2014/main" id="{D3FA5F78-4B55-4BBA-864A-834250A13C32}"/>
+                <a16:creationId xmlns:a16="http://schemas.microsoft.com/office/drawing/2014/main" id="{2B6D2C1D-E586-4450-AA68-F9B737DA8380}"/>
               </a:ext>
             </a:extLst>
           </p:cNvPr>
@@ -9997,7 +9997,7 @@
           <p:cNvPr id="156" name="">
             <a:extLst xmlns:a="http://schemas.openxmlformats.org/drawingml/2006/main">
               <a:ext uri="{FF2B5EF4-FFF2-40B4-BE49-F238E27FC236}">
-                <a16:creationId xmlns:a16="http://schemas.microsoft.com/office/drawing/2014/main" id="{E002BB81-334A-456D-A52A-F492653256A2}"/>
+                <a16:creationId xmlns:a16="http://schemas.microsoft.com/office/drawing/2014/main" id="{7BEE1FE4-C75C-4087-BC29-C57EC54AE1E4}"/>
               </a:ext>
             </a:extLst>
           </p:cNvPr>
@@ -10063,7 +10063,7 @@
           <p:cNvPr id="157" name="">
             <a:extLst xmlns:a="http://schemas.openxmlformats.org/drawingml/2006/main">
               <a:ext uri="{FF2B5EF4-FFF2-40B4-BE49-F238E27FC236}">
-                <a16:creationId xmlns:a16="http://schemas.microsoft.com/office/drawing/2014/main" id="{87858E6A-7514-43C2-B551-22B722B890F7}"/>
+                <a16:creationId xmlns:a16="http://schemas.microsoft.com/office/drawing/2014/main" id="{13078020-2FF7-428C-A2F8-E98A354D6A35}"/>
               </a:ext>
             </a:extLst>
           </p:cNvPr>
@@ -10119,7 +10119,7 @@
                 <a:ea typeface="Google Sans Flex"/>
                 <a:cs typeface="Google Sans Flex"/>
               </a:rPr>
-              <a:t>Authentication, shared durable quotas, monitoring, dated source refreshes and regional data partnerships.</a:t>
+              <a:t>Server-side retrieval indexes, shared vector caching, abuse controls, monitoring and dated regional source refreshes.</a:t>
             </a:r>
           </a:p>
         </p:txBody>
@@ -10129,7 +10129,7 @@
           <p:cNvPr id="158" name="">
             <a:extLst xmlns:a="http://schemas.openxmlformats.org/drawingml/2006/main">
               <a:ext uri="{FF2B5EF4-FFF2-40B4-BE49-F238E27FC236}">
-                <a16:creationId xmlns:a16="http://schemas.microsoft.com/office/drawing/2014/main" id="{837C9605-DA2D-478B-B720-D42A57BA1743}"/>
+                <a16:creationId xmlns:a16="http://schemas.microsoft.com/office/drawing/2014/main" id="{1ACB13C4-BDC6-439F-8EB9-3BA13B4AE348}"/>
               </a:ext>
             </a:extLst>
           </p:cNvPr>
@@ -10195,7 +10195,7 @@
           <p:cNvPr id="159" name="">
             <a:extLst xmlns:a="http://schemas.openxmlformats.org/drawingml/2006/main">
               <a:ext uri="{FF2B5EF4-FFF2-40B4-BE49-F238E27FC236}">
-                <a16:creationId xmlns:a16="http://schemas.microsoft.com/office/drawing/2014/main" id="{F1EB6ADA-C71D-42BC-A374-07630E00FE5B}"/>
+                <a16:creationId xmlns:a16="http://schemas.microsoft.com/office/drawing/2014/main" id="{22F8B5C7-FF78-4A75-917C-1261F4878EA3}"/>
               </a:ext>
             </a:extLst>
           </p:cNvPr>
@@ -10261,7 +10261,7 @@
           <p:cNvPr id="160" name="">
             <a:extLst xmlns:a="http://schemas.openxmlformats.org/drawingml/2006/main">
               <a:ext uri="{FF2B5EF4-FFF2-40B4-BE49-F238E27FC236}">
-                <a16:creationId xmlns:a16="http://schemas.microsoft.com/office/drawing/2014/main" id="{4E4306CD-0457-4548-B9DD-5D0F630CB0D3}"/>
+                <a16:creationId xmlns:a16="http://schemas.microsoft.com/office/drawing/2014/main" id="{B85B7D46-2F5D-4D76-9364-E1A38D51E8CE}"/>
               </a:ext>
             </a:extLst>
           </p:cNvPr>
@@ -10317,7 +10317,7 @@
                 <a:ea typeface="Google Sans Flex"/>
                 <a:cs typeface="Google Sans Flex"/>
               </a:rPr>
-              <a:t>Current ranking uses state/district proximity, not road kilometres or cheapest price. No verified matching or environmental benefit is implied.</a:t>
+              <a:t>Initial search coverage is bounded, with manual pagination. No claim of exhaustive global retrieval, perfect matching or measured environmental benefit.</a:t>
             </a:r>
           </a:p>
         </p:txBody>
@@ -10325,7 +10325,7 @@
     </p:spTree>
     <p:extLst>
       <p:ext uri="{BB962C8B-B14F-4D97-AF65-F5344CB8AC3E}">
-        <p14:creationId xmlns:p14="http://schemas.microsoft.com/office/powerpoint/2010/main" val="679431512"/>
+        <p14:creationId xmlns:p14="http://schemas.microsoft.com/office/powerpoint/2010/main" val="436936593"/>
       </p:ext>
     </p:extLst>
   </p:cSld>
@@ -10349,7 +10349,7 @@
           <p:cNvPr id="156" name="Google Shape;156;p26">
             <a:extLst xmlns:a="http://schemas.openxmlformats.org/drawingml/2006/main">
               <a:ext uri="{FF2B5EF4-FFF2-40B4-BE49-F238E27FC236}">
-                <a16:creationId xmlns:a16="http://schemas.microsoft.com/office/drawing/2014/main" id="{1C19676F-D704-4D72-B44E-9C6CCD8EF87E}"/>
+                <a16:creationId xmlns:a16="http://schemas.microsoft.com/office/drawing/2014/main" id="{91CB88DB-2F4A-4B96-A087-AD095FEB7805}"/>
               </a:ext>
             </a:extLst>
           </p:cNvPr>
@@ -10359,7 +10359,7 @@
           <p:nvPr/>
         </p:nvPicPr>
         <p:blipFill rotWithShape="1">
-          <a:blip xmlns:r="http://schemas.openxmlformats.org/officeDocument/2006/relationships" xmlns:a="http://schemas.openxmlformats.org/drawingml/2006/main" r:embed="R0211aeafa44145b8">
+          <a:blip xmlns:r="http://schemas.openxmlformats.org/officeDocument/2006/relationships" xmlns:a="http://schemas.openxmlformats.org/drawingml/2006/main" r:embed="R0abeede17a8440e4">
             <a:alphaModFix/>
           </a:blip>
           <a:srcRect xmlns:a="http://schemas.openxmlformats.org/drawingml/2006/main" l="0" t="0" r="0" b="98001"/>
@@ -10383,7 +10383,7 @@
           <p:cNvPr id="157" name="Google Shape;157;p26">
             <a:extLst xmlns:a="http://schemas.openxmlformats.org/drawingml/2006/main">
               <a:ext uri="{FF2B5EF4-FFF2-40B4-BE49-F238E27FC236}">
-                <a16:creationId xmlns:a16="http://schemas.microsoft.com/office/drawing/2014/main" id="{FFA67DDB-9629-4D6B-A689-D738149F8630}"/>
+                <a16:creationId xmlns:a16="http://schemas.microsoft.com/office/drawing/2014/main" id="{9577383F-5DD3-417A-ABA9-A9D0AA4B31DD}"/>
               </a:ext>
             </a:extLst>
           </p:cNvPr>
@@ -10393,7 +10393,7 @@
           <p:nvPr/>
         </p:nvPicPr>
         <p:blipFill>
-          <a:blip xmlns:r="http://schemas.openxmlformats.org/officeDocument/2006/relationships" xmlns:a="http://schemas.openxmlformats.org/drawingml/2006/main" r:embed="R28fc1c172e0d4c4d">
+          <a:blip xmlns:r="http://schemas.openxmlformats.org/officeDocument/2006/relationships" xmlns:a="http://schemas.openxmlformats.org/drawingml/2006/main" r:embed="R840c6e26767e43c0">
             <a:alphaModFix/>
           </a:blip>
           <a:stretch xmlns:a="http://schemas.openxmlformats.org/drawingml/2006/main">
@@ -10418,7 +10418,7 @@
           <p:cNvPr id="158" name="Google Shape;158;p26">
             <a:extLst xmlns:a="http://schemas.openxmlformats.org/drawingml/2006/main">
               <a:ext uri="{FF2B5EF4-FFF2-40B4-BE49-F238E27FC236}">
-                <a16:creationId xmlns:a16="http://schemas.microsoft.com/office/drawing/2014/main" id="{6E7E7FE2-E9BC-4C64-81F8-8DBE067BC262}"/>
+                <a16:creationId xmlns:a16="http://schemas.microsoft.com/office/drawing/2014/main" id="{51071D93-0670-44A9-B00A-E314C58794BD}"/>
               </a:ext>
             </a:extLst>
           </p:cNvPr>
@@ -10469,7 +10469,7 @@
           <p:cNvPr id="159" name="Google Shape;159;p26">
             <a:extLst xmlns:a="http://schemas.openxmlformats.org/drawingml/2006/main">
               <a:ext uri="{FF2B5EF4-FFF2-40B4-BE49-F238E27FC236}">
-                <a16:creationId xmlns:a16="http://schemas.microsoft.com/office/drawing/2014/main" id="{05DE6393-F6B6-45F9-B747-4CF1FB059E4A}"/>
+                <a16:creationId xmlns:a16="http://schemas.microsoft.com/office/drawing/2014/main" id="{D78F5322-9B94-4474-A1CD-19172441EA77}"/>
               </a:ext>
             </a:extLst>
           </p:cNvPr>
@@ -10549,7 +10549,7 @@
           <p:cNvPr id="160" name="">
             <a:extLst xmlns:a="http://schemas.openxmlformats.org/drawingml/2006/main">
               <a:ext uri="{FF2B5EF4-FFF2-40B4-BE49-F238E27FC236}">
-                <a16:creationId xmlns:a16="http://schemas.microsoft.com/office/drawing/2014/main" id="{EB69A631-6123-4744-A215-384A4C2CADD9}"/>
+                <a16:creationId xmlns:a16="http://schemas.microsoft.com/office/drawing/2014/main" id="{AFFA2BBF-CC29-4670-AA51-FC662633FD47}"/>
               </a:ext>
             </a:extLst>
           </p:cNvPr>
@@ -10615,7 +10615,7 @@
           <p:cNvPr id="161" name="">
             <a:extLst xmlns:a="http://schemas.openxmlformats.org/drawingml/2006/main">
               <a:ext uri="{FF2B5EF4-FFF2-40B4-BE49-F238E27FC236}">
-                <a16:creationId xmlns:a16="http://schemas.microsoft.com/office/drawing/2014/main" id="{B4B85619-C0F1-4F9E-9137-F2C37DE4366B}"/>
+                <a16:creationId xmlns:a16="http://schemas.microsoft.com/office/drawing/2014/main" id="{C1D0ACEB-640B-4E91-91C8-A57D0CF65AC0}"/>
               </a:ext>
             </a:extLst>
           </p:cNvPr>
@@ -10670,7 +10670,7 @@
                 <a:latin typeface="Google Sans Flex"/>
                 <a:ea typeface="Google Sans Flex"/>
                 <a:cs typeface="Google Sans Flex"/>
-                <a:hlinkClick xmlns:r="http://schemas.openxmlformats.org/officeDocument/2006/relationships" r:id="R8f0f67ef9ac44722"/>
+                <a:hlinkClick xmlns:r="http://schemas.openxmlformats.org/officeDocument/2006/relationships" r:id="Rae9815693b5a452c"/>
               </a:rPr>
               <a:t>https://wasterecast.web.app/</a:t>
             </a:r>
@@ -10682,7 +10682,7 @@
           <p:cNvPr id="162" name="">
             <a:extLst xmlns:a="http://schemas.openxmlformats.org/drawingml/2006/main">
               <a:ext uri="{FF2B5EF4-FFF2-40B4-BE49-F238E27FC236}">
-                <a16:creationId xmlns:a16="http://schemas.microsoft.com/office/drawing/2014/main" id="{0BB23271-25F7-477C-A025-ABA560AF4ADD}"/>
+                <a16:creationId xmlns:a16="http://schemas.microsoft.com/office/drawing/2014/main" id="{8123B303-9A85-4175-8E09-73D0B0835FE5}"/>
               </a:ext>
             </a:extLst>
           </p:cNvPr>
@@ -10748,7 +10748,7 @@
           <p:cNvPr id="163" name="">
             <a:extLst xmlns:a="http://schemas.openxmlformats.org/drawingml/2006/main">
               <a:ext uri="{FF2B5EF4-FFF2-40B4-BE49-F238E27FC236}">
-                <a16:creationId xmlns:a16="http://schemas.microsoft.com/office/drawing/2014/main" id="{1267D791-2B35-4A9C-BE23-9D1003D4EB26}"/>
+                <a16:creationId xmlns:a16="http://schemas.microsoft.com/office/drawing/2014/main" id="{A5C5B12B-C469-40DD-9A20-5E718EB7C096}"/>
               </a:ext>
             </a:extLst>
           </p:cNvPr>
@@ -10803,7 +10803,7 @@
                 <a:latin typeface="Google Sans Flex"/>
                 <a:ea typeface="Google Sans Flex"/>
                 <a:cs typeface="Google Sans Flex"/>
-                <a:hlinkClick xmlns:r="http://schemas.openxmlformats.org/officeDocument/2006/relationships" r:id="R90188f02041d4fb4"/>
+                <a:hlinkClick xmlns:r="http://schemas.openxmlformats.org/officeDocument/2006/relationships" r:id="Rab5fbbd0bfea4b2b"/>
               </a:rPr>
               <a:t>https://github.com/anshuman542018/wasterecast</a:t>
             </a:r>
@@ -10815,7 +10815,7 @@
           <p:cNvPr id="164" name="">
             <a:extLst xmlns:a="http://schemas.openxmlformats.org/drawingml/2006/main">
               <a:ext uri="{FF2B5EF4-FFF2-40B4-BE49-F238E27FC236}">
-                <a16:creationId xmlns:a16="http://schemas.microsoft.com/office/drawing/2014/main" id="{155A1357-EFB0-4732-9FE8-C02978E12324}"/>
+                <a16:creationId xmlns:a16="http://schemas.microsoft.com/office/drawing/2014/main" id="{5E151FBC-805D-4B60-98C8-3F8726E6406D}"/>
               </a:ext>
             </a:extLst>
           </p:cNvPr>
@@ -10871,7 +10871,7 @@
                 <a:ea typeface="Google Sans Flex"/>
                 <a:cs typeface="Google Sans Flex"/>
               </a:rPr>
-              <a:t>DEMO VIDEO LINK / 3 MINUTES</a:t>
+              <a:t>UPDATED DEMO VIDEO / 3 MINUTES</a:t>
             </a:r>
           </a:p>
         </p:txBody>
@@ -10881,7 +10881,7 @@
           <p:cNvPr id="165" name="">
             <a:extLst xmlns:a="http://schemas.openxmlformats.org/drawingml/2006/main">
               <a:ext uri="{FF2B5EF4-FFF2-40B4-BE49-F238E27FC236}">
-                <a16:creationId xmlns:a16="http://schemas.microsoft.com/office/drawing/2014/main" id="{12C21AC4-540E-4C76-B1B2-4ECF4F689E61}"/>
+                <a16:creationId xmlns:a16="http://schemas.microsoft.com/office/drawing/2014/main" id="{1B0ACBB7-06F2-4772-9D25-CA00906B1D22}"/>
               </a:ext>
             </a:extLst>
           </p:cNvPr>
@@ -10936,7 +10936,7 @@
                 <a:latin typeface="Google Sans Flex"/>
                 <a:ea typeface="Google Sans Flex"/>
                 <a:cs typeface="Google Sans Flex"/>
-                <a:hlinkClick xmlns:r="http://schemas.openxmlformats.org/officeDocument/2006/relationships" r:id="Rfd677ce2a0064717"/>
+                <a:hlinkClick xmlns:r="http://schemas.openxmlformats.org/officeDocument/2006/relationships" r:id="Raa74300038e54f36"/>
               </a:rPr>
               <a:t>https://drive.google.com/file/d/1e1EyM-4qKs6WXAbR9nq35Z9UsCGghN5u/view</a:t>
             </a:r>
@@ -10948,7 +10948,7 @@
           <p:cNvPr id="166" name="">
             <a:extLst xmlns:a="http://schemas.openxmlformats.org/drawingml/2006/main">
               <a:ext uri="{FF2B5EF4-FFF2-40B4-BE49-F238E27FC236}">
-                <a16:creationId xmlns:a16="http://schemas.microsoft.com/office/drawing/2014/main" id="{96C1FC38-5B31-4F79-86E6-FDD2DA887E37}"/>
+                <a16:creationId xmlns:a16="http://schemas.microsoft.com/office/drawing/2014/main" id="{EA0A6404-8E5E-4E3B-B793-BD6F09157787}"/>
               </a:ext>
             </a:extLst>
           </p:cNvPr>
@@ -11012,7 +11012,7 @@
     </p:spTree>
     <p:extLst>
       <p:ext uri="{BB962C8B-B14F-4D97-AF65-F5344CB8AC3E}">
-        <p14:creationId xmlns:p14="http://schemas.microsoft.com/office/powerpoint/2010/main" val="656001818"/>
+        <p14:creationId xmlns:p14="http://schemas.microsoft.com/office/powerpoint/2010/main" val="840479917"/>
       </p:ext>
     </p:extLst>
   </p:cSld>
@@ -11036,7 +11036,7 @@
           <p:cNvPr id="164" name="Google Shape;164;p27">
             <a:extLst xmlns:a="http://schemas.openxmlformats.org/drawingml/2006/main">
               <a:ext uri="{FF2B5EF4-FFF2-40B4-BE49-F238E27FC236}">
-                <a16:creationId xmlns:a16="http://schemas.microsoft.com/office/drawing/2014/main" id="{AFA6E76F-E3C6-47DB-8E76-E9E4D4DC2EAC}"/>
+                <a16:creationId xmlns:a16="http://schemas.microsoft.com/office/drawing/2014/main" id="{CECC00D6-EE88-4409-A75F-B95B75EBFFC7}"/>
               </a:ext>
             </a:extLst>
           </p:cNvPr>
@@ -11046,7 +11046,7 @@
           <p:nvPr/>
         </p:nvPicPr>
         <p:blipFill rotWithShape="1">
-          <a:blip xmlns:r="http://schemas.openxmlformats.org/officeDocument/2006/relationships" xmlns:a="http://schemas.openxmlformats.org/drawingml/2006/main" r:embed="R290c7dc9df67431f">
+          <a:blip xmlns:r="http://schemas.openxmlformats.org/officeDocument/2006/relationships" xmlns:a="http://schemas.openxmlformats.org/drawingml/2006/main" r:embed="Rdcb8b3460da442df">
             <a:alphaModFix/>
           </a:blip>
           <a:srcRect xmlns:a="http://schemas.openxmlformats.org/drawingml/2006/main" l="0" t="0" r="0" b="98001"/>
@@ -11070,7 +11070,7 @@
           <p:cNvPr id="165" name="Google Shape;165;p27">
             <a:extLst xmlns:a="http://schemas.openxmlformats.org/drawingml/2006/main">
               <a:ext uri="{FF2B5EF4-FFF2-40B4-BE49-F238E27FC236}">
-                <a16:creationId xmlns:a16="http://schemas.microsoft.com/office/drawing/2014/main" id="{3452DBC9-B5DE-43D0-8563-0896F1504329}"/>
+                <a16:creationId xmlns:a16="http://schemas.microsoft.com/office/drawing/2014/main" id="{1E283F32-2BCC-4511-AF65-C090495D57BA}"/>
               </a:ext>
             </a:extLst>
           </p:cNvPr>
@@ -11080,7 +11080,7 @@
           <p:nvPr/>
         </p:nvPicPr>
         <p:blipFill>
-          <a:blip xmlns:r="http://schemas.openxmlformats.org/officeDocument/2006/relationships" xmlns:a="http://schemas.openxmlformats.org/drawingml/2006/main" r:embed="R9165d90099d84448">
+          <a:blip xmlns:r="http://schemas.openxmlformats.org/officeDocument/2006/relationships" xmlns:a="http://schemas.openxmlformats.org/drawingml/2006/main" r:embed="R6cf187330cd040ff">
             <a:alphaModFix/>
           </a:blip>
           <a:stretch xmlns:a="http://schemas.openxmlformats.org/drawingml/2006/main">
@@ -11105,7 +11105,7 @@
           <p:cNvPr id="166" name="Google Shape;166;p27">
             <a:extLst xmlns:a="http://schemas.openxmlformats.org/drawingml/2006/main">
               <a:ext uri="{FF2B5EF4-FFF2-40B4-BE49-F238E27FC236}">
-                <a16:creationId xmlns:a16="http://schemas.microsoft.com/office/drawing/2014/main" id="{0A60310D-90BA-4EF0-AE9D-EC70B0A0DC5F}"/>
+                <a16:creationId xmlns:a16="http://schemas.microsoft.com/office/drawing/2014/main" id="{67CDEF01-AE5C-4AA9-AD1F-7E13C9E99D14}"/>
               </a:ext>
             </a:extLst>
           </p:cNvPr>
@@ -11156,7 +11156,7 @@
           <p:cNvPr id="167" name="">
             <a:extLst xmlns:a="http://schemas.openxmlformats.org/drawingml/2006/main">
               <a:ext uri="{FF2B5EF4-FFF2-40B4-BE49-F238E27FC236}">
-                <a16:creationId xmlns:a16="http://schemas.microsoft.com/office/drawing/2014/main" id="{1618C53A-80EA-46C3-BD9F-19071CAE28D1}"/>
+                <a16:creationId xmlns:a16="http://schemas.microsoft.com/office/drawing/2014/main" id="{56DEAD74-E513-4C67-8288-8594AC6CA4BD}"/>
               </a:ext>
             </a:extLst>
           </p:cNvPr>
@@ -11222,7 +11222,7 @@
           <p:cNvPr id="168" name="">
             <a:extLst xmlns:a="http://schemas.openxmlformats.org/drawingml/2006/main">
               <a:ext uri="{FF2B5EF4-FFF2-40B4-BE49-F238E27FC236}">
-                <a16:creationId xmlns:a16="http://schemas.microsoft.com/office/drawing/2014/main" id="{3FFE7222-A503-47CE-8B9F-73E7D16BC74E}"/>
+                <a16:creationId xmlns:a16="http://schemas.microsoft.com/office/drawing/2014/main" id="{DCDDE766-142B-4147-8B5C-C92446967552}"/>
               </a:ext>
             </a:extLst>
           </p:cNvPr>
@@ -11278,7 +11278,7 @@
                 <a:ea typeface="Google Sans Flex"/>
                 <a:cs typeface="Google Sans Flex"/>
               </a:rPr>
-              <a:t>Real records. Explicit uncertainty. A human-confirmed next step.</a:t>
+              <a:t>Every proposed trade needs evidence and acceptance.</a:t>
             </a:r>
           </a:p>
         </p:txBody>
@@ -11288,7 +11288,7 @@
           <p:cNvPr id="169" name="">
             <a:extLst xmlns:a="http://schemas.openxmlformats.org/drawingml/2006/main">
               <a:ext uri="{FF2B5EF4-FFF2-40B4-BE49-F238E27FC236}">
-                <a16:creationId xmlns:a16="http://schemas.microsoft.com/office/drawing/2014/main" id="{BEF9685F-7A7D-4814-8676-262485C79DDF}"/>
+                <a16:creationId xmlns:a16="http://schemas.microsoft.com/office/drawing/2014/main" id="{5EE81FAA-0578-4243-8D61-3121D7DD3733}"/>
               </a:ext>
             </a:extLst>
           </p:cNvPr>
@@ -11344,7 +11344,7 @@
                 <a:ea typeface="Google Sans Flex"/>
                 <a:cs typeface="Google Sans Flex"/>
               </a:rPr>
-              <a:t>Source evidence</a:t>
+              <a:t>Two data sources</a:t>
             </a:r>
           </a:p>
         </p:txBody>
@@ -11354,7 +11354,7 @@
           <p:cNvPr id="170" name="">
             <a:extLst xmlns:a="http://schemas.openxmlformats.org/drawingml/2006/main">
               <a:ext uri="{FF2B5EF4-FFF2-40B4-BE49-F238E27FC236}">
-                <a16:creationId xmlns:a16="http://schemas.microsoft.com/office/drawing/2014/main" id="{3041B2A0-08ED-4D9A-91F0-DE16FF26F759}"/>
+                <a16:creationId xmlns:a16="http://schemas.microsoft.com/office/drawing/2014/main" id="{4F08172A-6C23-4288-B901-7E873E4B02F1}"/>
               </a:ext>
             </a:extLst>
           </p:cNvPr>
@@ -11410,7 +11410,7 @@
                 <a:ea typeface="Google Sans Flex"/>
                 <a:cs typeface="Google Sans Flex"/>
               </a:rPr>
-              <a:t>MPCB Directory 2025; TNPCB solvent list; WBPCB inventory 2023–24. Source pages and retrieval dates stay attached.</a:t>
+              <a:t>Registered listings are self-declared. The separate 912-record India directory and worldwide map leads need verification.</a:t>
             </a:r>
           </a:p>
         </p:txBody>
@@ -11420,7 +11420,7 @@
           <p:cNvPr id="171" name="">
             <a:extLst xmlns:a="http://schemas.openxmlformats.org/drawingml/2006/main">
               <a:ext uri="{FF2B5EF4-FFF2-40B4-BE49-F238E27FC236}">
-                <a16:creationId xmlns:a16="http://schemas.microsoft.com/office/drawing/2014/main" id="{D3869E7F-A4A2-4ACE-B0F5-5C10BE6F0C36}"/>
+                <a16:creationId xmlns:a16="http://schemas.microsoft.com/office/drawing/2014/main" id="{0DC33A82-C4ED-4D0A-B6AD-A9609E3E8F9A}"/>
               </a:ext>
             </a:extLst>
           </p:cNvPr>
@@ -11476,7 +11476,7 @@
                 <a:ea typeface="Google Sans Flex"/>
                 <a:cs typeface="Google Sans Flex"/>
               </a:rPr>
-              <a:t>What a lead means</a:t>
+              <a:t>AI and fixed checks</a:t>
             </a:r>
           </a:p>
         </p:txBody>
@@ -11486,7 +11486,7 @@
           <p:cNvPr id="172" name="">
             <a:extLst xmlns:a="http://schemas.openxmlformats.org/drawingml/2006/main">
               <a:ext uri="{FF2B5EF4-FFF2-40B4-BE49-F238E27FC236}">
-                <a16:creationId xmlns:a16="http://schemas.microsoft.com/office/drawing/2014/main" id="{2C1E98BC-A128-4AF5-95A1-617B06C546CA}"/>
+                <a16:creationId xmlns:a16="http://schemas.microsoft.com/office/drawing/2014/main" id="{ACD70136-9D09-4F2D-804C-E8CA6D1C8AE9}"/>
               </a:ext>
             </a:extLst>
           </p:cNvPr>
@@ -11542,7 +11542,7 @@
                 <a:ea typeface="Google Sans Flex"/>
                 <a:cs typeface="Google Sans Flex"/>
               </a:rPr>
-              <a:t>A facility worth checking. Listing status does not prove current authorization, demand, capacity or material acceptance.</a:t>
+              <a:t>Fixed checks preserve failures and unknowns. Gemini fit scores are uncalibrated estimates, never acceptance certificates.</a:t>
             </a:r>
           </a:p>
         </p:txBody>
@@ -11552,7 +11552,7 @@
           <p:cNvPr id="173" name="">
             <a:extLst xmlns:a="http://schemas.openxmlformats.org/drawingml/2006/main">
               <a:ext uri="{FF2B5EF4-FFF2-40B4-BE49-F238E27FC236}">
-                <a16:creationId xmlns:a16="http://schemas.microsoft.com/office/drawing/2014/main" id="{3C0F8E19-878B-4B92-8746-2A321AB4B99F}"/>
+                <a16:creationId xmlns:a16="http://schemas.microsoft.com/office/drawing/2014/main" id="{467BE016-498E-4C15-839F-3461A6DA89C8}"/>
               </a:ext>
             </a:extLst>
           </p:cNvPr>
@@ -11608,7 +11608,7 @@
                 <a:ea typeface="Google Sans Flex"/>
                 <a:cs typeface="Google Sans Flex"/>
               </a:rPr>
-              <a:t>What AI confidence means</a:t>
+              <a:t>Conditioning and cost</a:t>
             </a:r>
           </a:p>
         </p:txBody>
@@ -11618,7 +11618,7 @@
           <p:cNvPr id="174" name="">
             <a:extLst xmlns:a="http://schemas.openxmlformats.org/drawingml/2006/main">
               <a:ext uri="{FF2B5EF4-FFF2-40B4-BE49-F238E27FC236}">
-                <a16:creationId xmlns:a16="http://schemas.microsoft.com/office/drawing/2014/main" id="{F99302EC-85F8-4F8D-A968-7BB0DF0B31C5}"/>
+                <a16:creationId xmlns:a16="http://schemas.microsoft.com/office/drawing/2014/main" id="{6DC8B565-37FA-481A-9DDE-845856D9C851}"/>
               </a:ext>
             </a:extLst>
           </p:cNvPr>
@@ -11674,7 +11674,7 @@
                 <a:ea typeface="Google Sans Flex"/>
                 <a:cs typeface="Google Sans Flex"/>
               </a:rPr>
-              <a:t>An extraction estimate from the model. It is not a measured accuracy score or approval to move waste.</a:t>
+              <a:t>Processing needs a trial, retest and written acceptance. Costs require references; no yield or FX is invented.</a:t>
             </a:r>
           </a:p>
         </p:txBody>
@@ -11684,7 +11684,7 @@
           <p:cNvPr id="175" name="">
             <a:extLst xmlns:a="http://schemas.openxmlformats.org/drawingml/2006/main">
               <a:ext uri="{FF2B5EF4-FFF2-40B4-BE49-F238E27FC236}">
-                <a16:creationId xmlns:a16="http://schemas.microsoft.com/office/drawing/2014/main" id="{A6F969C0-D1BF-4934-A3E1-EDE6121FD76C}"/>
+                <a16:creationId xmlns:a16="http://schemas.microsoft.com/office/drawing/2014/main" id="{C04CE98B-642E-41F9-BEF4-F8EEDAC8DDD6}"/>
               </a:ext>
             </a:extLst>
           </p:cNvPr>
@@ -11750,7 +11750,7 @@
           <p:cNvPr id="176" name="">
             <a:extLst xmlns:a="http://schemas.openxmlformats.org/drawingml/2006/main">
               <a:ext uri="{FF2B5EF4-FFF2-40B4-BE49-F238E27FC236}">
-                <a16:creationId xmlns:a16="http://schemas.microsoft.com/office/drawing/2014/main" id="{BC4B8BD9-6CFB-443C-AF66-CDC3EACAF756}"/>
+                <a16:creationId xmlns:a16="http://schemas.microsoft.com/office/drawing/2014/main" id="{4DE30A6A-97DF-4E47-A14A-01A58E53864E}"/>
               </a:ext>
             </a:extLst>
           </p:cNvPr>
@@ -11806,7 +11806,7 @@
                 <a:ea typeface="Google Sans Flex"/>
                 <a:cs typeface="Google Sans Flex"/>
               </a:rPr>
-              <a:t>Public prototype and repository. Participant confirmed public AI profiling; free-tier quota and provider availability still apply.</a:t>
+              <a:t>Public app and source. Free quotas apply. Expert validation and verified commercial outcomes remain pending.</a:t>
             </a:r>
           </a:p>
         </p:txBody>
@@ -11816,7 +11816,7 @@
           <p:cNvPr id="177" name="">
             <a:extLst xmlns:a="http://schemas.openxmlformats.org/drawingml/2006/main">
               <a:ext uri="{FF2B5EF4-FFF2-40B4-BE49-F238E27FC236}">
-                <a16:creationId xmlns:a16="http://schemas.microsoft.com/office/drawing/2014/main" id="{DEAA1287-B876-4BCF-8A11-756158EECC0A}"/>
+                <a16:creationId xmlns:a16="http://schemas.microsoft.com/office/drawing/2014/main" id="{CC3AB288-BB93-402E-BE7A-81A96EAB41A1}"/>
               </a:ext>
             </a:extLst>
           </p:cNvPr>
@@ -11872,7 +11872,7 @@
                 <a:ea typeface="Google Sans Flex"/>
                 <a:cs typeface="Google Sans Flex"/>
               </a:rPr>
-              <a:t>Google free-tier processing/logging terms apply. Avoid confidential uploads. No completed transactions or certified compliance are claimed.</a:t>
+              <a:t>Document uploads use Google free-tier processing terms. Business contacts need publication consent. Private profiles/reviews have owner-only access.</a:t>
             </a:r>
           </a:p>
         </p:txBody>
@@ -11880,7 +11880,7 @@
     </p:spTree>
     <p:extLst>
       <p:ext uri="{BB962C8B-B14F-4D97-AF65-F5344CB8AC3E}">
-        <p14:creationId xmlns:p14="http://schemas.microsoft.com/office/powerpoint/2010/main" val="1663189975"/>
+        <p14:creationId xmlns:p14="http://schemas.microsoft.com/office/powerpoint/2010/main" val="1728694429"/>
       </p:ext>
     </p:extLst>
   </p:cSld>
@@ -11904,7 +11904,7 @@
           <p:cNvPr id="171" name="Google Shape;171;p28">
             <a:extLst xmlns:a="http://schemas.openxmlformats.org/drawingml/2006/main">
               <a:ext uri="{FF2B5EF4-FFF2-40B4-BE49-F238E27FC236}">
-                <a16:creationId xmlns:a16="http://schemas.microsoft.com/office/drawing/2014/main" id="{E8DBF7C1-53E5-4436-80A3-EED17390E462}"/>
+                <a16:creationId xmlns:a16="http://schemas.microsoft.com/office/drawing/2014/main" id="{7F7608E7-DC68-4DF6-8F70-FBBE1D73B426}"/>
               </a:ext>
             </a:extLst>
           </p:cNvPr>
@@ -11914,7 +11914,7 @@
           <p:nvPr/>
         </p:nvPicPr>
         <p:blipFill rotWithShape="1">
-          <a:blip xmlns:r="http://schemas.openxmlformats.org/officeDocument/2006/relationships" xmlns:a="http://schemas.openxmlformats.org/drawingml/2006/main" r:embed="R4416fd02d8eb4feb">
+          <a:blip xmlns:r="http://schemas.openxmlformats.org/officeDocument/2006/relationships" xmlns:a="http://schemas.openxmlformats.org/drawingml/2006/main" r:embed="Rcad18a2d48f54ce1">
             <a:alphaModFix/>
           </a:blip>
           <a:srcRect xmlns:a="http://schemas.openxmlformats.org/drawingml/2006/main" l="0" t="0" r="0" b="98001"/>
@@ -11938,7 +11938,7 @@
           <p:cNvPr id="172" name="Google Shape;172;p28">
             <a:extLst xmlns:a="http://schemas.openxmlformats.org/drawingml/2006/main">
               <a:ext uri="{FF2B5EF4-FFF2-40B4-BE49-F238E27FC236}">
-                <a16:creationId xmlns:a16="http://schemas.microsoft.com/office/drawing/2014/main" id="{D5687434-240B-46F8-BF97-7D214FF07772}"/>
+                <a16:creationId xmlns:a16="http://schemas.microsoft.com/office/drawing/2014/main" id="{0E73F857-DB37-4C8D-81F5-D794596936B1}"/>
               </a:ext>
             </a:extLst>
           </p:cNvPr>
@@ -11948,7 +11948,7 @@
           <p:nvPr/>
         </p:nvPicPr>
         <p:blipFill>
-          <a:blip xmlns:r="http://schemas.openxmlformats.org/officeDocument/2006/relationships" xmlns:a="http://schemas.openxmlformats.org/drawingml/2006/main" r:embed="R9834ea6ffeb7433c">
+          <a:blip xmlns:r="http://schemas.openxmlformats.org/officeDocument/2006/relationships" xmlns:a="http://schemas.openxmlformats.org/drawingml/2006/main" r:embed="R4ee0e46fa4504165">
             <a:alphaModFix/>
           </a:blip>
           <a:stretch xmlns:a="http://schemas.openxmlformats.org/drawingml/2006/main">
@@ -11971,7 +11971,7 @@
     </p:spTree>
     <p:extLst>
       <p:ext uri="{BB962C8B-B14F-4D97-AF65-F5344CB8AC3E}">
-        <p14:creationId xmlns:p14="http://schemas.microsoft.com/office/powerpoint/2010/main" val="1897235611"/>
+        <p14:creationId xmlns:p14="http://schemas.microsoft.com/office/powerpoint/2010/main" val="993415022"/>
       </p:ext>
     </p:extLst>
   </p:cSld>
@@ -11995,7 +11995,7 @@
           <p:cNvPr id="61" name="Google Shape;61;p14">
             <a:extLst xmlns:a="http://schemas.openxmlformats.org/drawingml/2006/main">
               <a:ext uri="{FF2B5EF4-FFF2-40B4-BE49-F238E27FC236}">
-                <a16:creationId xmlns:a16="http://schemas.microsoft.com/office/drawing/2014/main" id="{B57A5F17-28BF-405F-8338-9621BD5A066C}"/>
+                <a16:creationId xmlns:a16="http://schemas.microsoft.com/office/drawing/2014/main" id="{1F8FF287-3EAD-4C51-8043-D37D5F646274}"/>
               </a:ext>
             </a:extLst>
           </p:cNvPr>
@@ -12005,7 +12005,7 @@
           <p:nvPr/>
         </p:nvPicPr>
         <p:blipFill rotWithShape="1">
-          <a:blip xmlns:r="http://schemas.openxmlformats.org/officeDocument/2006/relationships" xmlns:a="http://schemas.openxmlformats.org/drawingml/2006/main" r:embed="R654de390e2444e95">
+          <a:blip xmlns:r="http://schemas.openxmlformats.org/officeDocument/2006/relationships" xmlns:a="http://schemas.openxmlformats.org/drawingml/2006/main" r:embed="Rd2eeab1c63c341b3">
             <a:alphaModFix/>
           </a:blip>
           <a:srcRect xmlns:a="http://schemas.openxmlformats.org/drawingml/2006/main" l="0" t="0" r="0" b="98001"/>
@@ -12029,7 +12029,7 @@
           <p:cNvPr id="62" name="Google Shape;62;p14">
             <a:extLst xmlns:a="http://schemas.openxmlformats.org/drawingml/2006/main">
               <a:ext uri="{FF2B5EF4-FFF2-40B4-BE49-F238E27FC236}">
-                <a16:creationId xmlns:a16="http://schemas.microsoft.com/office/drawing/2014/main" id="{0E3C7139-424B-4DC1-A494-ED82FB9DB0EA}"/>
+                <a16:creationId xmlns:a16="http://schemas.microsoft.com/office/drawing/2014/main" id="{CCB066AD-8FDE-4B76-9028-23F4E6A68B22}"/>
               </a:ext>
             </a:extLst>
           </p:cNvPr>
@@ -12080,7 +12080,7 @@
           <p:cNvPr id="63" name="Google Shape;63;p14">
             <a:extLst xmlns:a="http://schemas.openxmlformats.org/drawingml/2006/main">
               <a:ext uri="{FF2B5EF4-FFF2-40B4-BE49-F238E27FC236}">
-                <a16:creationId xmlns:a16="http://schemas.microsoft.com/office/drawing/2014/main" id="{12EBBF19-8302-4E82-8EC0-33BA95C48BF9}"/>
+                <a16:creationId xmlns:a16="http://schemas.microsoft.com/office/drawing/2014/main" id="{DC1F8FDE-3EAF-485E-9D31-7DB5775D4C59}"/>
               </a:ext>
             </a:extLst>
           </p:cNvPr>
@@ -12205,7 +12205,7 @@
                 <a:ea typeface="Google Sans Flex"/>
                 <a:cs typeface="Google Sans Flex"/>
               </a:rPr>
-              <a:t>Turn a waste description into recovery leads, source evidence and a clear next step.</a:t>
+              <a:t>Find a counterpart. Check acceptance conditions. Work through what needs to change.</a:t>
             </a:r>
             <a:endParaRPr sz="1100">
               <a:solidFill>
@@ -12283,7 +12283,7 @@
           <p:cNvPr id="64" name="Google Shape;64;p14">
             <a:extLst xmlns:a="http://schemas.openxmlformats.org/drawingml/2006/main">
               <a:ext uri="{FF2B5EF4-FFF2-40B4-BE49-F238E27FC236}">
-                <a16:creationId xmlns:a16="http://schemas.microsoft.com/office/drawing/2014/main" id="{09DCD6D1-F2EA-4264-96B9-12DAA0916679}"/>
+                <a16:creationId xmlns:a16="http://schemas.microsoft.com/office/drawing/2014/main" id="{78B81CDC-3BC2-4AFB-88E6-D36C14B16504}"/>
               </a:ext>
             </a:extLst>
           </p:cNvPr>
@@ -12293,7 +12293,7 @@
           <p:nvPr/>
         </p:nvPicPr>
         <p:blipFill>
-          <a:blip xmlns:r="http://schemas.openxmlformats.org/officeDocument/2006/relationships" xmlns:a="http://schemas.openxmlformats.org/drawingml/2006/main" r:embed="R299f2b58ebb7483a">
+          <a:blip xmlns:r="http://schemas.openxmlformats.org/officeDocument/2006/relationships" xmlns:a="http://schemas.openxmlformats.org/drawingml/2006/main" r:embed="R7b84117c5ac74ef2">
             <a:alphaModFix/>
           </a:blip>
           <a:stretch xmlns:a="http://schemas.openxmlformats.org/drawingml/2006/main"/>
@@ -12321,7 +12321,7 @@
     </p:spTree>
     <p:extLst>
       <p:ext uri="{BB962C8B-B14F-4D97-AF65-F5344CB8AC3E}">
-        <p14:creationId xmlns:p14="http://schemas.microsoft.com/office/powerpoint/2010/main" val="1946493584"/>
+        <p14:creationId xmlns:p14="http://schemas.microsoft.com/office/powerpoint/2010/main" val="666284937"/>
       </p:ext>
     </p:extLst>
   </p:cSld>
@@ -12345,7 +12345,7 @@
           <p:cNvPr id="69" name="Google Shape;69;p15">
             <a:extLst xmlns:a="http://schemas.openxmlformats.org/drawingml/2006/main">
               <a:ext uri="{FF2B5EF4-FFF2-40B4-BE49-F238E27FC236}">
-                <a16:creationId xmlns:a16="http://schemas.microsoft.com/office/drawing/2014/main" id="{DF8A2604-EC2A-4537-9C2A-3B9FF661DDA0}"/>
+                <a16:creationId xmlns:a16="http://schemas.microsoft.com/office/drawing/2014/main" id="{F96418CA-514B-4A83-8E01-C8FFB8659334}"/>
               </a:ext>
             </a:extLst>
           </p:cNvPr>
@@ -12355,7 +12355,7 @@
           <p:nvPr/>
         </p:nvPicPr>
         <p:blipFill>
-          <a:blip xmlns:r="http://schemas.openxmlformats.org/officeDocument/2006/relationships" xmlns:a="http://schemas.openxmlformats.org/drawingml/2006/main" r:embed="R5bab953389ba4652">
+          <a:blip xmlns:r="http://schemas.openxmlformats.org/officeDocument/2006/relationships" xmlns:a="http://schemas.openxmlformats.org/drawingml/2006/main" r:embed="R45bceddef51746e5">
             <a:alphaModFix/>
           </a:blip>
           <a:stretch xmlns:a="http://schemas.openxmlformats.org/drawingml/2006/main">
@@ -12380,7 +12380,7 @@
           <p:cNvPr id="70" name="Google Shape;70;p15">
             <a:extLst xmlns:a="http://schemas.openxmlformats.org/drawingml/2006/main">
               <a:ext uri="{FF2B5EF4-FFF2-40B4-BE49-F238E27FC236}">
-                <a16:creationId xmlns:a16="http://schemas.microsoft.com/office/drawing/2014/main" id="{607A0C10-733A-4E4F-A16A-AD6006F3F4E7}"/>
+                <a16:creationId xmlns:a16="http://schemas.microsoft.com/office/drawing/2014/main" id="{70631EA3-756C-4C43-8B9D-38852153CDF9}"/>
               </a:ext>
             </a:extLst>
           </p:cNvPr>
@@ -12431,7 +12431,7 @@
           <p:cNvPr id="71" name="Google Shape;71;p15">
             <a:extLst xmlns:a="http://schemas.openxmlformats.org/drawingml/2006/main">
               <a:ext uri="{FF2B5EF4-FFF2-40B4-BE49-F238E27FC236}">
-                <a16:creationId xmlns:a16="http://schemas.microsoft.com/office/drawing/2014/main" id="{316FA616-A37D-4299-A05F-FA6327F257B7}"/>
+                <a16:creationId xmlns:a16="http://schemas.microsoft.com/office/drawing/2014/main" id="{D042EDF1-921D-4B72-B59D-BD8189732682}"/>
               </a:ext>
             </a:extLst>
           </p:cNvPr>
@@ -12511,7 +12511,7 @@
           <p:cNvPr id="72" name="">
             <a:extLst xmlns:a="http://schemas.openxmlformats.org/drawingml/2006/main">
               <a:ext uri="{FF2B5EF4-FFF2-40B4-BE49-F238E27FC236}">
-                <a16:creationId xmlns:a16="http://schemas.microsoft.com/office/drawing/2014/main" id="{DE2609D1-07C0-4591-A5AE-784F816C6C3B}"/>
+                <a16:creationId xmlns:a16="http://schemas.microsoft.com/office/drawing/2014/main" id="{A6A9E167-2B42-4888-A82D-DCDF4CF0BA1F}"/>
               </a:ext>
             </a:extLst>
           </p:cNvPr>
@@ -12567,7 +12567,7 @@
                 <a:ea typeface="Google Sans Flex"/>
                 <a:cs typeface="Google Sans Flex"/>
               </a:rPr>
-              <a:t>Waste is a potential input. Finding a usable route takes evidence.</a:t>
+              <a:t>A category match does not establish material acceptance.</a:t>
             </a:r>
           </a:p>
         </p:txBody>
@@ -12577,7 +12577,7 @@
           <p:cNvPr id="73" name="">
             <a:extLst xmlns:a="http://schemas.openxmlformats.org/drawingml/2006/main">
               <a:ext uri="{FF2B5EF4-FFF2-40B4-BE49-F238E27FC236}">
-                <a16:creationId xmlns:a16="http://schemas.microsoft.com/office/drawing/2014/main" id="{0FA6CB1F-74E9-4E91-A0E1-EF6D6FC80CF4}"/>
+                <a16:creationId xmlns:a16="http://schemas.microsoft.com/office/drawing/2014/main" id="{FE1C94FB-791D-450A-AB76-C3ED6733675F}"/>
               </a:ext>
             </a:extLst>
           </p:cNvPr>
@@ -12643,7 +12643,7 @@
           <p:cNvPr id="74" name="">
             <a:extLst xmlns:a="http://schemas.openxmlformats.org/drawingml/2006/main">
               <a:ext uri="{FF2B5EF4-FFF2-40B4-BE49-F238E27FC236}">
-                <a16:creationId xmlns:a16="http://schemas.microsoft.com/office/drawing/2014/main" id="{D0496D4F-D845-44C3-9DD5-12C0B8AD494F}"/>
+                <a16:creationId xmlns:a16="http://schemas.microsoft.com/office/drawing/2014/main" id="{249AE0FF-3E35-41CB-9463-BE5DA508A846}"/>
               </a:ext>
             </a:extLst>
           </p:cNvPr>
@@ -12699,7 +12699,7 @@
                 <a:ea typeface="Google Sans Flex"/>
                 <a:cs typeface="Google Sans Flex"/>
               </a:rPr>
-              <a:t>A generator knows its waste, but not which facility can accept its exact composition, quantity and condition.</a:t>
+              <a:t>Generators and buyers describe the same material differently. A promising listing can still fail on moisture, contaminants, grade or usable cost.</a:t>
             </a:r>
           </a:p>
         </p:txBody>
@@ -12709,7 +12709,7 @@
           <p:cNvPr id="75" name="">
             <a:extLst xmlns:a="http://schemas.openxmlformats.org/drawingml/2006/main">
               <a:ext uri="{FF2B5EF4-FFF2-40B4-BE49-F238E27FC236}">
-                <a16:creationId xmlns:a16="http://schemas.microsoft.com/office/drawing/2014/main" id="{1E3BD7B5-46F1-4D39-92C9-64E04BBB0650}"/>
+                <a16:creationId xmlns:a16="http://schemas.microsoft.com/office/drawing/2014/main" id="{760C9242-2416-425A-88A6-140D52ED6516}"/>
               </a:ext>
             </a:extLst>
           </p:cNvPr>
@@ -12775,7 +12775,7 @@
           <p:cNvPr id="76" name="">
             <a:extLst xmlns:a="http://schemas.openxmlformats.org/drawingml/2006/main">
               <a:ext uri="{FF2B5EF4-FFF2-40B4-BE49-F238E27FC236}">
-                <a16:creationId xmlns:a16="http://schemas.microsoft.com/office/drawing/2014/main" id="{46F0934D-2B75-4B60-AB02-BB3DCC8BBEF0}"/>
+                <a16:creationId xmlns:a16="http://schemas.microsoft.com/office/drawing/2014/main" id="{6D7AFD09-8125-4E81-910D-3C620D60ED4D}"/>
               </a:ext>
             </a:extLst>
           </p:cNvPr>
@@ -12831,7 +12831,7 @@
                 <a:ea typeface="Google Sans Flex"/>
                 <a:cs typeface="Google Sans Flex"/>
               </a:rPr>
-              <a:t>Gemini extracts the material profile. WasteRecast screens public records, explains gaps and prepares an acceptance enquiry.</a:t>
+              <a:t>A global exchange retrieves possible counterparts, checks sourced specifications and explains a supported change to investigate before a trade.</a:t>
             </a:r>
           </a:p>
         </p:txBody>
@@ -12841,7 +12841,7 @@
           <p:cNvPr id="77" name="">
             <a:extLst xmlns:a="http://schemas.openxmlformats.org/drawingml/2006/main">
               <a:ext uri="{FF2B5EF4-FFF2-40B4-BE49-F238E27FC236}">
-                <a16:creationId xmlns:a16="http://schemas.microsoft.com/office/drawing/2014/main" id="{B0EAEC8C-A1C1-41D5-A795-94067AEECD85}"/>
+                <a16:creationId xmlns:a16="http://schemas.microsoft.com/office/drawing/2014/main" id="{CD6BC272-0B05-462D-8836-7B36DC6F21B1}"/>
               </a:ext>
             </a:extLst>
           </p:cNvPr>
@@ -12905,7 +12905,7 @@
     </p:spTree>
     <p:extLst>
       <p:ext uri="{BB962C8B-B14F-4D97-AF65-F5344CB8AC3E}">
-        <p14:creationId xmlns:p14="http://schemas.microsoft.com/office/powerpoint/2010/main" val="1592287945"/>
+        <p14:creationId xmlns:p14="http://schemas.microsoft.com/office/powerpoint/2010/main" val="1823268641"/>
       </p:ext>
     </p:extLst>
   </p:cSld>
@@ -12929,7 +12929,7 @@
           <p:cNvPr id="76" name="Google Shape;76;p16">
             <a:extLst xmlns:a="http://schemas.openxmlformats.org/drawingml/2006/main">
               <a:ext uri="{FF2B5EF4-FFF2-40B4-BE49-F238E27FC236}">
-                <a16:creationId xmlns:a16="http://schemas.microsoft.com/office/drawing/2014/main" id="{195FE7F9-BE29-4638-AA13-5A54C2A63418}"/>
+                <a16:creationId xmlns:a16="http://schemas.microsoft.com/office/drawing/2014/main" id="{A61B1350-1CC3-44F9-9E27-DAC448B81EE9}"/>
               </a:ext>
             </a:extLst>
           </p:cNvPr>
@@ -12939,7 +12939,7 @@
           <p:nvPr/>
         </p:nvPicPr>
         <p:blipFill rotWithShape="1">
-          <a:blip xmlns:r="http://schemas.openxmlformats.org/officeDocument/2006/relationships" xmlns:a="http://schemas.openxmlformats.org/drawingml/2006/main" r:embed="Rc719a884e2f5433c">
+          <a:blip xmlns:r="http://schemas.openxmlformats.org/officeDocument/2006/relationships" xmlns:a="http://schemas.openxmlformats.org/drawingml/2006/main" r:embed="Rd7edbcc50c874539">
             <a:alphaModFix/>
           </a:blip>
           <a:srcRect xmlns:a="http://schemas.openxmlformats.org/drawingml/2006/main" l="0" t="0" r="0" b="98001"/>
@@ -12963,7 +12963,7 @@
           <p:cNvPr id="77" name="Google Shape;77;p16">
             <a:extLst xmlns:a="http://schemas.openxmlformats.org/drawingml/2006/main">
               <a:ext uri="{FF2B5EF4-FFF2-40B4-BE49-F238E27FC236}">
-                <a16:creationId xmlns:a16="http://schemas.microsoft.com/office/drawing/2014/main" id="{F95528AB-0F7D-46AB-9B30-48CB8A6000A6}"/>
+                <a16:creationId xmlns:a16="http://schemas.microsoft.com/office/drawing/2014/main" id="{1BA49859-66AB-4E71-B8D1-A04C09411063}"/>
               </a:ext>
             </a:extLst>
           </p:cNvPr>
@@ -12973,7 +12973,7 @@
           <p:nvPr/>
         </p:nvPicPr>
         <p:blipFill>
-          <a:blip xmlns:r="http://schemas.openxmlformats.org/officeDocument/2006/relationships" xmlns:a="http://schemas.openxmlformats.org/drawingml/2006/main" r:embed="Rdf8b9b4ed0af4ad4">
+          <a:blip xmlns:r="http://schemas.openxmlformats.org/officeDocument/2006/relationships" xmlns:a="http://schemas.openxmlformats.org/drawingml/2006/main" r:embed="Rc505671251e94744">
             <a:alphaModFix/>
           </a:blip>
           <a:stretch xmlns:a="http://schemas.openxmlformats.org/drawingml/2006/main">
@@ -12998,7 +12998,7 @@
           <p:cNvPr id="78" name="Google Shape;78;p16">
             <a:extLst xmlns:a="http://schemas.openxmlformats.org/drawingml/2006/main">
               <a:ext uri="{FF2B5EF4-FFF2-40B4-BE49-F238E27FC236}">
-                <a16:creationId xmlns:a16="http://schemas.microsoft.com/office/drawing/2014/main" id="{B1DC018F-2D9B-4043-8215-EF9262846C8C}"/>
+                <a16:creationId xmlns:a16="http://schemas.microsoft.com/office/drawing/2014/main" id="{E630F4D2-8433-40B4-B0EB-6EC039CE46A8}"/>
               </a:ext>
             </a:extLst>
           </p:cNvPr>
@@ -13049,7 +13049,7 @@
           <p:cNvPr id="79" name="Google Shape;79;p16">
             <a:extLst xmlns:a="http://schemas.openxmlformats.org/drawingml/2006/main">
               <a:ext uri="{FF2B5EF4-FFF2-40B4-BE49-F238E27FC236}">
-                <a16:creationId xmlns:a16="http://schemas.microsoft.com/office/drawing/2014/main" id="{81FA955A-3F42-4A61-BF21-71233B276A33}"/>
+                <a16:creationId xmlns:a16="http://schemas.microsoft.com/office/drawing/2014/main" id="{020DA193-A89D-4AFB-B70D-D1EFC2A03F64}"/>
               </a:ext>
             </a:extLst>
           </p:cNvPr>
@@ -13129,7 +13129,7 @@
           <p:cNvPr id="80" name="">
             <a:extLst xmlns:a="http://schemas.openxmlformats.org/drawingml/2006/main">
               <a:ext uri="{FF2B5EF4-FFF2-40B4-BE49-F238E27FC236}">
-                <a16:creationId xmlns:a16="http://schemas.microsoft.com/office/drawing/2014/main" id="{FB44E214-089C-41AD-B1CE-D99848A4FBF2}"/>
+                <a16:creationId xmlns:a16="http://schemas.microsoft.com/office/drawing/2014/main" id="{0FFD5320-BB20-4B33-88F5-591F45E59DDC}"/>
               </a:ext>
             </a:extLst>
           </p:cNvPr>
@@ -13195,7 +13195,7 @@
           <p:cNvPr id="81" name="">
             <a:extLst xmlns:a="http://schemas.openxmlformats.org/drawingml/2006/main">
               <a:ext uri="{FF2B5EF4-FFF2-40B4-BE49-F238E27FC236}">
-                <a16:creationId xmlns:a16="http://schemas.microsoft.com/office/drawing/2014/main" id="{95526CA1-E97D-4A7A-B30B-64AA2643B6AD}"/>
+                <a16:creationId xmlns:a16="http://schemas.microsoft.com/office/drawing/2014/main" id="{402DBD70-5D35-448C-8BEB-DCE9D58E5AF6}"/>
               </a:ext>
             </a:extLst>
           </p:cNvPr>
@@ -13251,7 +13251,7 @@
                 <a:ea typeface="Google Sans Flex"/>
                 <a:cs typeface="Google Sans Flex"/>
               </a:rPr>
-              <a:t>Evidence stays beside each lead. Missing specifications and unconfirmed acceptance stay visible.</a:t>
+              <a:t>Search retrieves possibilities by meaning. Typed checks then distinguish a stated fit, an unknown fact, a failed condition and an incompatible material.</a:t>
             </a:r>
           </a:p>
         </p:txBody>
@@ -13261,7 +13261,7 @@
           <p:cNvPr id="82" name="">
             <a:extLst xmlns:a="http://schemas.openxmlformats.org/drawingml/2006/main">
               <a:ext uri="{FF2B5EF4-FFF2-40B4-BE49-F238E27FC236}">
-                <a16:creationId xmlns:a16="http://schemas.microsoft.com/office/drawing/2014/main" id="{99D7644D-A6BC-4E91-8ADF-F3999E0F9476}"/>
+                <a16:creationId xmlns:a16="http://schemas.microsoft.com/office/drawing/2014/main" id="{8C361607-3E05-47FE-A27B-79DD1526E651}"/>
               </a:ext>
             </a:extLst>
           </p:cNvPr>
@@ -13327,7 +13327,7 @@
           <p:cNvPr id="83" name="">
             <a:extLst xmlns:a="http://schemas.openxmlformats.org/drawingml/2006/main">
               <a:ext uri="{FF2B5EF4-FFF2-40B4-BE49-F238E27FC236}">
-                <a16:creationId xmlns:a16="http://schemas.microsoft.com/office/drawing/2014/main" id="{8C4FAC98-C8E4-40B0-B0DE-3AFA3B365A5A}"/>
+                <a16:creationId xmlns:a16="http://schemas.microsoft.com/office/drawing/2014/main" id="{BE8477BE-C9BE-4AE4-9D94-B01C9EB15F0A}"/>
               </a:ext>
             </a:extLst>
           </p:cNvPr>
@@ -13383,7 +13383,7 @@
                 <a:ea typeface="Google Sans Flex"/>
                 <a:cs typeface="Google Sans Flex"/>
               </a:rPr>
-              <a:t>Move from an unstructured description to a short, source-linked enquiry that a recycler can actually evaluate.</a:t>
+              <a:t>Translate evidence into comparable units. Investigate a documented process for a partial fit. Recalculate economics from quotes and measured yield.</a:t>
             </a:r>
           </a:p>
         </p:txBody>
@@ -13393,7 +13393,7 @@
           <p:cNvPr id="84" name="">
             <a:extLst xmlns:a="http://schemas.openxmlformats.org/drawingml/2006/main">
               <a:ext uri="{FF2B5EF4-FFF2-40B4-BE49-F238E27FC236}">
-                <a16:creationId xmlns:a16="http://schemas.microsoft.com/office/drawing/2014/main" id="{AD6F253B-EAF3-4605-B631-A1E9EE4EB351}"/>
+                <a16:creationId xmlns:a16="http://schemas.microsoft.com/office/drawing/2014/main" id="{4DDB3778-5469-4997-9131-45077BF55A46}"/>
               </a:ext>
             </a:extLst>
           </p:cNvPr>
@@ -13459,7 +13459,7 @@
           <p:cNvPr id="85" name="">
             <a:extLst xmlns:a="http://schemas.openxmlformats.org/drawingml/2006/main">
               <a:ext uri="{FF2B5EF4-FFF2-40B4-BE49-F238E27FC236}">
-                <a16:creationId xmlns:a16="http://schemas.microsoft.com/office/drawing/2014/main" id="{85882E6C-056F-4E3B-8744-AE65DE363D3C}"/>
+                <a16:creationId xmlns:a16="http://schemas.microsoft.com/office/drawing/2014/main" id="{8E83C506-2BD6-4080-9F93-8A87ECF9C8CE}"/>
               </a:ext>
             </a:extLst>
           </p:cNvPr>
@@ -13515,7 +13515,7 @@
                 <a:ea typeface="Google Sans Flex"/>
                 <a:cs typeface="Google Sans Flex"/>
               </a:rPr>
-              <a:t>Recast combines conversational app control with a material-specific verification workflow—not a promise of a confirmed buyer.</a:t>
+              <a:t>A smallest-supported-change investigation explains what a partial match needs. It preserves the failed condition until a trial and retest support acceptance.</a:t>
             </a:r>
           </a:p>
         </p:txBody>
@@ -13525,7 +13525,7 @@
           <p:cNvPr id="86" name="">
             <a:extLst xmlns:a="http://schemas.openxmlformats.org/drawingml/2006/main">
               <a:ext uri="{FF2B5EF4-FFF2-40B4-BE49-F238E27FC236}">
-                <a16:creationId xmlns:a16="http://schemas.microsoft.com/office/drawing/2014/main" id="{90798051-DCAF-498F-891C-8979B899C121}"/>
+                <a16:creationId xmlns:a16="http://schemas.microsoft.com/office/drawing/2014/main" id="{9AD7A3F6-CB1C-47CF-A70A-DB4A05EDC80D}"/>
               </a:ext>
             </a:extLst>
           </p:cNvPr>
@@ -13581,7 +13581,7 @@
                 <a:ea typeface="Google Sans Flex"/>
                 <a:cs typeface="Google Sans Flex"/>
               </a:rPr>
-              <a:t>Marketplaces and reuse exchanges already exist. Our differentiation is the workflow; uniqueness and commercial impact still need pilot validation.</a:t>
+              <a:t>Existing exchanges also match materials. Our proposed distinction is the combined evidence, constraint and conditional-processing workflow. Pilot validation is pending.</a:t>
             </a:r>
           </a:p>
         </p:txBody>
@@ -13589,7 +13589,7 @@
     </p:spTree>
     <p:extLst>
       <p:ext uri="{BB962C8B-B14F-4D97-AF65-F5344CB8AC3E}">
-        <p14:creationId xmlns:p14="http://schemas.microsoft.com/office/powerpoint/2010/main" val="1754367876"/>
+        <p14:creationId xmlns:p14="http://schemas.microsoft.com/office/powerpoint/2010/main" val="601186513"/>
       </p:ext>
     </p:extLst>
   </p:cSld>
@@ -13613,7 +13613,7 @@
           <p:cNvPr id="84" name="Google Shape;84;p17">
             <a:extLst xmlns:a="http://schemas.openxmlformats.org/drawingml/2006/main">
               <a:ext uri="{FF2B5EF4-FFF2-40B4-BE49-F238E27FC236}">
-                <a16:creationId xmlns:a16="http://schemas.microsoft.com/office/drawing/2014/main" id="{34BE45B2-5621-4AD7-84FE-BB6721FE8FEB}"/>
+                <a16:creationId xmlns:a16="http://schemas.microsoft.com/office/drawing/2014/main" id="{6CCC1341-23C6-4AB5-8BC3-2615DD716062}"/>
               </a:ext>
             </a:extLst>
           </p:cNvPr>
@@ -13623,7 +13623,7 @@
           <p:nvPr/>
         </p:nvPicPr>
         <p:blipFill rotWithShape="1">
-          <a:blip xmlns:r="http://schemas.openxmlformats.org/officeDocument/2006/relationships" xmlns:a="http://schemas.openxmlformats.org/drawingml/2006/main" r:embed="R8631bb01a046421f">
+          <a:blip xmlns:r="http://schemas.openxmlformats.org/officeDocument/2006/relationships" xmlns:a="http://schemas.openxmlformats.org/drawingml/2006/main" r:embed="Rc7d10f9165f64c42">
             <a:alphaModFix/>
           </a:blip>
           <a:srcRect xmlns:a="http://schemas.openxmlformats.org/drawingml/2006/main" l="0" t="0" r="0" b="98001"/>
@@ -13647,7 +13647,7 @@
           <p:cNvPr id="85" name="Google Shape;85;p17">
             <a:extLst xmlns:a="http://schemas.openxmlformats.org/drawingml/2006/main">
               <a:ext uri="{FF2B5EF4-FFF2-40B4-BE49-F238E27FC236}">
-                <a16:creationId xmlns:a16="http://schemas.microsoft.com/office/drawing/2014/main" id="{98F37934-3154-476F-B163-93CA07A5FEAF}"/>
+                <a16:creationId xmlns:a16="http://schemas.microsoft.com/office/drawing/2014/main" id="{7D2CE005-2040-4FB0-9C48-12864725E6DA}"/>
               </a:ext>
             </a:extLst>
           </p:cNvPr>
@@ -13657,7 +13657,7 @@
           <p:nvPr/>
         </p:nvPicPr>
         <p:blipFill>
-          <a:blip xmlns:r="http://schemas.openxmlformats.org/officeDocument/2006/relationships" xmlns:a="http://schemas.openxmlformats.org/drawingml/2006/main" r:embed="Rce7534b1ae124800">
+          <a:blip xmlns:r="http://schemas.openxmlformats.org/officeDocument/2006/relationships" xmlns:a="http://schemas.openxmlformats.org/drawingml/2006/main" r:embed="R5baec42710d747eb">
             <a:alphaModFix/>
           </a:blip>
           <a:stretch xmlns:a="http://schemas.openxmlformats.org/drawingml/2006/main">
@@ -13682,7 +13682,7 @@
           <p:cNvPr id="86" name="Google Shape;86;p17">
             <a:extLst xmlns:a="http://schemas.openxmlformats.org/drawingml/2006/main">
               <a:ext uri="{FF2B5EF4-FFF2-40B4-BE49-F238E27FC236}">
-                <a16:creationId xmlns:a16="http://schemas.microsoft.com/office/drawing/2014/main" id="{28C5D3CB-9542-4CAF-9FF4-0C34BABBCE47}"/>
+                <a16:creationId xmlns:a16="http://schemas.microsoft.com/office/drawing/2014/main" id="{EFA6AF39-334C-4ADA-9B0B-C65760583CB7}"/>
               </a:ext>
             </a:extLst>
           </p:cNvPr>
@@ -13733,7 +13733,7 @@
           <p:cNvPr id="87" name="Google Shape;87;p17">
             <a:extLst xmlns:a="http://schemas.openxmlformats.org/drawingml/2006/main">
               <a:ext uri="{FF2B5EF4-FFF2-40B4-BE49-F238E27FC236}">
-                <a16:creationId xmlns:a16="http://schemas.microsoft.com/office/drawing/2014/main" id="{8A7792E8-2ADC-40F8-A6DD-155E6BA434C5}"/>
+                <a16:creationId xmlns:a16="http://schemas.microsoft.com/office/drawing/2014/main" id="{E3F23A04-EACF-434E-9556-621B0BD524EB}"/>
               </a:ext>
             </a:extLst>
           </p:cNvPr>
@@ -13813,7 +13813,7 @@
           <p:cNvPr id="88" name="">
             <a:extLst xmlns:a="http://schemas.openxmlformats.org/drawingml/2006/main">
               <a:ext uri="{FF2B5EF4-FFF2-40B4-BE49-F238E27FC236}">
-                <a16:creationId xmlns:a16="http://schemas.microsoft.com/office/drawing/2014/main" id="{2B775E31-5CE3-487F-B80B-C47EBC7A1B0F}"/>
+                <a16:creationId xmlns:a16="http://schemas.microsoft.com/office/drawing/2014/main" id="{76DBA02A-FB54-4653-92F2-E8F68BFC303A}"/>
               </a:ext>
             </a:extLst>
           </p:cNvPr>
@@ -13869,7 +13869,7 @@
                 <a:ea typeface="Google Sans Flex"/>
                 <a:cs typeface="Google Sans Flex"/>
               </a:rPr>
-              <a:t>01 / MATERIAL PROFILE</a:t>
+              <a:t>01 / GLOBAL REGISTERED EXCHANGE</a:t>
             </a:r>
           </a:p>
         </p:txBody>
@@ -13879,7 +13879,7 @@
           <p:cNvPr id="89" name="">
             <a:extLst xmlns:a="http://schemas.openxmlformats.org/drawingml/2006/main">
               <a:ext uri="{FF2B5EF4-FFF2-40B4-BE49-F238E27FC236}">
-                <a16:creationId xmlns:a16="http://schemas.microsoft.com/office/drawing/2014/main" id="{C4A00756-7FC9-4D85-8DBD-7EB35BDC1FEF}"/>
+                <a16:creationId xmlns:a16="http://schemas.microsoft.com/office/drawing/2014/main" id="{ACC60FE0-641F-4232-9CEC-3FF05D5F8390}"/>
               </a:ext>
             </a:extLst>
           </p:cNvPr>
@@ -13935,7 +13935,7 @@
                 <a:ea typeface="Google Sans Flex"/>
                 <a:cs typeface="Google Sans Flex"/>
               </a:rPr>
-              <a:t>Text, optional PDF or image → structured Gemini profile, quoted evidence and missing facts. 16 material families.</a:t>
+              <a:t>Verified Google/email accounts; buyer requests and seller offers; country filters; owner controls; 30-day expiry.</a:t>
             </a:r>
           </a:p>
         </p:txBody>
@@ -13945,7 +13945,7 @@
           <p:cNvPr id="90" name="">
             <a:extLst xmlns:a="http://schemas.openxmlformats.org/drawingml/2006/main">
               <a:ext uri="{FF2B5EF4-FFF2-40B4-BE49-F238E27FC236}">
-                <a16:creationId xmlns:a16="http://schemas.microsoft.com/office/drawing/2014/main" id="{91187DD0-CDA1-4C0B-AF57-CE240793C0D3}"/>
+                <a16:creationId xmlns:a16="http://schemas.microsoft.com/office/drawing/2014/main" id="{E1BEA6F5-A3EC-4C02-8610-C0CE4949E551}"/>
               </a:ext>
             </a:extLst>
           </p:cNvPr>
@@ -14001,7 +14001,7 @@
                 <a:ea typeface="Google Sans Flex"/>
                 <a:cs typeface="Google Sans Flex"/>
               </a:rPr>
-              <a:t>02 / CLEAR RECOVERY LEADS</a:t>
+              <a:t>02 / HYBRID RETRIEVAL</a:t>
             </a:r>
           </a:p>
         </p:txBody>
@@ -14011,7 +14011,7 @@
           <p:cNvPr id="91" name="">
             <a:extLst xmlns:a="http://schemas.openxmlformats.org/drawingml/2006/main">
               <a:ext uri="{FF2B5EF4-FFF2-40B4-BE49-F238E27FC236}">
-                <a16:creationId xmlns:a16="http://schemas.microsoft.com/office/drawing/2014/main" id="{E66A5A88-B463-47A9-8480-429510476A8A}"/>
+                <a16:creationId xmlns:a16="http://schemas.microsoft.com/office/drawing/2014/main" id="{FC567049-5AE1-4B51-87B4-3027AB0C4249}"/>
               </a:ext>
             </a:extLst>
           </p:cNvPr>
@@ -14067,7 +14067,7 @@
                 <a:ea typeface="Google Sans Flex"/>
                 <a:cs typeface="Google Sans Flex"/>
               </a:rPr>
-              <a:t>912 source-attributed India board records; worldwide open-map discovery. Five visible leads at a time.</a:t>
+              <a:t>Alias/IDF overlap + actual 768-dimensional Gemini vectors + curated process edges, fused by reciprocal rank.</a:t>
             </a:r>
           </a:p>
         </p:txBody>
@@ -14077,7 +14077,7 @@
           <p:cNvPr id="92" name="">
             <a:extLst xmlns:a="http://schemas.openxmlformats.org/drawingml/2006/main">
               <a:ext uri="{FF2B5EF4-FFF2-40B4-BE49-F238E27FC236}">
-                <a16:creationId xmlns:a16="http://schemas.microsoft.com/office/drawing/2014/main" id="{0BDFC1E1-C5D3-4023-8A8C-008FC517FCD9}"/>
+                <a16:creationId xmlns:a16="http://schemas.microsoft.com/office/drawing/2014/main" id="{25320F6C-6BD8-4320-AC9E-DDAC7605FA1B}"/>
               </a:ext>
             </a:extLst>
           </p:cNvPr>
@@ -14133,7 +14133,7 @@
                 <a:ea typeface="Google Sans Flex"/>
                 <a:cs typeface="Google Sans Flex"/>
               </a:rPr>
-              <a:t>03 / VERIFIABLE NEXT STEPS</a:t>
+              <a:t>03 / ACCEPTANCE PASSPORT</a:t>
             </a:r>
           </a:p>
         </p:txBody>
@@ -14143,7 +14143,7 @@
           <p:cNvPr id="93" name="">
             <a:extLst xmlns:a="http://schemas.openxmlformats.org/drawingml/2006/main">
               <a:ext uri="{FF2B5EF4-FFF2-40B4-BE49-F238E27FC236}">
-                <a16:creationId xmlns:a16="http://schemas.microsoft.com/office/drawing/2014/main" id="{CE40DD9B-C738-4C42-9FA0-332D36866EA0}"/>
+                <a16:creationId xmlns:a16="http://schemas.microsoft.com/office/drawing/2014/main" id="{5343FF34-59AB-4DF4-96F1-877CE930F5C3}"/>
               </a:ext>
             </a:extLst>
           </p:cNvPr>
@@ -14199,7 +14199,7 @@
                 <a:ea typeface="Google Sans Flex"/>
                 <a:cs typeface="Google Sans Flex"/>
               </a:rPr>
-              <a:t>Source documents, published contacts where available, saved leads, four confirmation checks and enquiry export.</a:t>
+              <a:t>12 typed facts with quotations, references and review state. Compatible-unit checks return pass, fail or unknown.</a:t>
             </a:r>
           </a:p>
         </p:txBody>
@@ -14209,7 +14209,7 @@
           <p:cNvPr id="94" name="">
             <a:extLst xmlns:a="http://schemas.openxmlformats.org/drawingml/2006/main">
               <a:ext uri="{FF2B5EF4-FFF2-40B4-BE49-F238E27FC236}">
-                <a16:creationId xmlns:a16="http://schemas.microsoft.com/office/drawing/2014/main" id="{FC3E2BAC-2BFE-48E6-8BA0-7C9006E065B1}"/>
+                <a16:creationId xmlns:a16="http://schemas.microsoft.com/office/drawing/2014/main" id="{87BF5275-3422-4B73-9BE4-DFADF26ED460}"/>
               </a:ext>
             </a:extLst>
           </p:cNvPr>
@@ -14265,7 +14265,7 @@
                 <a:ea typeface="Google Sans Flex"/>
                 <a:cs typeface="Google Sans Flex"/>
               </a:rPr>
-              <a:t>04 / ACCESSIBLE INTERACTION</a:t>
+              <a:t>04 / DECISIONS AND FOLLOW-THROUGH</a:t>
             </a:r>
           </a:p>
         </p:txBody>
@@ -14275,7 +14275,7 @@
           <p:cNvPr id="95" name="">
             <a:extLst xmlns:a="http://schemas.openxmlformats.org/drawingml/2006/main">
               <a:ext uri="{FF2B5EF4-FFF2-40B4-BE49-F238E27FC236}">
-                <a16:creationId xmlns:a16="http://schemas.microsoft.com/office/drawing/2014/main" id="{27652ABA-CE78-415F-9CAF-5ECE24356B9E}"/>
+                <a16:creationId xmlns:a16="http://schemas.microsoft.com/office/drawing/2014/main" id="{410DF289-3B80-493D-A696-9E8BF915DB7F}"/>
               </a:ext>
             </a:extLst>
           </p:cNvPr>
@@ -14331,7 +14331,7 @@
                 <a:ea typeface="Google Sans Flex"/>
                 <a:cs typeface="Google Sans Flex"/>
               </a:rPr>
-              <a:t>Recast Live assistant with validated app tools; English, Hindi, Marathi and Spanish controls; light/dark themes.</a:t>
+              <a:t>Conditioning investigations, sourced landed costs, private review/outcomes; public recovery directory and Recast assistant.</a:t>
             </a:r>
           </a:p>
         </p:txBody>
@@ -14341,7 +14341,7 @@
           <p:cNvPr id="96" name="">
             <a:extLst xmlns:a="http://schemas.openxmlformats.org/drawingml/2006/main">
               <a:ext uri="{FF2B5EF4-FFF2-40B4-BE49-F238E27FC236}">
-                <a16:creationId xmlns:a16="http://schemas.microsoft.com/office/drawing/2014/main" id="{CA6C0F35-91D2-44BC-92D7-2F15D5A519AF}"/>
+                <a16:creationId xmlns:a16="http://schemas.microsoft.com/office/drawing/2014/main" id="{079E1CAD-1BA3-429F-8995-739BBD1119B0}"/>
               </a:ext>
             </a:extLst>
           </p:cNvPr>
@@ -14397,7 +14397,7 @@
                 <a:ea typeface="Google Sans Flex"/>
                 <a:cs typeface="Google Sans Flex"/>
               </a:rPr>
-              <a:t>Public records are discovery evidence, not verified demand. Worldwide map coverage is best effort. Some diagnostics remain in English.</a:t>
+              <a:t>Vector search requires verified sign-in. Missing vectors trigger a labelled alias/process fallback. Public directory listings are not registered users.</a:t>
             </a:r>
           </a:p>
         </p:txBody>
@@ -14405,7 +14405,7 @@
     </p:spTree>
     <p:extLst>
       <p:ext uri="{BB962C8B-B14F-4D97-AF65-F5344CB8AC3E}">
-        <p14:creationId xmlns:p14="http://schemas.microsoft.com/office/powerpoint/2010/main" val="821758732"/>
+        <p14:creationId xmlns:p14="http://schemas.microsoft.com/office/powerpoint/2010/main" val="1045126625"/>
       </p:ext>
     </p:extLst>
   </p:cSld>
@@ -14429,7 +14429,7 @@
           <p:cNvPr id="92" name="Google Shape;92;p18">
             <a:extLst xmlns:a="http://schemas.openxmlformats.org/drawingml/2006/main">
               <a:ext uri="{FF2B5EF4-FFF2-40B4-BE49-F238E27FC236}">
-                <a16:creationId xmlns:a16="http://schemas.microsoft.com/office/drawing/2014/main" id="{BF59FA84-D3F0-4BEF-B030-66F83FFED1F8}"/>
+                <a16:creationId xmlns:a16="http://schemas.microsoft.com/office/drawing/2014/main" id="{043652B6-55BF-4EAB-AE4F-7674A78D440E}"/>
               </a:ext>
             </a:extLst>
           </p:cNvPr>
@@ -14439,7 +14439,7 @@
           <p:nvPr/>
         </p:nvPicPr>
         <p:blipFill rotWithShape="1">
-          <a:blip xmlns:r="http://schemas.openxmlformats.org/officeDocument/2006/relationships" xmlns:a="http://schemas.openxmlformats.org/drawingml/2006/main" r:embed="R8dd2bc7a9f814589">
+          <a:blip xmlns:r="http://schemas.openxmlformats.org/officeDocument/2006/relationships" xmlns:a="http://schemas.openxmlformats.org/drawingml/2006/main" r:embed="R058ced9e53a04bae">
             <a:alphaModFix/>
           </a:blip>
           <a:srcRect xmlns:a="http://schemas.openxmlformats.org/drawingml/2006/main" l="0" t="0" r="0" b="98001"/>
@@ -14463,7 +14463,7 @@
           <p:cNvPr id="93" name="Google Shape;93;p18">
             <a:extLst xmlns:a="http://schemas.openxmlformats.org/drawingml/2006/main">
               <a:ext uri="{FF2B5EF4-FFF2-40B4-BE49-F238E27FC236}">
-                <a16:creationId xmlns:a16="http://schemas.microsoft.com/office/drawing/2014/main" id="{4B459E60-EFDC-4230-9B90-FC9663099381}"/>
+                <a16:creationId xmlns:a16="http://schemas.microsoft.com/office/drawing/2014/main" id="{A0289D5F-7EF0-47BE-82D9-34DA3CD70084}"/>
               </a:ext>
             </a:extLst>
           </p:cNvPr>
@@ -14473,7 +14473,7 @@
           <p:nvPr/>
         </p:nvPicPr>
         <p:blipFill>
-          <a:blip xmlns:r="http://schemas.openxmlformats.org/officeDocument/2006/relationships" xmlns:a="http://schemas.openxmlformats.org/drawingml/2006/main" r:embed="R3477a941ff304119">
+          <a:blip xmlns:r="http://schemas.openxmlformats.org/officeDocument/2006/relationships" xmlns:a="http://schemas.openxmlformats.org/drawingml/2006/main" r:embed="Rdebcef3ac1204879">
             <a:alphaModFix/>
           </a:blip>
           <a:stretch xmlns:a="http://schemas.openxmlformats.org/drawingml/2006/main">
@@ -14498,7 +14498,7 @@
           <p:cNvPr id="94" name="Google Shape;94;p18">
             <a:extLst xmlns:a="http://schemas.openxmlformats.org/drawingml/2006/main">
               <a:ext uri="{FF2B5EF4-FFF2-40B4-BE49-F238E27FC236}">
-                <a16:creationId xmlns:a16="http://schemas.microsoft.com/office/drawing/2014/main" id="{36FDCE84-78F4-43B0-A551-39E412A08D3B}"/>
+                <a16:creationId xmlns:a16="http://schemas.microsoft.com/office/drawing/2014/main" id="{231F80F5-7B06-4C68-87A8-A639A3A9B7F0}"/>
               </a:ext>
             </a:extLst>
           </p:cNvPr>
@@ -14549,7 +14549,7 @@
           <p:cNvPr id="95" name="Google Shape;95;p18">
             <a:extLst xmlns:a="http://schemas.openxmlformats.org/drawingml/2006/main">
               <a:ext uri="{FF2B5EF4-FFF2-40B4-BE49-F238E27FC236}">
-                <a16:creationId xmlns:a16="http://schemas.microsoft.com/office/drawing/2014/main" id="{EEDE0DC3-3236-4CCB-B2BE-CBC3DC009098}"/>
+                <a16:creationId xmlns:a16="http://schemas.microsoft.com/office/drawing/2014/main" id="{F9A71EDD-B6D1-4E30-B1AB-70BC4A087314}"/>
               </a:ext>
             </a:extLst>
           </p:cNvPr>
@@ -14629,7 +14629,7 @@
           <p:cNvPr id="96" name="">
             <a:extLst xmlns:a="http://schemas.openxmlformats.org/drawingml/2006/main">
               <a:ext uri="{FF2B5EF4-FFF2-40B4-BE49-F238E27FC236}">
-                <a16:creationId xmlns:a16="http://schemas.microsoft.com/office/drawing/2014/main" id="{D5804315-08FE-4970-AF84-FE3272A4853A}"/>
+                <a16:creationId xmlns:a16="http://schemas.microsoft.com/office/drawing/2014/main" id="{9156A472-2152-4E47-8970-2FED723DB48F}"/>
               </a:ext>
             </a:extLst>
           </p:cNvPr>
@@ -14659,7 +14659,7 @@
           <p:cNvPr id="97" name="">
             <a:extLst xmlns:a="http://schemas.openxmlformats.org/drawingml/2006/main">
               <a:ext uri="{FF2B5EF4-FFF2-40B4-BE49-F238E27FC236}">
-                <a16:creationId xmlns:a16="http://schemas.microsoft.com/office/drawing/2014/main" id="{D4BAEAAA-6B09-4AB6-A06E-8A5DB8F28441}"/>
+                <a16:creationId xmlns:a16="http://schemas.microsoft.com/office/drawing/2014/main" id="{67C915BC-46BA-4BE2-B6B0-DC5612BDCB94}"/>
               </a:ext>
             </a:extLst>
           </p:cNvPr>
@@ -14743,7 +14743,7 @@
                 <a:ea typeface="Google Sans Flex"/>
                 <a:cs typeface="Google Sans Flex"/>
               </a:rPr>
-              <a:t>Material + city</a:t>
+              <a:t>Offer or requirement</a:t>
             </a:r>
           </a:p>
           <a:p xmlns:a="http://schemas.openxmlformats.org/drawingml/2006/main">
@@ -14766,7 +14766,7 @@
                 <a:ea typeface="Google Sans Flex"/>
                 <a:cs typeface="Google Sans Flex"/>
               </a:rPr>
-              <a:t>Optional document</a:t>
+              <a:t>Optional evidence</a:t>
             </a:r>
           </a:p>
         </p:txBody>
@@ -14776,7 +14776,7 @@
           <p:cNvPr id="98" name="">
             <a:extLst xmlns:a="http://schemas.openxmlformats.org/drawingml/2006/main">
               <a:ext uri="{FF2B5EF4-FFF2-40B4-BE49-F238E27FC236}">
-                <a16:creationId xmlns:a16="http://schemas.microsoft.com/office/drawing/2014/main" id="{9C899FA2-78C5-4F0E-B854-3CAC7819A9D5}"/>
+                <a16:creationId xmlns:a16="http://schemas.microsoft.com/office/drawing/2014/main" id="{7283218D-48D4-453E-B979-36C23B90F4D5}"/>
               </a:ext>
             </a:extLst>
           </p:cNvPr>
@@ -14806,7 +14806,7 @@
           <p:cNvPr id="99" name="">
             <a:extLst xmlns:a="http://schemas.openxmlformats.org/drawingml/2006/main">
               <a:ext uri="{FF2B5EF4-FFF2-40B4-BE49-F238E27FC236}">
-                <a16:creationId xmlns:a16="http://schemas.microsoft.com/office/drawing/2014/main" id="{99F7780C-502C-40E7-AF2E-DD9BC244D808}"/>
+                <a16:creationId xmlns:a16="http://schemas.microsoft.com/office/drawing/2014/main" id="{FFE8F5CF-4D5E-41C3-9761-747970A25ADF}"/>
               </a:ext>
             </a:extLst>
           </p:cNvPr>
@@ -14836,7 +14836,7 @@
           <p:cNvPr id="100" name="">
             <a:extLst xmlns:a="http://schemas.openxmlformats.org/drawingml/2006/main">
               <a:ext uri="{FF2B5EF4-FFF2-40B4-BE49-F238E27FC236}">
-                <a16:creationId xmlns:a16="http://schemas.microsoft.com/office/drawing/2014/main" id="{38D86A8F-5879-4268-86E5-B3E24AC8D178}"/>
+                <a16:creationId xmlns:a16="http://schemas.microsoft.com/office/drawing/2014/main" id="{EB48D505-9324-4564-A70A-1CC2316F4C6D}"/>
               </a:ext>
             </a:extLst>
           </p:cNvPr>
@@ -14892,7 +14892,7 @@
                 <a:ea typeface="Google Sans Flex"/>
                 <a:cs typeface="Google Sans Flex"/>
               </a:rPr>
-              <a:t>2  Extract</a:t>
+              <a:t>2  Retrieve</a:t>
             </a:r>
           </a:p>
           <a:p xmlns:a="http://schemas.openxmlformats.org/drawingml/2006/main">
@@ -14920,7 +14920,7 @@
                 <a:ea typeface="Google Sans Flex"/>
                 <a:cs typeface="Google Sans Flex"/>
               </a:rPr>
-              <a:t>Gemini profile</a:t>
+              <a:t>Aliases + vectors</a:t>
             </a:r>
           </a:p>
           <a:p xmlns:a="http://schemas.openxmlformats.org/drawingml/2006/main">
@@ -14943,7 +14943,7 @@
                 <a:ea typeface="Google Sans Flex"/>
                 <a:cs typeface="Google Sans Flex"/>
               </a:rPr>
-              <a:t>Unknown facts retained</a:t>
+              <a:t>Process edges / RRF</a:t>
             </a:r>
           </a:p>
         </p:txBody>
@@ -14953,7 +14953,7 @@
           <p:cNvPr id="101" name="">
             <a:extLst xmlns:a="http://schemas.openxmlformats.org/drawingml/2006/main">
               <a:ext uri="{FF2B5EF4-FFF2-40B4-BE49-F238E27FC236}">
-                <a16:creationId xmlns:a16="http://schemas.microsoft.com/office/drawing/2014/main" id="{73AB6182-9F7A-4472-8D87-A0880DB37014}"/>
+                <a16:creationId xmlns:a16="http://schemas.microsoft.com/office/drawing/2014/main" id="{CBC7022D-8465-48F3-980C-994DF136A91E}"/>
               </a:ext>
             </a:extLst>
           </p:cNvPr>
@@ -14983,7 +14983,7 @@
           <p:cNvPr id="102" name="">
             <a:extLst xmlns:a="http://schemas.openxmlformats.org/drawingml/2006/main">
               <a:ext uri="{FF2B5EF4-FFF2-40B4-BE49-F238E27FC236}">
-                <a16:creationId xmlns:a16="http://schemas.microsoft.com/office/drawing/2014/main" id="{FDF7A4CF-57D7-4388-9190-5937400D86D4}"/>
+                <a16:creationId xmlns:a16="http://schemas.microsoft.com/office/drawing/2014/main" id="{BDE4C993-1163-40B5-9D98-C4D64F8251B8}"/>
               </a:ext>
             </a:extLst>
           </p:cNvPr>
@@ -15013,7 +15013,7 @@
           <p:cNvPr id="103" name="">
             <a:extLst xmlns:a="http://schemas.openxmlformats.org/drawingml/2006/main">
               <a:ext uri="{FF2B5EF4-FFF2-40B4-BE49-F238E27FC236}">
-                <a16:creationId xmlns:a16="http://schemas.microsoft.com/office/drawing/2014/main" id="{627CCD77-6240-412F-A703-C8B8B6DF4905}"/>
+                <a16:creationId xmlns:a16="http://schemas.microsoft.com/office/drawing/2014/main" id="{F6ABFE98-8AFD-4C2A-A2D5-CD06B4CB18EC}"/>
               </a:ext>
             </a:extLst>
           </p:cNvPr>
@@ -15069,7 +15069,7 @@
                 <a:ea typeface="Google Sans Flex"/>
                 <a:cs typeface="Google Sans Flex"/>
               </a:rPr>
-              <a:t>3  Screen</a:t>
+              <a:t>3  Check</a:t>
             </a:r>
           </a:p>
           <a:p xmlns:a="http://schemas.openxmlformats.org/drawingml/2006/main">
@@ -15097,7 +15097,7 @@
                 <a:ea typeface="Google Sans Flex"/>
                 <a:cs typeface="Google Sans Flex"/>
               </a:rPr>
-              <a:t>Family + route checks</a:t>
+              <a:t>Typed pass/fail/unknown</a:t>
             </a:r>
           </a:p>
           <a:p xmlns:a="http://schemas.openxmlformats.org/drawingml/2006/main">
@@ -15120,7 +15120,7 @@
                 <a:ea typeface="Google Sans Flex"/>
                 <a:cs typeface="Google Sans Flex"/>
               </a:rPr>
-              <a:t>State/district order</a:t>
+              <a:t>Gemini explanation</a:t>
             </a:r>
           </a:p>
         </p:txBody>
@@ -15130,7 +15130,7 @@
           <p:cNvPr id="104" name="">
             <a:extLst xmlns:a="http://schemas.openxmlformats.org/drawingml/2006/main">
               <a:ext uri="{FF2B5EF4-FFF2-40B4-BE49-F238E27FC236}">
-                <a16:creationId xmlns:a16="http://schemas.microsoft.com/office/drawing/2014/main" id="{781F40B2-3A63-4737-B10C-39EE0C8E0B9F}"/>
+                <a16:creationId xmlns:a16="http://schemas.microsoft.com/office/drawing/2014/main" id="{556A7E86-DEEC-4DBF-A5FF-9A87A278B514}"/>
               </a:ext>
             </a:extLst>
           </p:cNvPr>
@@ -15160,7 +15160,7 @@
           <p:cNvPr id="105" name="">
             <a:extLst xmlns:a="http://schemas.openxmlformats.org/drawingml/2006/main">
               <a:ext uri="{FF2B5EF4-FFF2-40B4-BE49-F238E27FC236}">
-                <a16:creationId xmlns:a16="http://schemas.microsoft.com/office/drawing/2014/main" id="{8CCFE00D-C99F-4C79-80B5-1487468C836C}"/>
+                <a16:creationId xmlns:a16="http://schemas.microsoft.com/office/drawing/2014/main" id="{10FD085C-1B24-4969-B040-E9CB5BC40155}"/>
               </a:ext>
             </a:extLst>
           </p:cNvPr>
@@ -15190,7 +15190,7 @@
           <p:cNvPr id="106" name="">
             <a:extLst xmlns:a="http://schemas.openxmlformats.org/drawingml/2006/main">
               <a:ext uri="{FF2B5EF4-FFF2-40B4-BE49-F238E27FC236}">
-                <a16:creationId xmlns:a16="http://schemas.microsoft.com/office/drawing/2014/main" id="{0275EC6E-78B3-431C-AC1A-8B7CC7A2C77B}"/>
+                <a16:creationId xmlns:a16="http://schemas.microsoft.com/office/drawing/2014/main" id="{5074F5C6-B574-4A37-8AF2-36D1E18A6CB7}"/>
               </a:ext>
             </a:extLst>
           </p:cNvPr>
@@ -15246,7 +15246,7 @@
                 <a:ea typeface="Google Sans Flex"/>
                 <a:cs typeface="Google Sans Flex"/>
               </a:rPr>
-              <a:t>4  Review</a:t>
+              <a:t>4  Investigate</a:t>
             </a:r>
           </a:p>
           <a:p xmlns:a="http://schemas.openxmlformats.org/drawingml/2006/main">
@@ -15274,7 +15274,7 @@
                 <a:ea typeface="Google Sans Flex"/>
                 <a:cs typeface="Google Sans Flex"/>
               </a:rPr>
-              <a:t>Gemini fit notes</a:t>
+              <a:t>Supported operations</a:t>
             </a:r>
           </a:p>
           <a:p xmlns:a="http://schemas.openxmlformats.org/drawingml/2006/main">
@@ -15297,7 +15297,7 @@
                 <a:ea typeface="Google Sans Flex"/>
                 <a:cs typeface="Google Sans Flex"/>
               </a:rPr>
-              <a:t>Source-linked gaps</a:t>
+              <a:t>Quotes + usable yield</a:t>
             </a:r>
           </a:p>
         </p:txBody>
@@ -15307,7 +15307,7 @@
           <p:cNvPr id="107" name="">
             <a:extLst xmlns:a="http://schemas.openxmlformats.org/drawingml/2006/main">
               <a:ext uri="{FF2B5EF4-FFF2-40B4-BE49-F238E27FC236}">
-                <a16:creationId xmlns:a16="http://schemas.microsoft.com/office/drawing/2014/main" id="{F31D1C55-0760-41A6-9B35-C473457840E7}"/>
+                <a16:creationId xmlns:a16="http://schemas.microsoft.com/office/drawing/2014/main" id="{02847420-2283-4CE3-9F75-01879D171975}"/>
               </a:ext>
             </a:extLst>
           </p:cNvPr>
@@ -15337,7 +15337,7 @@
           <p:cNvPr id="108" name="">
             <a:extLst xmlns:a="http://schemas.openxmlformats.org/drawingml/2006/main">
               <a:ext uri="{FF2B5EF4-FFF2-40B4-BE49-F238E27FC236}">
-                <a16:creationId xmlns:a16="http://schemas.microsoft.com/office/drawing/2014/main" id="{447F8644-B7A8-417C-89D9-D88CBE1FCABD}"/>
+                <a16:creationId xmlns:a16="http://schemas.microsoft.com/office/drawing/2014/main" id="{D531C894-4F77-4073-9F78-D08CFE48CF74}"/>
               </a:ext>
             </a:extLst>
           </p:cNvPr>
@@ -15393,7 +15393,7 @@
                 <a:ea typeface="Google Sans Flex"/>
                 <a:cs typeface="Google Sans Flex"/>
               </a:rPr>
-              <a:t>5  Verify and enquire</a:t>
+              <a:t>5  Confirm with the counterpart</a:t>
             </a:r>
           </a:p>
           <a:p xmlns:a="http://schemas.openxmlformats.org/drawingml/2006/main">
@@ -15416,7 +15416,7 @@
                 <a:ea typeface="Google Sans Flex"/>
                 <a:cs typeface="Google Sans Flex"/>
               </a:rPr>
-              <a:t>Composition → current authorization → buyer acceptance/capacity → written quote</a:t>
+              <a:t>Sample trial and retest → current authorization → written acceptance → commercial terms</a:t>
             </a:r>
           </a:p>
         </p:txBody>
@@ -15426,7 +15426,7 @@
           <p:cNvPr id="109" name="">
             <a:extLst xmlns:a="http://schemas.openxmlformats.org/drawingml/2006/main">
               <a:ext uri="{FF2B5EF4-FFF2-40B4-BE49-F238E27FC236}">
-                <a16:creationId xmlns:a16="http://schemas.microsoft.com/office/drawing/2014/main" id="{A598D102-058E-4D54-949D-A7AC18B9E720}"/>
+                <a16:creationId xmlns:a16="http://schemas.microsoft.com/office/drawing/2014/main" id="{6FAD74EA-E54B-49FB-A922-66357AF81176}"/>
               </a:ext>
             </a:extLst>
           </p:cNvPr>
@@ -15490,7 +15490,7 @@
     </p:spTree>
     <p:extLst>
       <p:ext uri="{BB962C8B-B14F-4D97-AF65-F5344CB8AC3E}">
-        <p14:creationId xmlns:p14="http://schemas.microsoft.com/office/powerpoint/2010/main" val="1328523821"/>
+        <p14:creationId xmlns:p14="http://schemas.microsoft.com/office/powerpoint/2010/main" val="1897318616"/>
       </p:ext>
     </p:extLst>
   </p:cSld>
@@ -15514,7 +15514,7 @@
           <p:cNvPr id="100" name="Google Shape;100;p19">
             <a:extLst xmlns:a="http://schemas.openxmlformats.org/drawingml/2006/main">
               <a:ext uri="{FF2B5EF4-FFF2-40B4-BE49-F238E27FC236}">
-                <a16:creationId xmlns:a16="http://schemas.microsoft.com/office/drawing/2014/main" id="{CAD9A716-A4B4-449B-89F6-A22513FD0699}"/>
+                <a16:creationId xmlns:a16="http://schemas.microsoft.com/office/drawing/2014/main" id="{5BF7F355-316B-4565-9B0A-F67E82515EBE}"/>
               </a:ext>
             </a:extLst>
           </p:cNvPr>
@@ -15524,7 +15524,7 @@
           <p:nvPr/>
         </p:nvPicPr>
         <p:blipFill rotWithShape="1">
-          <a:blip xmlns:r="http://schemas.openxmlformats.org/officeDocument/2006/relationships" xmlns:a="http://schemas.openxmlformats.org/drawingml/2006/main" r:embed="Re6e407f0b38b4c41">
+          <a:blip xmlns:r="http://schemas.openxmlformats.org/officeDocument/2006/relationships" xmlns:a="http://schemas.openxmlformats.org/drawingml/2006/main" r:embed="R747c422edc234b7b">
             <a:alphaModFix/>
           </a:blip>
           <a:srcRect xmlns:a="http://schemas.openxmlformats.org/drawingml/2006/main" l="0" t="0" r="0" b="98001"/>
@@ -15548,7 +15548,7 @@
           <p:cNvPr id="101" name="Google Shape;101;p19">
             <a:extLst xmlns:a="http://schemas.openxmlformats.org/drawingml/2006/main">
               <a:ext uri="{FF2B5EF4-FFF2-40B4-BE49-F238E27FC236}">
-                <a16:creationId xmlns:a16="http://schemas.microsoft.com/office/drawing/2014/main" id="{F9BDC404-B8D5-4882-9F26-36B2FC3E83B2}"/>
+                <a16:creationId xmlns:a16="http://schemas.microsoft.com/office/drawing/2014/main" id="{A9ED0352-E6F0-4BD2-95FA-156F1EAF5B33}"/>
               </a:ext>
             </a:extLst>
           </p:cNvPr>
@@ -15558,7 +15558,7 @@
           <p:nvPr/>
         </p:nvPicPr>
         <p:blipFill>
-          <a:blip xmlns:r="http://schemas.openxmlformats.org/officeDocument/2006/relationships" xmlns:a="http://schemas.openxmlformats.org/drawingml/2006/main" r:embed="R1d8fecc89da448ed">
+          <a:blip xmlns:r="http://schemas.openxmlformats.org/officeDocument/2006/relationships" xmlns:a="http://schemas.openxmlformats.org/drawingml/2006/main" r:embed="R2ac69c359b8c4a7a">
             <a:alphaModFix/>
           </a:blip>
           <a:stretch xmlns:a="http://schemas.openxmlformats.org/drawingml/2006/main">
@@ -15583,7 +15583,7 @@
           <p:cNvPr id="102" name="Google Shape;102;p19">
             <a:extLst xmlns:a="http://schemas.openxmlformats.org/drawingml/2006/main">
               <a:ext uri="{FF2B5EF4-FFF2-40B4-BE49-F238E27FC236}">
-                <a16:creationId xmlns:a16="http://schemas.microsoft.com/office/drawing/2014/main" id="{02C3C058-85FB-47F0-8610-FFA06EB059AF}"/>
+                <a16:creationId xmlns:a16="http://schemas.microsoft.com/office/drawing/2014/main" id="{48468EEB-BC8B-4133-895F-D507A6C5E532}"/>
               </a:ext>
             </a:extLst>
           </p:cNvPr>
@@ -15634,7 +15634,7 @@
           <p:cNvPr id="103" name="Google Shape;103;p19">
             <a:extLst xmlns:a="http://schemas.openxmlformats.org/drawingml/2006/main">
               <a:ext uri="{FF2B5EF4-FFF2-40B4-BE49-F238E27FC236}">
-                <a16:creationId xmlns:a16="http://schemas.microsoft.com/office/drawing/2014/main" id="{7EA5C023-5C40-4F37-8DB0-10CFF81E1ACA}"/>
+                <a16:creationId xmlns:a16="http://schemas.microsoft.com/office/drawing/2014/main" id="{F50201CD-EC14-4DB1-A39F-CD7A741566FC}"/>
               </a:ext>
             </a:extLst>
           </p:cNvPr>
@@ -15714,7 +15714,7 @@
           <p:cNvPr id="104" name="">
             <a:extLst xmlns:a="http://schemas.openxmlformats.org/drawingml/2006/main">
               <a:ext uri="{FF2B5EF4-FFF2-40B4-BE49-F238E27FC236}">
-                <a16:creationId xmlns:a16="http://schemas.microsoft.com/office/drawing/2014/main" id="{B9634C02-23C9-495C-AA74-392E61A0E43D}"/>
+                <a16:creationId xmlns:a16="http://schemas.microsoft.com/office/drawing/2014/main" id="{6E61391E-F1D7-4071-85D9-2F204D7EC7A0}"/>
               </a:ext>
             </a:extLst>
           </p:cNvPr>
@@ -15724,7 +15724,7 @@
           <p:nvPr/>
         </p:nvPicPr>
         <p:blipFill>
-          <a:blip xmlns:r="http://schemas.openxmlformats.org/officeDocument/2006/relationships" xmlns:a="http://schemas.openxmlformats.org/drawingml/2006/main" r:embed="Rd2ae776b6ff34a9f"/>
+          <a:blip xmlns:r="http://schemas.openxmlformats.org/officeDocument/2006/relationships" xmlns:a="http://schemas.openxmlformats.org/drawingml/2006/main" r:embed="Rb7b79ce4498d455b"/>
           <a:stretch xmlns:a="http://schemas.openxmlformats.org/drawingml/2006/main"/>
         </p:blipFill>
         <p:spPr>
@@ -15742,7 +15742,7 @@
           <p:cNvPr id="105" name="">
             <a:extLst xmlns:a="http://schemas.openxmlformats.org/drawingml/2006/main">
               <a:ext uri="{FF2B5EF4-FFF2-40B4-BE49-F238E27FC236}">
-                <a16:creationId xmlns:a16="http://schemas.microsoft.com/office/drawing/2014/main" id="{E94EAF24-E2BB-461E-ADC5-D45D94ED476E}"/>
+                <a16:creationId xmlns:a16="http://schemas.microsoft.com/office/drawing/2014/main" id="{43E3874B-307A-4B77-9C8C-19710C2F6C03}"/>
               </a:ext>
             </a:extLst>
           </p:cNvPr>
@@ -15808,7 +15808,7 @@
           <p:cNvPr id="106" name="">
             <a:extLst xmlns:a="http://schemas.openxmlformats.org/drawingml/2006/main">
               <a:ext uri="{FF2B5EF4-FFF2-40B4-BE49-F238E27FC236}">
-                <a16:creationId xmlns:a16="http://schemas.microsoft.com/office/drawing/2014/main" id="{F686F4AF-27C1-472A-867B-E10DF8D37980}"/>
+                <a16:creationId xmlns:a16="http://schemas.microsoft.com/office/drawing/2014/main" id="{C39E2E06-FA65-4CD6-A8C6-0E98BFF89373}"/>
               </a:ext>
             </a:extLst>
           </p:cNvPr>
@@ -15864,7 +15864,7 @@
                 <a:ea typeface="Google Sans Flex"/>
                 <a:cs typeface="Google Sans Flex"/>
               </a:rPr>
-              <a:t>1. Describe your material</a:t>
+              <a:t>1. Compare meaning</a:t>
             </a:r>
           </a:p>
           <a:p xmlns:a="http://schemas.openxmlformats.org/drawingml/2006/main">
@@ -15892,7 +15892,7 @@
                 <a:ea typeface="Google Sans Flex"/>
                 <a:cs typeface="Google Sans Flex"/>
               </a:rPr>
-              <a:t>2. Review the profile</a:t>
+              <a:t>2. Inspect each condition</a:t>
             </a:r>
           </a:p>
           <a:p xmlns:a="http://schemas.openxmlformats.org/drawingml/2006/main">
@@ -15920,7 +15920,7 @@
                 <a:ea typeface="Google Sans Flex"/>
                 <a:cs typeface="Google Sans Flex"/>
               </a:rPr>
-              <a:t>3. Find recovery leads</a:t>
+              <a:t>3. Resolve evidence gaps</a:t>
             </a:r>
           </a:p>
         </p:txBody>
@@ -15930,7 +15930,7 @@
           <p:cNvPr id="107" name="">
             <a:extLst xmlns:a="http://schemas.openxmlformats.org/drawingml/2006/main">
               <a:ext uri="{FF2B5EF4-FFF2-40B4-BE49-F238E27FC236}">
-                <a16:creationId xmlns:a16="http://schemas.microsoft.com/office/drawing/2014/main" id="{551C44D2-EA6A-4E10-AD60-33FE010216D1}"/>
+                <a16:creationId xmlns:a16="http://schemas.microsoft.com/office/drawing/2014/main" id="{4766D18F-8580-48D9-AA01-C936CC1A531D}"/>
               </a:ext>
             </a:extLst>
           </p:cNvPr>
@@ -15986,7 +15986,7 @@
                 <a:ea typeface="Google Sans Flex"/>
                 <a:cs typeface="Google Sans Flex"/>
               </a:rPr>
-              <a:t>Actual prototype, not a wireframe. AI walkthrough captured using the private local connection; public site uses Firebase AI Logic.</a:t>
+              <a:t>Actual deployed interface. Illustrative material and counterpart specifications. Facts retain review and source status.</a:t>
             </a:r>
           </a:p>
         </p:txBody>
@@ -15994,7 +15994,7 @@
     </p:spTree>
     <p:extLst>
       <p:ext uri="{BB962C8B-B14F-4D97-AF65-F5344CB8AC3E}">
-        <p14:creationId xmlns:p14="http://schemas.microsoft.com/office/powerpoint/2010/main" val="214909670"/>
+        <p14:creationId xmlns:p14="http://schemas.microsoft.com/office/powerpoint/2010/main" val="2092324710"/>
       </p:ext>
     </p:extLst>
   </p:cSld>
@@ -16018,7 +16018,7 @@
           <p:cNvPr id="122" name="">
             <a:extLst xmlns:a="http://schemas.openxmlformats.org/drawingml/2006/main">
               <a:ext uri="{FF2B5EF4-FFF2-40B4-BE49-F238E27FC236}">
-                <a16:creationId xmlns:a16="http://schemas.microsoft.com/office/drawing/2014/main" id="{F7E851CE-EF57-433E-96E2-6BF036B37534}"/>
+                <a16:creationId xmlns:a16="http://schemas.microsoft.com/office/drawing/2014/main" id="{62932D20-0B8A-4E79-BCC7-FF4DA0EE0413}"/>
               </a:ext>
             </a:extLst>
           </p:cNvPr>
@@ -16030,8 +16030,8 @@
         </p:nvCxnSpPr>
         <p:spPr>
           <a:xfrm xmlns:a="http://schemas.openxmlformats.org/drawingml/2006/main">
-            <a:off x="4572000" y="2171700"/>
-            <a:ext cx="2952750" cy="638175"/>
+            <a:off x="4572000" y="2143125"/>
+            <a:ext cx="2952750" cy="619125"/>
           </a:xfrm>
           <a:prstGeom xmlns:a="http://schemas.openxmlformats.org/drawingml/2006/main" prst="straightConnector1">
             <a:avLst/>
@@ -16050,7 +16050,7 @@
           <p:cNvPr id="121" name="">
             <a:extLst xmlns:a="http://schemas.openxmlformats.org/drawingml/2006/main">
               <a:ext uri="{FF2B5EF4-FFF2-40B4-BE49-F238E27FC236}">
-                <a16:creationId xmlns:a16="http://schemas.microsoft.com/office/drawing/2014/main" id="{12F1A524-9ABB-48A8-9F00-374230E10F22}"/>
+                <a16:creationId xmlns:a16="http://schemas.microsoft.com/office/drawing/2014/main" id="{357FB6D4-C47A-4531-81D0-5A0A7A9FD595}"/>
               </a:ext>
             </a:extLst>
           </p:cNvPr>
@@ -16062,8 +16062,8 @@
         </p:nvCxnSpPr>
         <p:spPr>
           <a:xfrm xmlns:a="http://schemas.openxmlformats.org/drawingml/2006/main">
-            <a:off x="4572000" y="2171700"/>
-            <a:ext cx="0" cy="638175"/>
+            <a:off x="4572000" y="2143125"/>
+            <a:ext cx="0" cy="619125"/>
           </a:xfrm>
           <a:prstGeom xmlns:a="http://schemas.openxmlformats.org/drawingml/2006/main" prst="straightConnector1">
             <a:avLst/>
@@ -16082,7 +16082,7 @@
           <p:cNvPr id="120" name="">
             <a:extLst xmlns:a="http://schemas.openxmlformats.org/drawingml/2006/main">
               <a:ext uri="{FF2B5EF4-FFF2-40B4-BE49-F238E27FC236}">
-                <a16:creationId xmlns:a16="http://schemas.microsoft.com/office/drawing/2014/main" id="{CDC31ACA-28CD-4BEE-A25C-97D79B5A76CC}"/>
+                <a16:creationId xmlns:a16="http://schemas.microsoft.com/office/drawing/2014/main" id="{993C0FC7-AAD0-40BF-80FF-1F223584FE0E}"/>
               </a:ext>
             </a:extLst>
           </p:cNvPr>
@@ -16094,8 +16094,8 @@
         </p:nvCxnSpPr>
         <p:spPr>
           <a:xfrm xmlns:a="http://schemas.openxmlformats.org/drawingml/2006/main" flipH="1">
-            <a:off x="1619250" y="2171700"/>
-            <a:ext cx="2952750" cy="638175"/>
+            <a:off x="1619250" y="2143125"/>
+            <a:ext cx="2952750" cy="619125"/>
           </a:xfrm>
           <a:prstGeom xmlns:a="http://schemas.openxmlformats.org/drawingml/2006/main" prst="straightConnector1">
             <a:avLst/>
@@ -16114,7 +16114,7 @@
           <p:cNvPr id="108" name="Google Shape;108;p20">
             <a:extLst xmlns:a="http://schemas.openxmlformats.org/drawingml/2006/main">
               <a:ext uri="{FF2B5EF4-FFF2-40B4-BE49-F238E27FC236}">
-                <a16:creationId xmlns:a16="http://schemas.microsoft.com/office/drawing/2014/main" id="{B82860EB-3C7B-4B98-B6FD-746C9A7A8F49}"/>
+                <a16:creationId xmlns:a16="http://schemas.microsoft.com/office/drawing/2014/main" id="{F625D423-71EC-4DD1-A07D-9CBA938A2B7E}"/>
               </a:ext>
             </a:extLst>
           </p:cNvPr>
@@ -16124,7 +16124,7 @@
           <p:nvPr/>
         </p:nvPicPr>
         <p:blipFill rotWithShape="1">
-          <a:blip xmlns:r="http://schemas.openxmlformats.org/officeDocument/2006/relationships" xmlns:a="http://schemas.openxmlformats.org/drawingml/2006/main" r:embed="R37417b3020db477c">
+          <a:blip xmlns:r="http://schemas.openxmlformats.org/officeDocument/2006/relationships" xmlns:a="http://schemas.openxmlformats.org/drawingml/2006/main" r:embed="R034e3898ab284e6e">
             <a:alphaModFix/>
           </a:blip>
           <a:srcRect xmlns:a="http://schemas.openxmlformats.org/drawingml/2006/main" l="0" t="0" r="0" b="98001"/>
@@ -16148,7 +16148,7 @@
           <p:cNvPr id="109" name="Google Shape;109;p20">
             <a:extLst xmlns:a="http://schemas.openxmlformats.org/drawingml/2006/main">
               <a:ext uri="{FF2B5EF4-FFF2-40B4-BE49-F238E27FC236}">
-                <a16:creationId xmlns:a16="http://schemas.microsoft.com/office/drawing/2014/main" id="{C1C09BC9-E278-43C2-806D-A524F8F949E3}"/>
+                <a16:creationId xmlns:a16="http://schemas.microsoft.com/office/drawing/2014/main" id="{4797018F-4739-41ED-8488-2FE8DB55ADB4}"/>
               </a:ext>
             </a:extLst>
           </p:cNvPr>
@@ -16158,7 +16158,7 @@
           <p:nvPr/>
         </p:nvPicPr>
         <p:blipFill>
-          <a:blip xmlns:r="http://schemas.openxmlformats.org/officeDocument/2006/relationships" xmlns:a="http://schemas.openxmlformats.org/drawingml/2006/main" r:embed="R015556ec906f4037">
+          <a:blip xmlns:r="http://schemas.openxmlformats.org/officeDocument/2006/relationships" xmlns:a="http://schemas.openxmlformats.org/drawingml/2006/main" r:embed="R7a7e4ffa6adb4d3e">
             <a:alphaModFix/>
           </a:blip>
           <a:stretch xmlns:a="http://schemas.openxmlformats.org/drawingml/2006/main">
@@ -16183,7 +16183,7 @@
           <p:cNvPr id="110" name="Google Shape;110;p20">
             <a:extLst xmlns:a="http://schemas.openxmlformats.org/drawingml/2006/main">
               <a:ext uri="{FF2B5EF4-FFF2-40B4-BE49-F238E27FC236}">
-                <a16:creationId xmlns:a16="http://schemas.microsoft.com/office/drawing/2014/main" id="{80B292F2-A369-411D-AEA7-0C2603057B87}"/>
+                <a16:creationId xmlns:a16="http://schemas.microsoft.com/office/drawing/2014/main" id="{F0ABB1AE-6DEF-452C-92BB-76D00B3CF874}"/>
               </a:ext>
             </a:extLst>
           </p:cNvPr>
@@ -16234,7 +16234,7 @@
           <p:cNvPr id="111" name="Google Shape;111;p20">
             <a:extLst xmlns:a="http://schemas.openxmlformats.org/drawingml/2006/main">
               <a:ext uri="{FF2B5EF4-FFF2-40B4-BE49-F238E27FC236}">
-                <a16:creationId xmlns:a16="http://schemas.microsoft.com/office/drawing/2014/main" id="{C62AD285-EC74-4C36-9DE0-2611F1D70B32}"/>
+                <a16:creationId xmlns:a16="http://schemas.microsoft.com/office/drawing/2014/main" id="{4EBFEB74-823F-49F0-B83B-2F563E127EA1}"/>
               </a:ext>
             </a:extLst>
           </p:cNvPr>
@@ -16314,7 +16314,7 @@
           <p:cNvPr id="112" name="">
             <a:extLst xmlns:a="http://schemas.openxmlformats.org/drawingml/2006/main">
               <a:ext uri="{FF2B5EF4-FFF2-40B4-BE49-F238E27FC236}">
-                <a16:creationId xmlns:a16="http://schemas.microsoft.com/office/drawing/2014/main" id="{DC9F60F7-AB24-499F-ACAD-F4619E3A0BE2}"/>
+                <a16:creationId xmlns:a16="http://schemas.microsoft.com/office/drawing/2014/main" id="{63E0DA5D-6F70-4F66-8A1F-BC9137C51FA4}"/>
               </a:ext>
             </a:extLst>
           </p:cNvPr>
@@ -16325,8 +16325,8 @@
         </p:nvSpPr>
         <p:spPr>
           <a:xfrm xmlns:a="http://schemas.openxmlformats.org/drawingml/2006/main">
-            <a:off x="2857500" y="1333500"/>
-            <a:ext cx="3429000" cy="838200"/>
+            <a:off x="2619375" y="1304925"/>
+            <a:ext cx="3905250" cy="838200"/>
           </a:xfrm>
           <a:prstGeom xmlns:a="http://schemas.openxmlformats.org/drawingml/2006/main" prst="rect">
             <a:avLst/>
@@ -16344,7 +16344,7 @@
           <p:cNvPr id="113" name="">
             <a:extLst xmlns:a="http://schemas.openxmlformats.org/drawingml/2006/main">
               <a:ext uri="{FF2B5EF4-FFF2-40B4-BE49-F238E27FC236}">
-                <a16:creationId xmlns:a16="http://schemas.microsoft.com/office/drawing/2014/main" id="{08665FE3-55F4-4CD3-B1EA-4C4C0A8DF225}"/>
+                <a16:creationId xmlns:a16="http://schemas.microsoft.com/office/drawing/2014/main" id="{896B9D4C-9037-41EF-9955-86FCF951790D}"/>
               </a:ext>
             </a:extLst>
           </p:cNvPr>
@@ -16355,8 +16355,8 @@
         </p:nvSpPr>
         <p:spPr>
           <a:xfrm xmlns:a="http://schemas.openxmlformats.org/drawingml/2006/main">
-            <a:off x="2990850" y="1466850"/>
-            <a:ext cx="3162300" cy="571500"/>
+            <a:off x="2752725" y="1438275"/>
+            <a:ext cx="3638550" cy="571500"/>
           </a:xfrm>
           <a:prstGeom xmlns:a="http://schemas.openxmlformats.org/drawingml/2006/main" prst="rect">
             <a:avLst/>
@@ -16423,7 +16423,7 @@
                 <a:ea typeface="Google Sans Flex"/>
                 <a:cs typeface="Google Sans Flex"/>
               </a:rPr>
-              <a:t>Static app + validated app tools</a:t>
+              <a:t>Auth + evidence passport + acceptance checks</a:t>
             </a:r>
           </a:p>
         </p:txBody>
@@ -16433,7 +16433,7 @@
           <p:cNvPr id="114" name="">
             <a:extLst xmlns:a="http://schemas.openxmlformats.org/drawingml/2006/main">
               <a:ext uri="{FF2B5EF4-FFF2-40B4-BE49-F238E27FC236}">
-                <a16:creationId xmlns:a16="http://schemas.microsoft.com/office/drawing/2014/main" id="{C80E29E1-1578-42C1-93D7-B8734DD398D1}"/>
+                <a16:creationId xmlns:a16="http://schemas.microsoft.com/office/drawing/2014/main" id="{468213D2-0936-4775-BBCE-F0977ADDC8AB}"/>
               </a:ext>
             </a:extLst>
           </p:cNvPr>
@@ -16444,7 +16444,7 @@
         </p:nvSpPr>
         <p:spPr>
           <a:xfrm xmlns:a="http://schemas.openxmlformats.org/drawingml/2006/main">
-            <a:off x="285750" y="2809875"/>
+            <a:off x="285750" y="2762250"/>
             <a:ext cx="2667000" cy="1114425"/>
           </a:xfrm>
           <a:prstGeom xmlns:a="http://schemas.openxmlformats.org/drawingml/2006/main" prst="rect">
@@ -16463,7 +16463,7 @@
           <p:cNvPr id="115" name="">
             <a:extLst xmlns:a="http://schemas.openxmlformats.org/drawingml/2006/main">
               <a:ext uri="{FF2B5EF4-FFF2-40B4-BE49-F238E27FC236}">
-                <a16:creationId xmlns:a16="http://schemas.microsoft.com/office/drawing/2014/main" id="{6710BE82-BC87-48AE-AFBD-B7A5EA18FD30}"/>
+                <a16:creationId xmlns:a16="http://schemas.microsoft.com/office/drawing/2014/main" id="{6463466A-1528-4135-8E4F-4A4F9B755340}"/>
               </a:ext>
             </a:extLst>
           </p:cNvPr>
@@ -16474,7 +16474,7 @@
         </p:nvSpPr>
         <p:spPr>
           <a:xfrm xmlns:a="http://schemas.openxmlformats.org/drawingml/2006/main">
-            <a:off x="419100" y="2943225"/>
+            <a:off x="419100" y="2895600"/>
             <a:ext cx="2400300" cy="847725"/>
           </a:xfrm>
           <a:prstGeom xmlns:a="http://schemas.openxmlformats.org/drawingml/2006/main" prst="rect">
@@ -16542,7 +16542,7 @@
                 <a:ea typeface="Google Sans Flex"/>
                 <a:cs typeface="Google Sans Flex"/>
               </a:rPr>
-              <a:t>Read-only catalog</a:t>
+              <a:t>Listings, private profiles</a:t>
             </a:r>
           </a:p>
           <a:p xmlns:a="http://schemas.openxmlformats.org/drawingml/2006/main">
@@ -16565,7 +16565,7 @@
                 <a:ea typeface="Google Sans Flex"/>
                 <a:cs typeface="Google Sans Flex"/>
               </a:rPr>
-              <a:t>912 source-linked records</a:t>
+              <a:t>Reviews + quota counters</a:t>
             </a:r>
           </a:p>
         </p:txBody>
@@ -16575,7 +16575,7 @@
           <p:cNvPr id="116" name="">
             <a:extLst xmlns:a="http://schemas.openxmlformats.org/drawingml/2006/main">
               <a:ext uri="{FF2B5EF4-FFF2-40B4-BE49-F238E27FC236}">
-                <a16:creationId xmlns:a16="http://schemas.microsoft.com/office/drawing/2014/main" id="{283E3D94-9C3F-4798-BBBD-0F85ACF0F4FA}"/>
+                <a16:creationId xmlns:a16="http://schemas.microsoft.com/office/drawing/2014/main" id="{9ACA0385-03CD-4FFB-A820-B8A423C6120C}"/>
               </a:ext>
             </a:extLst>
           </p:cNvPr>
@@ -16586,7 +16586,7 @@
         </p:nvSpPr>
         <p:spPr>
           <a:xfrm xmlns:a="http://schemas.openxmlformats.org/drawingml/2006/main">
-            <a:off x="3238500" y="2809875"/>
+            <a:off x="3238500" y="2762250"/>
             <a:ext cx="2667000" cy="1114425"/>
           </a:xfrm>
           <a:prstGeom xmlns:a="http://schemas.openxmlformats.org/drawingml/2006/main" prst="rect">
@@ -16605,7 +16605,7 @@
           <p:cNvPr id="117" name="">
             <a:extLst xmlns:a="http://schemas.openxmlformats.org/drawingml/2006/main">
               <a:ext uri="{FF2B5EF4-FFF2-40B4-BE49-F238E27FC236}">
-                <a16:creationId xmlns:a16="http://schemas.microsoft.com/office/drawing/2014/main" id="{7053B128-D80F-4B29-BA60-5CA86EA3BBCE}"/>
+                <a16:creationId xmlns:a16="http://schemas.microsoft.com/office/drawing/2014/main" id="{B697743C-CCC7-4E7C-A0A2-27FC9FF31958}"/>
               </a:ext>
             </a:extLst>
           </p:cNvPr>
@@ -16616,7 +16616,7 @@
         </p:nvSpPr>
         <p:spPr>
           <a:xfrm xmlns:a="http://schemas.openxmlformats.org/drawingml/2006/main">
-            <a:off x="3371850" y="2943225"/>
+            <a:off x="3371850" y="2895600"/>
             <a:ext cx="2400300" cy="847725"/>
           </a:xfrm>
           <a:prstGeom xmlns:a="http://schemas.openxmlformats.org/drawingml/2006/main" prst="rect">
@@ -16707,7 +16707,7 @@
                 <a:ea typeface="Google Sans Flex"/>
                 <a:cs typeface="Google Sans Flex"/>
               </a:rPr>
-              <a:t>Profiles + fit review</a:t>
+              <a:t>Extract + explain</a:t>
             </a:r>
           </a:p>
         </p:txBody>
@@ -16717,7 +16717,7 @@
           <p:cNvPr id="118" name="">
             <a:extLst xmlns:a="http://schemas.openxmlformats.org/drawingml/2006/main">
               <a:ext uri="{FF2B5EF4-FFF2-40B4-BE49-F238E27FC236}">
-                <a16:creationId xmlns:a16="http://schemas.microsoft.com/office/drawing/2014/main" id="{3FC8F88B-19C1-49DC-8496-CC09132A645F}"/>
+                <a16:creationId xmlns:a16="http://schemas.microsoft.com/office/drawing/2014/main" id="{FD6B86E2-AAFF-4A36-8514-5C8EDF9DA8CC}"/>
               </a:ext>
             </a:extLst>
           </p:cNvPr>
@@ -16728,7 +16728,7 @@
         </p:nvSpPr>
         <p:spPr>
           <a:xfrm xmlns:a="http://schemas.openxmlformats.org/drawingml/2006/main">
-            <a:off x="6191250" y="2809875"/>
+            <a:off x="6191250" y="2762250"/>
             <a:ext cx="2667000" cy="1114425"/>
           </a:xfrm>
           <a:prstGeom xmlns:a="http://schemas.openxmlformats.org/drawingml/2006/main" prst="rect">
@@ -16747,7 +16747,7 @@
           <p:cNvPr id="119" name="">
             <a:extLst xmlns:a="http://schemas.openxmlformats.org/drawingml/2006/main">
               <a:ext uri="{FF2B5EF4-FFF2-40B4-BE49-F238E27FC236}">
-                <a16:creationId xmlns:a16="http://schemas.microsoft.com/office/drawing/2014/main" id="{077CACEE-70C0-4912-ABB8-7E693A23DAFE}"/>
+                <a16:creationId xmlns:a16="http://schemas.microsoft.com/office/drawing/2014/main" id="{980BB4BE-AC1F-4159-A423-79D8A9AF8559}"/>
               </a:ext>
             </a:extLst>
           </p:cNvPr>
@@ -16758,7 +16758,7 @@
         </p:nvSpPr>
         <p:spPr>
           <a:xfrm xmlns:a="http://schemas.openxmlformats.org/drawingml/2006/main">
-            <a:off x="6324600" y="2943225"/>
+            <a:off x="6324600" y="2895600"/>
             <a:ext cx="2400300" cy="847725"/>
           </a:xfrm>
           <a:prstGeom xmlns:a="http://schemas.openxmlformats.org/drawingml/2006/main" prst="rect">
@@ -16803,7 +16803,7 @@
                 <a:ea typeface="Google Sans Flex"/>
                 <a:cs typeface="Google Sans Flex"/>
               </a:rPr>
-              <a:t>Vercel token service</a:t>
+              <a:t>Private Vercel service</a:t>
             </a:r>
           </a:p>
           <a:p xmlns:a="http://schemas.openxmlformats.org/drawingml/2006/main">
@@ -16826,7 +16826,7 @@
                 <a:ea typeface="Google Sans Flex"/>
                 <a:cs typeface="Google Sans Flex"/>
               </a:rPr>
-              <a:t>Attestation → Live token</a:t>
+              <a:t>App Check; auth for vectors</a:t>
             </a:r>
           </a:p>
           <a:p xmlns:a="http://schemas.openxmlformats.org/drawingml/2006/main">
@@ -16849,7 +16849,7 @@
                 <a:ea typeface="Google Sans Flex"/>
                 <a:cs typeface="Google Sans Flex"/>
               </a:rPr>
-              <a:t>Gemini Live connection</a:t>
+              <a:t>Embeddings / Live tokens</a:t>
             </a:r>
           </a:p>
         </p:txBody>
@@ -16859,7 +16859,7 @@
           <p:cNvPr id="123" name="">
             <a:extLst xmlns:a="http://schemas.openxmlformats.org/drawingml/2006/main">
               <a:ext uri="{FF2B5EF4-FFF2-40B4-BE49-F238E27FC236}">
-                <a16:creationId xmlns:a16="http://schemas.microsoft.com/office/drawing/2014/main" id="{10A820E7-BE9A-4B47-AF9D-D3C1DFFB5152}"/>
+                <a16:creationId xmlns:a16="http://schemas.microsoft.com/office/drawing/2014/main" id="{2C3C30AD-E4A2-4C86-8DBB-904F01EC8444}"/>
               </a:ext>
             </a:extLst>
           </p:cNvPr>
@@ -16870,7 +16870,7 @@
         </p:nvSpPr>
         <p:spPr>
           <a:xfrm xmlns:a="http://schemas.openxmlformats.org/drawingml/2006/main">
-            <a:off x="285750" y="4171950"/>
+            <a:off x="285750" y="4133850"/>
             <a:ext cx="8572500" cy="419100"/>
           </a:xfrm>
           <a:prstGeom xmlns:a="http://schemas.openxmlformats.org/drawingml/2006/main" prst="rect">
@@ -16915,7 +16915,7 @@
                 <a:ea typeface="Google Sans Flex"/>
                 <a:cs typeface="Google Sans Flex"/>
               </a:rPr>
-              <a:t>Catalog imports: public board PDFs. Worldwide discovery: browser → open geocoding/maps.</a:t>
+              <a:t>Actual vectors + aliases + process edges → rank fusion → typed checks → conditional investigation.</a:t>
             </a:r>
           </a:p>
           <a:p xmlns:a="http://schemas.openxmlformats.org/drawingml/2006/main">
@@ -16938,7 +16938,7 @@
                 <a:ea typeface="Google Sans Flex"/>
                 <a:cs typeface="Google Sans Flex"/>
               </a:rPr>
-              <a:t>Live audio: browser → Gemini directly after the token is issued.</a:t>
+              <a:t>Financial feasibility uses entered quotes and usable yield, separately from semantic fit.</a:t>
             </a:r>
           </a:p>
         </p:txBody>
@@ -16948,7 +16948,7 @@
           <p:cNvPr id="124" name="">
             <a:extLst xmlns:a="http://schemas.openxmlformats.org/drawingml/2006/main">
               <a:ext uri="{FF2B5EF4-FFF2-40B4-BE49-F238E27FC236}">
-                <a16:creationId xmlns:a16="http://schemas.microsoft.com/office/drawing/2014/main" id="{B9C8755D-8E65-4DFF-B2F6-ED2FFBE23E6E}"/>
+                <a16:creationId xmlns:a16="http://schemas.microsoft.com/office/drawing/2014/main" id="{461CC2B4-7EA0-4CB2-818B-98343A3C5EB1}"/>
               </a:ext>
             </a:extLst>
           </p:cNvPr>
@@ -17004,7 +17004,7 @@
                 <a:ea typeface="Google Sans Flex"/>
                 <a:cs typeface="Google Sans Flex"/>
               </a:rPr>
-              <a:t>Live deployment uses Firebase, not Cloud Run. Optional Cloud Run backend is a future path. Free quotas and third-party uptime apply.</a:t>
+              <a:t>Firebase is the deployed hosting path. Cloud Run is not deployed. API keys stay server-side; model and database free quotas apply.</a:t>
             </a:r>
           </a:p>
         </p:txBody>
@@ -17012,7 +17012,7 @@
     </p:spTree>
     <p:extLst>
       <p:ext uri="{BB962C8B-B14F-4D97-AF65-F5344CB8AC3E}">
-        <p14:creationId xmlns:p14="http://schemas.microsoft.com/office/powerpoint/2010/main" val="1547229502"/>
+        <p14:creationId xmlns:p14="http://schemas.microsoft.com/office/powerpoint/2010/main" val="365121840"/>
       </p:ext>
     </p:extLst>
   </p:cSld>
@@ -17036,7 +17036,7 @@
           <p:cNvPr id="116" name="Google Shape;116;p21">
             <a:extLst xmlns:a="http://schemas.openxmlformats.org/drawingml/2006/main">
               <a:ext uri="{FF2B5EF4-FFF2-40B4-BE49-F238E27FC236}">
-                <a16:creationId xmlns:a16="http://schemas.microsoft.com/office/drawing/2014/main" id="{243F18F5-1C79-43D4-B5C5-E4EB2E4CB9C3}"/>
+                <a16:creationId xmlns:a16="http://schemas.microsoft.com/office/drawing/2014/main" id="{62C3DF69-5ACB-442A-B0EA-B0A7DCCB8257}"/>
               </a:ext>
             </a:extLst>
           </p:cNvPr>
@@ -17046,7 +17046,7 @@
           <p:nvPr/>
         </p:nvPicPr>
         <p:blipFill rotWithShape="1">
-          <a:blip xmlns:r="http://schemas.openxmlformats.org/officeDocument/2006/relationships" xmlns:a="http://schemas.openxmlformats.org/drawingml/2006/main" r:embed="R518ce1bb557d4d6c">
+          <a:blip xmlns:r="http://schemas.openxmlformats.org/officeDocument/2006/relationships" xmlns:a="http://schemas.openxmlformats.org/drawingml/2006/main" r:embed="R961a3047b1974a22">
             <a:alphaModFix/>
           </a:blip>
           <a:srcRect xmlns:a="http://schemas.openxmlformats.org/drawingml/2006/main" l="0" t="0" r="0" b="98001"/>
@@ -17070,7 +17070,7 @@
           <p:cNvPr id="117" name="Google Shape;117;p21">
             <a:extLst xmlns:a="http://schemas.openxmlformats.org/drawingml/2006/main">
               <a:ext uri="{FF2B5EF4-FFF2-40B4-BE49-F238E27FC236}">
-                <a16:creationId xmlns:a16="http://schemas.microsoft.com/office/drawing/2014/main" id="{4FB582C7-F148-469E-ABEE-00B40F09127A}"/>
+                <a16:creationId xmlns:a16="http://schemas.microsoft.com/office/drawing/2014/main" id="{E95351E4-C72B-4318-89DE-426BD0EBA523}"/>
               </a:ext>
             </a:extLst>
           </p:cNvPr>
@@ -17080,7 +17080,7 @@
           <p:nvPr/>
         </p:nvPicPr>
         <p:blipFill>
-          <a:blip xmlns:r="http://schemas.openxmlformats.org/officeDocument/2006/relationships" xmlns:a="http://schemas.openxmlformats.org/drawingml/2006/main" r:embed="R2f8fefeec9ae4224">
+          <a:blip xmlns:r="http://schemas.openxmlformats.org/officeDocument/2006/relationships" xmlns:a="http://schemas.openxmlformats.org/drawingml/2006/main" r:embed="R814db5f9626c4172">
             <a:alphaModFix/>
           </a:blip>
           <a:stretch xmlns:a="http://schemas.openxmlformats.org/drawingml/2006/main">
@@ -17105,7 +17105,7 @@
           <p:cNvPr id="118" name="Google Shape;118;p21">
             <a:extLst xmlns:a="http://schemas.openxmlformats.org/drawingml/2006/main">
               <a:ext uri="{FF2B5EF4-FFF2-40B4-BE49-F238E27FC236}">
-                <a16:creationId xmlns:a16="http://schemas.microsoft.com/office/drawing/2014/main" id="{CAB99D1C-734B-4117-9DDF-C878FD49B47F}"/>
+                <a16:creationId xmlns:a16="http://schemas.microsoft.com/office/drawing/2014/main" id="{26481579-218E-4E43-9943-A3A105A8D3F2}"/>
               </a:ext>
             </a:extLst>
           </p:cNvPr>
@@ -17156,7 +17156,7 @@
           <p:cNvPr id="119" name="Google Shape;119;p21">
             <a:extLst xmlns:a="http://schemas.openxmlformats.org/drawingml/2006/main">
               <a:ext uri="{FF2B5EF4-FFF2-40B4-BE49-F238E27FC236}">
-                <a16:creationId xmlns:a16="http://schemas.microsoft.com/office/drawing/2014/main" id="{7A2DD859-985C-4A37-A5A3-6CE416413709}"/>
+                <a16:creationId xmlns:a16="http://schemas.microsoft.com/office/drawing/2014/main" id="{079C2632-E061-4F1C-9386-74B9C4F02AEF}"/>
               </a:ext>
             </a:extLst>
           </p:cNvPr>
@@ -17236,7 +17236,7 @@
           <p:cNvPr id="120" name="">
             <a:extLst xmlns:a="http://schemas.openxmlformats.org/drawingml/2006/main">
               <a:ext uri="{FF2B5EF4-FFF2-40B4-BE49-F238E27FC236}">
-                <a16:creationId xmlns:a16="http://schemas.microsoft.com/office/drawing/2014/main" id="{AFF40FD3-7F8B-4AF8-9764-D30A858F61F8}"/>
+                <a16:creationId xmlns:a16="http://schemas.microsoft.com/office/drawing/2014/main" id="{04E3A80C-6718-4D08-8827-E3E9C0B3B893}"/>
               </a:ext>
             </a:extLst>
           </p:cNvPr>
@@ -17292,7 +17292,7 @@
                 <a:ea typeface="Google Sans Flex"/>
                 <a:cs typeface="Google Sans Flex"/>
               </a:rPr>
-              <a:t>Firebase Hosting</a:t>
+              <a:t>Firebase Hosting + Auth</a:t>
             </a:r>
           </a:p>
         </p:txBody>
@@ -17302,7 +17302,7 @@
           <p:cNvPr id="121" name="">
             <a:extLst xmlns:a="http://schemas.openxmlformats.org/drawingml/2006/main">
               <a:ext uri="{FF2B5EF4-FFF2-40B4-BE49-F238E27FC236}">
-                <a16:creationId xmlns:a16="http://schemas.microsoft.com/office/drawing/2014/main" id="{E475401D-9380-489C-AC63-89C141681848}"/>
+                <a16:creationId xmlns:a16="http://schemas.microsoft.com/office/drawing/2014/main" id="{5B0B8426-50CD-4804-B35B-12C47EF9C650}"/>
               </a:ext>
             </a:extLst>
           </p:cNvPr>
@@ -17358,7 +17358,7 @@
                 <a:ea typeface="Google Sans Flex"/>
                 <a:cs typeface="Google Sans Flex"/>
               </a:rPr>
-              <a:t>Public HTTPS web app on Spark. Static delivery with a sourced catalog fallback.</a:t>
+              <a:t>Public HTTPS app; Google/email sign-in; verified owners manage exchange listings.</a:t>
             </a:r>
           </a:p>
         </p:txBody>
@@ -17368,7 +17368,7 @@
           <p:cNvPr id="122" name="">
             <a:extLst xmlns:a="http://schemas.openxmlformats.org/drawingml/2006/main">
               <a:ext uri="{FF2B5EF4-FFF2-40B4-BE49-F238E27FC236}">
-                <a16:creationId xmlns:a16="http://schemas.microsoft.com/office/drawing/2014/main" id="{C5A26652-BC8E-42FC-988E-213B02A2F8E5}"/>
+                <a16:creationId xmlns:a16="http://schemas.microsoft.com/office/drawing/2014/main" id="{E3701765-D7D1-481F-8846-2523B4B23916}"/>
               </a:ext>
             </a:extLst>
           </p:cNvPr>
@@ -17434,7 +17434,7 @@
           <p:cNvPr id="123" name="">
             <a:extLst xmlns:a="http://schemas.openxmlformats.org/drawingml/2006/main">
               <a:ext uri="{FF2B5EF4-FFF2-40B4-BE49-F238E27FC236}">
-                <a16:creationId xmlns:a16="http://schemas.microsoft.com/office/drawing/2014/main" id="{D9DA4255-576B-4968-8DC2-2B31481C69C2}"/>
+                <a16:creationId xmlns:a16="http://schemas.microsoft.com/office/drawing/2014/main" id="{0BEA0246-287B-4E7F-9065-4A9F0C3BEA23}"/>
               </a:ext>
             </a:extLst>
           </p:cNvPr>
@@ -17490,7 +17490,7 @@
                 <a:ea typeface="Google Sans Flex"/>
                 <a:cs typeface="Google Sans Flex"/>
               </a:rPr>
-              <a:t>912 public records in 23 read-only chunks; client writes denied.</a:t>
+              <a:t>Global offers/requests, consented business contacts, private reviews and durable embedding quotas; sourced directory.</a:t>
             </a:r>
           </a:p>
         </p:txBody>
@@ -17500,7 +17500,7 @@
           <p:cNvPr id="124" name="">
             <a:extLst xmlns:a="http://schemas.openxmlformats.org/drawingml/2006/main">
               <a:ext uri="{FF2B5EF4-FFF2-40B4-BE49-F238E27FC236}">
-                <a16:creationId xmlns:a16="http://schemas.microsoft.com/office/drawing/2014/main" id="{DBDBC29E-C6C8-40B5-99B9-2A43B7BBA71F}"/>
+                <a16:creationId xmlns:a16="http://schemas.microsoft.com/office/drawing/2014/main" id="{B4D8D32E-D5E9-4E17-8746-885861A93004}"/>
               </a:ext>
             </a:extLst>
           </p:cNvPr>
@@ -17566,7 +17566,7 @@
           <p:cNvPr id="125" name="">
             <a:extLst xmlns:a="http://schemas.openxmlformats.org/drawingml/2006/main">
               <a:ext uri="{FF2B5EF4-FFF2-40B4-BE49-F238E27FC236}">
-                <a16:creationId xmlns:a16="http://schemas.microsoft.com/office/drawing/2014/main" id="{97DA0198-ECDA-4A62-9CA4-751674690A2B}"/>
+                <a16:creationId xmlns:a16="http://schemas.microsoft.com/office/drawing/2014/main" id="{BDB76B0E-825F-4671-BE6F-8F63F9A78394}"/>
               </a:ext>
             </a:extLst>
           </p:cNvPr>
@@ -17622,7 +17622,7 @@
                 <a:ea typeface="Google Sans Flex"/>
                 <a:cs typeface="Google Sans Flex"/>
               </a:rPr>
-              <a:t>Structured extraction, evidence-aware fit review and conversational reasoning. App Check enforced.</a:t>
+              <a:t>Evidence extraction and constrained semantic explanations. App Check protects public requests.</a:t>
             </a:r>
           </a:p>
         </p:txBody>
@@ -17632,7 +17632,7 @@
           <p:cNvPr id="126" name="">
             <a:extLst xmlns:a="http://schemas.openxmlformats.org/drawingml/2006/main">
               <a:ext uri="{FF2B5EF4-FFF2-40B4-BE49-F238E27FC236}">
-                <a16:creationId xmlns:a16="http://schemas.microsoft.com/office/drawing/2014/main" id="{607A0807-B086-4DA2-A0FD-C1FC3E24E543}"/>
+                <a16:creationId xmlns:a16="http://schemas.microsoft.com/office/drawing/2014/main" id="{11CE1111-5117-4578-9D14-D7346BF644EF}"/>
               </a:ext>
             </a:extLst>
           </p:cNvPr>
@@ -17688,7 +17688,7 @@
                 <a:ea typeface="Google Sans Flex"/>
                 <a:cs typeface="Google Sans Flex"/>
               </a:rPr>
-              <a:t>Gemini Live + Vercel</a:t>
+              <a:t>Gemini embeddings + Live</a:t>
             </a:r>
           </a:p>
         </p:txBody>
@@ -17698,7 +17698,7 @@
           <p:cNvPr id="127" name="">
             <a:extLst xmlns:a="http://schemas.openxmlformats.org/drawingml/2006/main">
               <a:ext uri="{FF2B5EF4-FFF2-40B4-BE49-F238E27FC236}">
-                <a16:creationId xmlns:a16="http://schemas.microsoft.com/office/drawing/2014/main" id="{B69171B5-09DE-4E5D-87F6-D6282051E6AB}"/>
+                <a16:creationId xmlns:a16="http://schemas.microsoft.com/office/drawing/2014/main" id="{4B94D1D1-14D7-4039-A83B-37C431E7BE8D}"/>
               </a:ext>
             </a:extLst>
           </p:cNvPr>
@@ -17754,7 +17754,7 @@
                 <a:ea typeface="Google Sans Flex"/>
                 <a:cs typeface="Google Sans Flex"/>
               </a:rPr>
-              <a:t>Aoede speech and validated tool calls. Private key issues short-lived, one-use tokens.</a:t>
+              <a:t>768-dimensional semantic vectors; private Vercel endpoint; one-use Live voice tokens.</a:t>
             </a:r>
           </a:p>
         </p:txBody>
@@ -17764,7 +17764,7 @@
           <p:cNvPr id="128" name="">
             <a:extLst xmlns:a="http://schemas.openxmlformats.org/drawingml/2006/main">
               <a:ext uri="{FF2B5EF4-FFF2-40B4-BE49-F238E27FC236}">
-                <a16:creationId xmlns:a16="http://schemas.microsoft.com/office/drawing/2014/main" id="{DA9D3872-237A-4061-AEC9-BF89BCAB44C1}"/>
+                <a16:creationId xmlns:a16="http://schemas.microsoft.com/office/drawing/2014/main" id="{067FA271-F460-4377-928A-A0629223BE75}"/>
               </a:ext>
             </a:extLst>
           </p:cNvPr>
@@ -17820,7 +17820,7 @@
                 <a:ea typeface="Google Sans Flex"/>
                 <a:cs typeface="Google Sans Flex"/>
               </a:rPr>
-              <a:t>Supporting stack</a:t>
+              <a:t>Application logic</a:t>
             </a:r>
           </a:p>
         </p:txBody>
@@ -17830,7 +17830,7 @@
           <p:cNvPr id="129" name="">
             <a:extLst xmlns:a="http://schemas.openxmlformats.org/drawingml/2006/main">
               <a:ext uri="{FF2B5EF4-FFF2-40B4-BE49-F238E27FC236}">
-                <a16:creationId xmlns:a16="http://schemas.microsoft.com/office/drawing/2014/main" id="{2385B03C-23CC-4E17-A2DA-E7CFDBAF4CB4}"/>
+                <a16:creationId xmlns:a16="http://schemas.microsoft.com/office/drawing/2014/main" id="{0AC9A4B7-9B12-4F8B-BA6D-5E1D85BF9220}"/>
               </a:ext>
             </a:extLst>
           </p:cNvPr>
@@ -17886,7 +17886,7 @@
                 <a:ea typeface="Google Sans Flex"/>
                 <a:cs typeface="Google Sans Flex"/>
               </a:rPr>
-              <a:t>Vite / JavaScript; official board PDFs; OpenStreetMap / Overpass; Open-Meteo geocoding.</a:t>
+              <a:t>Alias/IDF + cosine + RRF retrieval; typed unit checks; curated process solver; referenced landed-cost calculation.</a:t>
             </a:r>
           </a:p>
         </p:txBody>
@@ -17896,7 +17896,7 @@
           <p:cNvPr id="130" name="">
             <a:extLst xmlns:a="http://schemas.openxmlformats.org/drawingml/2006/main">
               <a:ext uri="{FF2B5EF4-FFF2-40B4-BE49-F238E27FC236}">
-                <a16:creationId xmlns:a16="http://schemas.microsoft.com/office/drawing/2014/main" id="{12FA9B0E-BA80-437D-AB6F-B4A011BBBB73}"/>
+                <a16:creationId xmlns:a16="http://schemas.microsoft.com/office/drawing/2014/main" id="{11955CA7-F9BF-4CEA-810A-F6C465A0FC90}"/>
               </a:ext>
             </a:extLst>
           </p:cNvPr>
@@ -17952,7 +17952,7 @@
                 <a:ea typeface="Google Sans Flex"/>
                 <a:cs typeface="Google Sans Flex"/>
               </a:rPr>
-              <a:t>Cloud Run, Cloud SQL, BigQuery and Vertex AI are not deployed. Firebase is the permitted hosting option selected for this release.</a:t>
+              <a:t>No Cloud Run, Cloud SQL, BigQuery, paid vector database or Vertex AI deployment. Firebase is the chosen permitted hosting path.</a:t>
             </a:r>
           </a:p>
         </p:txBody>
@@ -17960,7 +17960,7 @@
     </p:spTree>
     <p:extLst>
       <p:ext uri="{BB962C8B-B14F-4D97-AF65-F5344CB8AC3E}">
-        <p14:creationId xmlns:p14="http://schemas.microsoft.com/office/powerpoint/2010/main" val="798558718"/>
+        <p14:creationId xmlns:p14="http://schemas.microsoft.com/office/powerpoint/2010/main" val="1184182111"/>
       </p:ext>
     </p:extLst>
   </p:cSld>

</xml_diff>